<commit_message>
Update DIA 2 - APRESENTACAO - VERSAO AMPLIADA FINAL.pptx
</commit_message>
<xml_diff>
--- a/DIA 2 - APRESENTACAO - VERSAO AMPLIADA FINAL.pptx
+++ b/DIA 2 - APRESENTACAO - VERSAO AMPLIADA FINAL.pptx
@@ -5,20 +5,25 @@
     <p:sldMasterId id="2147483648" r:id="rId1"/>
   </p:sldMasterIdLst>
   <p:notesMasterIdLst>
-    <p:notesMasterId r:id="rId13"/>
+    <p:notesMasterId r:id="rId18"/>
   </p:notesMasterIdLst>
   <p:sldIdLst>
     <p:sldId id="256" r:id="rId2"/>
     <p:sldId id="266" r:id="rId3"/>
-    <p:sldId id="268" r:id="rId4"/>
+    <p:sldId id="273" r:id="rId4"/>
     <p:sldId id="269" r:id="rId5"/>
-    <p:sldId id="267" r:id="rId6"/>
-    <p:sldId id="265" r:id="rId7"/>
-    <p:sldId id="260" r:id="rId8"/>
-    <p:sldId id="262" r:id="rId9"/>
-    <p:sldId id="263" r:id="rId10"/>
-    <p:sldId id="264" r:id="rId11"/>
-    <p:sldId id="261" r:id="rId12"/>
+    <p:sldId id="274" r:id="rId6"/>
+    <p:sldId id="270" r:id="rId7"/>
+    <p:sldId id="271" r:id="rId8"/>
+    <p:sldId id="275" r:id="rId9"/>
+    <p:sldId id="272" r:id="rId10"/>
+    <p:sldId id="267" r:id="rId11"/>
+    <p:sldId id="265" r:id="rId12"/>
+    <p:sldId id="260" r:id="rId13"/>
+    <p:sldId id="262" r:id="rId14"/>
+    <p:sldId id="263" r:id="rId15"/>
+    <p:sldId id="264" r:id="rId16"/>
+    <p:sldId id="261" r:id="rId17"/>
   </p:sldIdLst>
   <p:sldSz cx="12192000" cy="6858000"/>
   <p:notesSz cx="6858000" cy="9144000"/>
@@ -2708,6 +2713,232 @@
       </pc:sldChg>
     </pc:docChg>
   </pc:docChgLst>
+  <pc:docChgLst>
+    <pc:chgData name="Renan Xavier Cortes" userId="d6af805853004405" providerId="LiveId" clId="{32CE5F03-9B31-4102-A03B-787EE1528540}"/>
+    <pc:docChg chg="undo custSel addSld delSld modSld">
+      <pc:chgData name="Renan Xavier Cortes" userId="d6af805853004405" providerId="LiveId" clId="{32CE5F03-9B31-4102-A03B-787EE1528540}" dt="2026-09-29T19:03:40.045" v="359" actId="1076"/>
+      <pc:docMkLst>
+        <pc:docMk/>
+      </pc:docMkLst>
+      <pc:sldChg chg="del">
+        <pc:chgData name="Renan Xavier Cortes" userId="d6af805853004405" providerId="LiveId" clId="{32CE5F03-9B31-4102-A03B-787EE1528540}" dt="2026-09-29T18:53:06.902" v="89" actId="47"/>
+        <pc:sldMkLst>
+          <pc:docMk/>
+          <pc:sldMk cId="1465096313" sldId="268"/>
+        </pc:sldMkLst>
+      </pc:sldChg>
+      <pc:sldChg chg="addSp delSp modSp add mod delAnim modAnim">
+        <pc:chgData name="Renan Xavier Cortes" userId="d6af805853004405" providerId="LiveId" clId="{32CE5F03-9B31-4102-A03B-787EE1528540}" dt="2026-09-29T18:45:51.497" v="87" actId="1076"/>
+        <pc:sldMkLst>
+          <pc:docMk/>
+          <pc:sldMk cId="1268954086" sldId="270"/>
+        </pc:sldMkLst>
+        <pc:spChg chg="del">
+          <ac:chgData name="Renan Xavier Cortes" userId="d6af805853004405" providerId="LiveId" clId="{32CE5F03-9B31-4102-A03B-787EE1528540}" dt="2026-09-29T18:44:29.944" v="7" actId="478"/>
+          <ac:spMkLst>
+            <pc:docMk/>
+            <pc:sldMk cId="1268954086" sldId="270"/>
+            <ac:spMk id="9" creationId="{4ADC85D4-4D6F-B41F-8D19-0C37EEA6532F}"/>
+          </ac:spMkLst>
+        </pc:spChg>
+        <pc:spChg chg="add mod">
+          <ac:chgData name="Renan Xavier Cortes" userId="d6af805853004405" providerId="LiveId" clId="{32CE5F03-9B31-4102-A03B-787EE1528540}" dt="2026-09-29T18:45:51.497" v="87" actId="1076"/>
+          <ac:spMkLst>
+            <pc:docMk/>
+            <pc:sldMk cId="1268954086" sldId="270"/>
+            <ac:spMk id="10" creationId="{439966E0-F76D-F319-6141-19CB38DC8D8B}"/>
+          </ac:spMkLst>
+        </pc:spChg>
+        <pc:spChg chg="del">
+          <ac:chgData name="Renan Xavier Cortes" userId="d6af805853004405" providerId="LiveId" clId="{32CE5F03-9B31-4102-A03B-787EE1528540}" dt="2026-09-29T18:44:29.348" v="6" actId="478"/>
+          <ac:spMkLst>
+            <pc:docMk/>
+            <pc:sldMk cId="1268954086" sldId="270"/>
+            <ac:spMk id="11" creationId="{2618659E-1058-1132-89D4-6B86F32FC853}"/>
+          </ac:spMkLst>
+        </pc:spChg>
+        <pc:spChg chg="del">
+          <ac:chgData name="Renan Xavier Cortes" userId="d6af805853004405" providerId="LiveId" clId="{32CE5F03-9B31-4102-A03B-787EE1528540}" dt="2026-09-29T18:44:27.800" v="5" actId="478"/>
+          <ac:spMkLst>
+            <pc:docMk/>
+            <pc:sldMk cId="1268954086" sldId="270"/>
+            <ac:spMk id="12" creationId="{0A11E838-7A28-D1BE-5FDC-461C62B8169E}"/>
+          </ac:spMkLst>
+        </pc:spChg>
+        <pc:spChg chg="del">
+          <ac:chgData name="Renan Xavier Cortes" userId="d6af805853004405" providerId="LiveId" clId="{32CE5F03-9B31-4102-A03B-787EE1528540}" dt="2026-09-29T18:44:26.959" v="4" actId="478"/>
+          <ac:spMkLst>
+            <pc:docMk/>
+            <pc:sldMk cId="1268954086" sldId="270"/>
+            <ac:spMk id="13" creationId="{D1F1D044-C509-E859-2F17-4F37728104EB}"/>
+          </ac:spMkLst>
+        </pc:spChg>
+        <pc:spChg chg="add mod">
+          <ac:chgData name="Renan Xavier Cortes" userId="d6af805853004405" providerId="LiveId" clId="{32CE5F03-9B31-4102-A03B-787EE1528540}" dt="2026-09-29T18:45:51.497" v="87" actId="1076"/>
+          <ac:spMkLst>
+            <pc:docMk/>
+            <pc:sldMk cId="1268954086" sldId="270"/>
+            <ac:spMk id="14" creationId="{09C2AF41-9EBC-A93B-F400-326DED611B2C}"/>
+          </ac:spMkLst>
+        </pc:spChg>
+        <pc:picChg chg="del">
+          <ac:chgData name="Renan Xavier Cortes" userId="d6af805853004405" providerId="LiveId" clId="{32CE5F03-9B31-4102-A03B-787EE1528540}" dt="2026-09-29T18:44:25.537" v="3" actId="478"/>
+          <ac:picMkLst>
+            <pc:docMk/>
+            <pc:sldMk cId="1268954086" sldId="270"/>
+            <ac:picMk id="5" creationId="{4318DFD3-3634-EC8F-4CA2-B0EB8093C36F}"/>
+          </ac:picMkLst>
+        </pc:picChg>
+        <pc:picChg chg="add mod">
+          <ac:chgData name="Renan Xavier Cortes" userId="d6af805853004405" providerId="LiveId" clId="{32CE5F03-9B31-4102-A03B-787EE1528540}" dt="2026-09-29T18:44:36.329" v="11" actId="1076"/>
+          <ac:picMkLst>
+            <pc:docMk/>
+            <pc:sldMk cId="1268954086" sldId="270"/>
+            <ac:picMk id="6" creationId="{C7CB915E-012D-A5FC-3321-870B91EF401C}"/>
+          </ac:picMkLst>
+        </pc:picChg>
+      </pc:sldChg>
+      <pc:sldChg chg="delSp add mod delAnim">
+        <pc:chgData name="Renan Xavier Cortes" userId="d6af805853004405" providerId="LiveId" clId="{32CE5F03-9B31-4102-A03B-787EE1528540}" dt="2026-09-29T18:59:53.562" v="201" actId="478"/>
+        <pc:sldMkLst>
+          <pc:docMk/>
+          <pc:sldMk cId="3832149468" sldId="271"/>
+        </pc:sldMkLst>
+        <pc:spChg chg="del">
+          <ac:chgData name="Renan Xavier Cortes" userId="d6af805853004405" providerId="LiveId" clId="{32CE5F03-9B31-4102-A03B-787EE1528540}" dt="2026-09-29T18:59:53.562" v="201" actId="478"/>
+          <ac:spMkLst>
+            <pc:docMk/>
+            <pc:sldMk cId="3832149468" sldId="271"/>
+            <ac:spMk id="9" creationId="{4ADC85D4-4D6F-B41F-8D19-0C37EEA6532F}"/>
+          </ac:spMkLst>
+        </pc:spChg>
+        <pc:spChg chg="del">
+          <ac:chgData name="Renan Xavier Cortes" userId="d6af805853004405" providerId="LiveId" clId="{32CE5F03-9B31-4102-A03B-787EE1528540}" dt="2026-09-29T18:59:48.511" v="197" actId="478"/>
+          <ac:spMkLst>
+            <pc:docMk/>
+            <pc:sldMk cId="3832149468" sldId="271"/>
+            <ac:spMk id="11" creationId="{2618659E-1058-1132-89D4-6B86F32FC853}"/>
+          </ac:spMkLst>
+        </pc:spChg>
+        <pc:spChg chg="del">
+          <ac:chgData name="Renan Xavier Cortes" userId="d6af805853004405" providerId="LiveId" clId="{32CE5F03-9B31-4102-A03B-787EE1528540}" dt="2026-09-29T18:59:50.995" v="199" actId="478"/>
+          <ac:spMkLst>
+            <pc:docMk/>
+            <pc:sldMk cId="3832149468" sldId="271"/>
+            <ac:spMk id="12" creationId="{0A11E838-7A28-D1BE-5FDC-461C62B8169E}"/>
+          </ac:spMkLst>
+        </pc:spChg>
+        <pc:spChg chg="del">
+          <ac:chgData name="Renan Xavier Cortes" userId="d6af805853004405" providerId="LiveId" clId="{32CE5F03-9B31-4102-A03B-787EE1528540}" dt="2026-09-29T18:59:49.889" v="198" actId="478"/>
+          <ac:spMkLst>
+            <pc:docMk/>
+            <pc:sldMk cId="3832149468" sldId="271"/>
+            <ac:spMk id="13" creationId="{D1F1D044-C509-E859-2F17-4F37728104EB}"/>
+          </ac:spMkLst>
+        </pc:spChg>
+        <pc:picChg chg="del">
+          <ac:chgData name="Renan Xavier Cortes" userId="d6af805853004405" providerId="LiveId" clId="{32CE5F03-9B31-4102-A03B-787EE1528540}" dt="2026-09-29T18:59:51.795" v="200" actId="478"/>
+          <ac:picMkLst>
+            <pc:docMk/>
+            <pc:sldMk cId="3832149468" sldId="271"/>
+            <ac:picMk id="5" creationId="{4318DFD3-3634-EC8F-4CA2-B0EB8093C36F}"/>
+          </ac:picMkLst>
+        </pc:picChg>
+      </pc:sldChg>
+      <pc:sldChg chg="add">
+        <pc:chgData name="Renan Xavier Cortes" userId="d6af805853004405" providerId="LiveId" clId="{32CE5F03-9B31-4102-A03B-787EE1528540}" dt="2026-09-29T18:44:16.387" v="2"/>
+        <pc:sldMkLst>
+          <pc:docMk/>
+          <pc:sldMk cId="1290076" sldId="272"/>
+        </pc:sldMkLst>
+      </pc:sldChg>
+      <pc:sldChg chg="add">
+        <pc:chgData name="Renan Xavier Cortes" userId="d6af805853004405" providerId="LiveId" clId="{32CE5F03-9B31-4102-A03B-787EE1528540}" dt="2026-09-29T18:52:42.033" v="88"/>
+        <pc:sldMkLst>
+          <pc:docMk/>
+          <pc:sldMk cId="587472357" sldId="273"/>
+        </pc:sldMkLst>
+      </pc:sldChg>
+      <pc:sldChg chg="modSp add mod">
+        <pc:chgData name="Renan Xavier Cortes" userId="d6af805853004405" providerId="LiveId" clId="{32CE5F03-9B31-4102-A03B-787EE1528540}" dt="2026-09-29T18:59:18.488" v="196" actId="20577"/>
+        <pc:sldMkLst>
+          <pc:docMk/>
+          <pc:sldMk cId="2697758197" sldId="274"/>
+        </pc:sldMkLst>
+        <pc:spChg chg="mod">
+          <ac:chgData name="Renan Xavier Cortes" userId="d6af805853004405" providerId="LiveId" clId="{32CE5F03-9B31-4102-A03B-787EE1528540}" dt="2026-09-29T18:59:18.488" v="196" actId="20577"/>
+          <ac:spMkLst>
+            <pc:docMk/>
+            <pc:sldMk cId="2697758197" sldId="274"/>
+            <ac:spMk id="4" creationId="{F9B44222-0FEB-DD8A-E65A-F10683C06A0F}"/>
+          </ac:spMkLst>
+        </pc:spChg>
+      </pc:sldChg>
+      <pc:sldChg chg="addSp delSp modSp add mod">
+        <pc:chgData name="Renan Xavier Cortes" userId="d6af805853004405" providerId="LiveId" clId="{32CE5F03-9B31-4102-A03B-787EE1528540}" dt="2026-09-29T19:03:40.045" v="359" actId="1076"/>
+        <pc:sldMkLst>
+          <pc:docMk/>
+          <pc:sldMk cId="2071889659" sldId="275"/>
+        </pc:sldMkLst>
+        <pc:spChg chg="mod">
+          <ac:chgData name="Renan Xavier Cortes" userId="d6af805853004405" providerId="LiveId" clId="{32CE5F03-9B31-4102-A03B-787EE1528540}" dt="2026-09-29T19:00:23.343" v="313" actId="20577"/>
+          <ac:spMkLst>
+            <pc:docMk/>
+            <pc:sldMk cId="2071889659" sldId="275"/>
+            <ac:spMk id="4" creationId="{F9B44222-0FEB-DD8A-E65A-F10683C06A0F}"/>
+          </ac:spMkLst>
+        </pc:spChg>
+        <pc:spChg chg="add del">
+          <ac:chgData name="Renan Xavier Cortes" userId="d6af805853004405" providerId="LiveId" clId="{32CE5F03-9B31-4102-A03B-787EE1528540}" dt="2026-09-29T19:02:05.280" v="333" actId="11529"/>
+          <ac:spMkLst>
+            <pc:docMk/>
+            <pc:sldMk cId="2071889659" sldId="275"/>
+            <ac:spMk id="11" creationId="{8BEE410F-77B2-4534-4D33-ACC5D248E82D}"/>
+          </ac:spMkLst>
+        </pc:spChg>
+        <pc:spChg chg="add mod">
+          <ac:chgData name="Renan Xavier Cortes" userId="d6af805853004405" providerId="LiveId" clId="{32CE5F03-9B31-4102-A03B-787EE1528540}" dt="2026-09-29T19:02:32.496" v="350" actId="692"/>
+          <ac:spMkLst>
+            <pc:docMk/>
+            <pc:sldMk cId="2071889659" sldId="275"/>
+            <ac:spMk id="12" creationId="{0B40F988-AD4C-F7F7-CE31-F2CDDF82E91A}"/>
+          </ac:spMkLst>
+        </pc:spChg>
+        <pc:spChg chg="add mod">
+          <ac:chgData name="Renan Xavier Cortes" userId="d6af805853004405" providerId="LiveId" clId="{32CE5F03-9B31-4102-A03B-787EE1528540}" dt="2026-09-29T19:02:49.280" v="354" actId="14100"/>
+          <ac:spMkLst>
+            <pc:docMk/>
+            <pc:sldMk cId="2071889659" sldId="275"/>
+            <ac:spMk id="13" creationId="{D34651EC-928C-45A9-FB4A-89294682FE03}"/>
+          </ac:spMkLst>
+        </pc:spChg>
+        <pc:picChg chg="add mod">
+          <ac:chgData name="Renan Xavier Cortes" userId="d6af805853004405" providerId="LiveId" clId="{32CE5F03-9B31-4102-A03B-787EE1528540}" dt="2026-09-29T19:01:30.373" v="321" actId="1076"/>
+          <ac:picMkLst>
+            <pc:docMk/>
+            <pc:sldMk cId="2071889659" sldId="275"/>
+            <ac:picMk id="6" creationId="{E0B70768-61C8-F85A-E614-A9F14CEAD950}"/>
+          </ac:picMkLst>
+        </pc:picChg>
+        <pc:picChg chg="add del mod">
+          <ac:chgData name="Renan Xavier Cortes" userId="d6af805853004405" providerId="LiveId" clId="{32CE5F03-9B31-4102-A03B-787EE1528540}" dt="2026-09-29T19:03:10.356" v="355" actId="478"/>
+          <ac:picMkLst>
+            <pc:docMk/>
+            <pc:sldMk cId="2071889659" sldId="275"/>
+            <ac:picMk id="10" creationId="{918C452C-A393-6CAA-7A87-EA606435045A}"/>
+          </ac:picMkLst>
+        </pc:picChg>
+        <pc:picChg chg="add mod">
+          <ac:chgData name="Renan Xavier Cortes" userId="d6af805853004405" providerId="LiveId" clId="{32CE5F03-9B31-4102-A03B-787EE1528540}" dt="2026-09-29T19:03:40.045" v="359" actId="1076"/>
+          <ac:picMkLst>
+            <pc:docMk/>
+            <pc:sldMk cId="2071889659" sldId="275"/>
+            <ac:picMk id="15" creationId="{AD23F083-ACAE-F3BE-99C5-AC59D9D5284D}"/>
+          </ac:picMkLst>
+        </pc:picChg>
+      </pc:sldChg>
+    </pc:docChg>
+  </pc:docChgLst>
 </pc:chgInfo>
 </file>
 
@@ -3218,6 +3449,426 @@
     </p:spTree>
     <p:extLst>
       <p:ext uri="{BB962C8B-B14F-4D97-AF65-F5344CB8AC3E}">
+        <p14:creationId xmlns:p14="http://schemas.microsoft.com/office/powerpoint/2010/main" val="592255382"/>
+      </p:ext>
+    </p:extLst>
+  </p:cSld>
+  <p:clrMapOvr>
+    <a:masterClrMapping/>
+  </p:clrMapOvr>
+</p:notes>
+</file>
+
+<file path=ppt/notesSlides/notesSlide11.xml><?xml version="1.0" encoding="utf-8"?>
+<p:notes xmlns:a="http://schemas.openxmlformats.org/drawingml/2006/main" xmlns:r="http://schemas.openxmlformats.org/officeDocument/2006/relationships" xmlns:p="http://schemas.openxmlformats.org/presentationml/2006/main">
+  <p:cSld>
+    <p:spTree>
+      <p:nvGrpSpPr>
+        <p:cNvPr id="1" name=""/>
+        <p:cNvGrpSpPr/>
+        <p:nvPr/>
+      </p:nvGrpSpPr>
+      <p:grpSpPr>
+        <a:xfrm>
+          <a:off x="0" y="0"/>
+          <a:ext cx="0" cy="0"/>
+          <a:chOff x="0" y="0"/>
+          <a:chExt cx="0" cy="0"/>
+        </a:xfrm>
+      </p:grpSpPr>
+      <p:sp>
+        <p:nvSpPr>
+          <p:cNvPr id="2" name="Espaço Reservado para Imagem de Slide 1"/>
+          <p:cNvSpPr>
+            <a:spLocks noGrp="1" noRot="1" noChangeAspect="1"/>
+          </p:cNvSpPr>
+          <p:nvPr>
+            <p:ph type="sldImg"/>
+          </p:nvPr>
+        </p:nvSpPr>
+        <p:spPr/>
+      </p:sp>
+      <p:sp>
+        <p:nvSpPr>
+          <p:cNvPr id="3" name="Espaço Reservado para Anotações 2"/>
+          <p:cNvSpPr>
+            <a:spLocks noGrp="1"/>
+          </p:cNvSpPr>
+          <p:nvPr>
+            <p:ph type="body" idx="1"/>
+          </p:nvPr>
+        </p:nvSpPr>
+        <p:spPr/>
+        <p:txBody>
+          <a:bodyPr/>
+          <a:lstStyle/>
+          <a:p>
+            <a:endParaRPr lang="pt-BR" dirty="0"/>
+          </a:p>
+        </p:txBody>
+      </p:sp>
+      <p:sp>
+        <p:nvSpPr>
+          <p:cNvPr id="4" name="Espaço Reservado para Número de Slide 3"/>
+          <p:cNvSpPr>
+            <a:spLocks noGrp="1"/>
+          </p:cNvSpPr>
+          <p:nvPr>
+            <p:ph type="sldNum" sz="quarter" idx="5"/>
+          </p:nvPr>
+        </p:nvSpPr>
+        <p:spPr/>
+        <p:txBody>
+          <a:bodyPr/>
+          <a:lstStyle/>
+          <a:p>
+            <a:fld id="{87C88D93-34D3-419D-AEF5-A26FFAFED389}" type="slidenum">
+              <a:rPr lang="pt-BR" smtClean="0"/>
+              <a:t>12</a:t>
+            </a:fld>
+            <a:endParaRPr lang="pt-BR"/>
+          </a:p>
+        </p:txBody>
+      </p:sp>
+    </p:spTree>
+    <p:extLst>
+      <p:ext uri="{BB962C8B-B14F-4D97-AF65-F5344CB8AC3E}">
+        <p14:creationId xmlns:p14="http://schemas.microsoft.com/office/powerpoint/2010/main" val="2429228612"/>
+      </p:ext>
+    </p:extLst>
+  </p:cSld>
+  <p:clrMapOvr>
+    <a:masterClrMapping/>
+  </p:clrMapOvr>
+</p:notes>
+</file>
+
+<file path=ppt/notesSlides/notesSlide12.xml><?xml version="1.0" encoding="utf-8"?>
+<p:notes xmlns:a="http://schemas.openxmlformats.org/drawingml/2006/main" xmlns:r="http://schemas.openxmlformats.org/officeDocument/2006/relationships" xmlns:p="http://schemas.openxmlformats.org/presentationml/2006/main">
+  <p:cSld>
+    <p:spTree>
+      <p:nvGrpSpPr>
+        <p:cNvPr id="1" name=""/>
+        <p:cNvGrpSpPr/>
+        <p:nvPr/>
+      </p:nvGrpSpPr>
+      <p:grpSpPr>
+        <a:xfrm>
+          <a:off x="0" y="0"/>
+          <a:ext cx="0" cy="0"/>
+          <a:chOff x="0" y="0"/>
+          <a:chExt cx="0" cy="0"/>
+        </a:xfrm>
+      </p:grpSpPr>
+      <p:sp>
+        <p:nvSpPr>
+          <p:cNvPr id="2" name="Espaço Reservado para Imagem de Slide 1"/>
+          <p:cNvSpPr>
+            <a:spLocks noGrp="1" noRot="1" noChangeAspect="1"/>
+          </p:cNvSpPr>
+          <p:nvPr>
+            <p:ph type="sldImg"/>
+          </p:nvPr>
+        </p:nvSpPr>
+        <p:spPr/>
+      </p:sp>
+      <p:sp>
+        <p:nvSpPr>
+          <p:cNvPr id="3" name="Espaço Reservado para Anotações 2"/>
+          <p:cNvSpPr>
+            <a:spLocks noGrp="1"/>
+          </p:cNvSpPr>
+          <p:nvPr>
+            <p:ph type="body" idx="1"/>
+          </p:nvPr>
+        </p:nvSpPr>
+        <p:spPr/>
+        <p:txBody>
+          <a:bodyPr/>
+          <a:lstStyle/>
+          <a:p>
+            <a:endParaRPr lang="pt-BR" dirty="0"/>
+          </a:p>
+        </p:txBody>
+      </p:sp>
+      <p:sp>
+        <p:nvSpPr>
+          <p:cNvPr id="4" name="Espaço Reservado para Número de Slide 3"/>
+          <p:cNvSpPr>
+            <a:spLocks noGrp="1"/>
+          </p:cNvSpPr>
+          <p:nvPr>
+            <p:ph type="sldNum" sz="quarter" idx="5"/>
+          </p:nvPr>
+        </p:nvSpPr>
+        <p:spPr/>
+        <p:txBody>
+          <a:bodyPr/>
+          <a:lstStyle/>
+          <a:p>
+            <a:fld id="{87C88D93-34D3-419D-AEF5-A26FFAFED389}" type="slidenum">
+              <a:rPr lang="pt-BR" smtClean="0"/>
+              <a:t>13</a:t>
+            </a:fld>
+            <a:endParaRPr lang="pt-BR"/>
+          </a:p>
+        </p:txBody>
+      </p:sp>
+    </p:spTree>
+    <p:extLst>
+      <p:ext uri="{BB962C8B-B14F-4D97-AF65-F5344CB8AC3E}">
+        <p14:creationId xmlns:p14="http://schemas.microsoft.com/office/powerpoint/2010/main" val="3517665198"/>
+      </p:ext>
+    </p:extLst>
+  </p:cSld>
+  <p:clrMapOvr>
+    <a:masterClrMapping/>
+  </p:clrMapOvr>
+</p:notes>
+</file>
+
+<file path=ppt/notesSlides/notesSlide13.xml><?xml version="1.0" encoding="utf-8"?>
+<p:notes xmlns:a="http://schemas.openxmlformats.org/drawingml/2006/main" xmlns:r="http://schemas.openxmlformats.org/officeDocument/2006/relationships" xmlns:p="http://schemas.openxmlformats.org/presentationml/2006/main">
+  <p:cSld>
+    <p:spTree>
+      <p:nvGrpSpPr>
+        <p:cNvPr id="1" name=""/>
+        <p:cNvGrpSpPr/>
+        <p:nvPr/>
+      </p:nvGrpSpPr>
+      <p:grpSpPr>
+        <a:xfrm>
+          <a:off x="0" y="0"/>
+          <a:ext cx="0" cy="0"/>
+          <a:chOff x="0" y="0"/>
+          <a:chExt cx="0" cy="0"/>
+        </a:xfrm>
+      </p:grpSpPr>
+      <p:sp>
+        <p:nvSpPr>
+          <p:cNvPr id="2" name="Espaço Reservado para Imagem de Slide 1"/>
+          <p:cNvSpPr>
+            <a:spLocks noGrp="1" noRot="1" noChangeAspect="1"/>
+          </p:cNvSpPr>
+          <p:nvPr>
+            <p:ph type="sldImg"/>
+          </p:nvPr>
+        </p:nvSpPr>
+        <p:spPr/>
+      </p:sp>
+      <p:sp>
+        <p:nvSpPr>
+          <p:cNvPr id="3" name="Espaço Reservado para Anotações 2"/>
+          <p:cNvSpPr>
+            <a:spLocks noGrp="1"/>
+          </p:cNvSpPr>
+          <p:nvPr>
+            <p:ph type="body" idx="1"/>
+          </p:nvPr>
+        </p:nvSpPr>
+        <p:spPr/>
+        <p:txBody>
+          <a:bodyPr/>
+          <a:lstStyle/>
+          <a:p>
+            <a:endParaRPr lang="pt-BR" dirty="0"/>
+          </a:p>
+        </p:txBody>
+      </p:sp>
+      <p:sp>
+        <p:nvSpPr>
+          <p:cNvPr id="4" name="Espaço Reservado para Número de Slide 3"/>
+          <p:cNvSpPr>
+            <a:spLocks noGrp="1"/>
+          </p:cNvSpPr>
+          <p:nvPr>
+            <p:ph type="sldNum" sz="quarter" idx="5"/>
+          </p:nvPr>
+        </p:nvSpPr>
+        <p:spPr/>
+        <p:txBody>
+          <a:bodyPr/>
+          <a:lstStyle/>
+          <a:p>
+            <a:fld id="{87C88D93-34D3-419D-AEF5-A26FFAFED389}" type="slidenum">
+              <a:rPr lang="pt-BR" smtClean="0"/>
+              <a:t>14</a:t>
+            </a:fld>
+            <a:endParaRPr lang="pt-BR"/>
+          </a:p>
+        </p:txBody>
+      </p:sp>
+    </p:spTree>
+    <p:extLst>
+      <p:ext uri="{BB962C8B-B14F-4D97-AF65-F5344CB8AC3E}">
+        <p14:creationId xmlns:p14="http://schemas.microsoft.com/office/powerpoint/2010/main" val="1357359887"/>
+      </p:ext>
+    </p:extLst>
+  </p:cSld>
+  <p:clrMapOvr>
+    <a:masterClrMapping/>
+  </p:clrMapOvr>
+</p:notes>
+</file>
+
+<file path=ppt/notesSlides/notesSlide14.xml><?xml version="1.0" encoding="utf-8"?>
+<p:notes xmlns:a="http://schemas.openxmlformats.org/drawingml/2006/main" xmlns:r="http://schemas.openxmlformats.org/officeDocument/2006/relationships" xmlns:p="http://schemas.openxmlformats.org/presentationml/2006/main">
+  <p:cSld>
+    <p:spTree>
+      <p:nvGrpSpPr>
+        <p:cNvPr id="1" name=""/>
+        <p:cNvGrpSpPr/>
+        <p:nvPr/>
+      </p:nvGrpSpPr>
+      <p:grpSpPr>
+        <a:xfrm>
+          <a:off x="0" y="0"/>
+          <a:ext cx="0" cy="0"/>
+          <a:chOff x="0" y="0"/>
+          <a:chExt cx="0" cy="0"/>
+        </a:xfrm>
+      </p:grpSpPr>
+      <p:sp>
+        <p:nvSpPr>
+          <p:cNvPr id="2" name="Espaço Reservado para Imagem de Slide 1"/>
+          <p:cNvSpPr>
+            <a:spLocks noGrp="1" noRot="1" noChangeAspect="1"/>
+          </p:cNvSpPr>
+          <p:nvPr>
+            <p:ph type="sldImg"/>
+          </p:nvPr>
+        </p:nvSpPr>
+        <p:spPr/>
+      </p:sp>
+      <p:sp>
+        <p:nvSpPr>
+          <p:cNvPr id="3" name="Espaço Reservado para Anotações 2"/>
+          <p:cNvSpPr>
+            <a:spLocks noGrp="1"/>
+          </p:cNvSpPr>
+          <p:nvPr>
+            <p:ph type="body" idx="1"/>
+          </p:nvPr>
+        </p:nvSpPr>
+        <p:spPr/>
+        <p:txBody>
+          <a:bodyPr/>
+          <a:lstStyle/>
+          <a:p>
+            <a:endParaRPr lang="pt-BR" dirty="0"/>
+          </a:p>
+        </p:txBody>
+      </p:sp>
+      <p:sp>
+        <p:nvSpPr>
+          <p:cNvPr id="4" name="Espaço Reservado para Número de Slide 3"/>
+          <p:cNvSpPr>
+            <a:spLocks noGrp="1"/>
+          </p:cNvSpPr>
+          <p:nvPr>
+            <p:ph type="sldNum" sz="quarter" idx="5"/>
+          </p:nvPr>
+        </p:nvSpPr>
+        <p:spPr/>
+        <p:txBody>
+          <a:bodyPr/>
+          <a:lstStyle/>
+          <a:p>
+            <a:fld id="{87C88D93-34D3-419D-AEF5-A26FFAFED389}" type="slidenum">
+              <a:rPr lang="pt-BR" smtClean="0"/>
+              <a:t>15</a:t>
+            </a:fld>
+            <a:endParaRPr lang="pt-BR"/>
+          </a:p>
+        </p:txBody>
+      </p:sp>
+    </p:spTree>
+    <p:extLst>
+      <p:ext uri="{BB962C8B-B14F-4D97-AF65-F5344CB8AC3E}">
+        <p14:creationId xmlns:p14="http://schemas.microsoft.com/office/powerpoint/2010/main" val="393282365"/>
+      </p:ext>
+    </p:extLst>
+  </p:cSld>
+  <p:clrMapOvr>
+    <a:masterClrMapping/>
+  </p:clrMapOvr>
+</p:notes>
+</file>
+
+<file path=ppt/notesSlides/notesSlide15.xml><?xml version="1.0" encoding="utf-8"?>
+<p:notes xmlns:a="http://schemas.openxmlformats.org/drawingml/2006/main" xmlns:r="http://schemas.openxmlformats.org/officeDocument/2006/relationships" xmlns:p="http://schemas.openxmlformats.org/presentationml/2006/main">
+  <p:cSld>
+    <p:spTree>
+      <p:nvGrpSpPr>
+        <p:cNvPr id="1" name=""/>
+        <p:cNvGrpSpPr/>
+        <p:nvPr/>
+      </p:nvGrpSpPr>
+      <p:grpSpPr>
+        <a:xfrm>
+          <a:off x="0" y="0"/>
+          <a:ext cx="0" cy="0"/>
+          <a:chOff x="0" y="0"/>
+          <a:chExt cx="0" cy="0"/>
+        </a:xfrm>
+      </p:grpSpPr>
+      <p:sp>
+        <p:nvSpPr>
+          <p:cNvPr id="2" name="Espaço Reservado para Imagem de Slide 1"/>
+          <p:cNvSpPr>
+            <a:spLocks noGrp="1" noRot="1" noChangeAspect="1"/>
+          </p:cNvSpPr>
+          <p:nvPr>
+            <p:ph type="sldImg"/>
+          </p:nvPr>
+        </p:nvSpPr>
+        <p:spPr/>
+      </p:sp>
+      <p:sp>
+        <p:nvSpPr>
+          <p:cNvPr id="3" name="Espaço Reservado para Anotações 2"/>
+          <p:cNvSpPr>
+            <a:spLocks noGrp="1"/>
+          </p:cNvSpPr>
+          <p:nvPr>
+            <p:ph type="body" idx="1"/>
+          </p:nvPr>
+        </p:nvSpPr>
+        <p:spPr/>
+        <p:txBody>
+          <a:bodyPr/>
+          <a:lstStyle/>
+          <a:p>
+            <a:endParaRPr lang="pt-BR" dirty="0"/>
+          </a:p>
+        </p:txBody>
+      </p:sp>
+      <p:sp>
+        <p:nvSpPr>
+          <p:cNvPr id="4" name="Espaço Reservado para Número de Slide 3"/>
+          <p:cNvSpPr>
+            <a:spLocks noGrp="1"/>
+          </p:cNvSpPr>
+          <p:nvPr>
+            <p:ph type="sldNum" sz="quarter" idx="5"/>
+          </p:nvPr>
+        </p:nvSpPr>
+        <p:spPr/>
+        <p:txBody>
+          <a:bodyPr/>
+          <a:lstStyle/>
+          <a:p>
+            <a:fld id="{87C88D93-34D3-419D-AEF5-A26FFAFED389}" type="slidenum">
+              <a:rPr lang="pt-BR" smtClean="0"/>
+              <a:t>16</a:t>
+            </a:fld>
+            <a:endParaRPr lang="pt-BR"/>
+          </a:p>
+        </p:txBody>
+      </p:sp>
+    </p:spTree>
+    <p:extLst>
+      <p:ext uri="{BB962C8B-B14F-4D97-AF65-F5344CB8AC3E}">
         <p14:creationId xmlns:p14="http://schemas.microsoft.com/office/powerpoint/2010/main" val="2981686523"/>
       </p:ext>
     </p:extLst>
@@ -3302,7 +3953,7 @@
     </p:spTree>
     <p:extLst>
       <p:ext uri="{BB962C8B-B14F-4D97-AF65-F5344CB8AC3E}">
-        <p14:creationId xmlns:p14="http://schemas.microsoft.com/office/powerpoint/2010/main" val="3324213401"/>
+        <p14:creationId xmlns:p14="http://schemas.microsoft.com/office/powerpoint/2010/main" val="1850242408"/>
       </p:ext>
     </p:extLst>
   </p:cSld>
@@ -3470,7 +4121,7 @@
     </p:spTree>
     <p:extLst>
       <p:ext uri="{BB962C8B-B14F-4D97-AF65-F5344CB8AC3E}">
-        <p14:creationId xmlns:p14="http://schemas.microsoft.com/office/powerpoint/2010/main" val="2353704698"/>
+        <p14:creationId xmlns:p14="http://schemas.microsoft.com/office/powerpoint/2010/main" val="575110526"/>
       </p:ext>
     </p:extLst>
   </p:cSld>
@@ -3554,7 +4205,7 @@
     </p:spTree>
     <p:extLst>
       <p:ext uri="{BB962C8B-B14F-4D97-AF65-F5344CB8AC3E}">
-        <p14:creationId xmlns:p14="http://schemas.microsoft.com/office/powerpoint/2010/main" val="592255382"/>
+        <p14:creationId xmlns:p14="http://schemas.microsoft.com/office/powerpoint/2010/main" val="3108953356"/>
       </p:ext>
     </p:extLst>
   </p:cSld>
@@ -3638,7 +4289,7 @@
     </p:spTree>
     <p:extLst>
       <p:ext uri="{BB962C8B-B14F-4D97-AF65-F5344CB8AC3E}">
-        <p14:creationId xmlns:p14="http://schemas.microsoft.com/office/powerpoint/2010/main" val="2429228612"/>
+        <p14:creationId xmlns:p14="http://schemas.microsoft.com/office/powerpoint/2010/main" val="1019644604"/>
       </p:ext>
     </p:extLst>
   </p:cSld>
@@ -3722,7 +4373,7 @@
     </p:spTree>
     <p:extLst>
       <p:ext uri="{BB962C8B-B14F-4D97-AF65-F5344CB8AC3E}">
-        <p14:creationId xmlns:p14="http://schemas.microsoft.com/office/powerpoint/2010/main" val="3517665198"/>
+        <p14:creationId xmlns:p14="http://schemas.microsoft.com/office/powerpoint/2010/main" val="2587457176"/>
       </p:ext>
     </p:extLst>
   </p:cSld>
@@ -3806,7 +4457,7 @@
     </p:spTree>
     <p:extLst>
       <p:ext uri="{BB962C8B-B14F-4D97-AF65-F5344CB8AC3E}">
-        <p14:creationId xmlns:p14="http://schemas.microsoft.com/office/powerpoint/2010/main" val="1357359887"/>
+        <p14:creationId xmlns:p14="http://schemas.microsoft.com/office/powerpoint/2010/main" val="3085305389"/>
       </p:ext>
     </p:extLst>
   </p:cSld>
@@ -3890,7 +4541,7 @@
     </p:spTree>
     <p:extLst>
       <p:ext uri="{BB962C8B-B14F-4D97-AF65-F5344CB8AC3E}">
-        <p14:creationId xmlns:p14="http://schemas.microsoft.com/office/powerpoint/2010/main" val="393282365"/>
+        <p14:creationId xmlns:p14="http://schemas.microsoft.com/office/powerpoint/2010/main" val="2353704698"/>
       </p:ext>
     </p:extLst>
   </p:cSld>
@@ -7502,6 +8153,1622 @@
         </p:nvSpPr>
         <p:spPr>
           <a:xfrm>
+            <a:off x="249836" y="200638"/>
+            <a:ext cx="11692327" cy="584775"/>
+          </a:xfrm>
+          <a:prstGeom prst="rect">
+            <a:avLst/>
+          </a:prstGeom>
+          <a:noFill/>
+        </p:spPr>
+        <p:txBody>
+          <a:bodyPr wrap="square" rtlCol="0">
+            <a:spAutoFit/>
+          </a:bodyPr>
+          <a:lstStyle/>
+          <a:p>
+            <a:r>
+              <a:rPr lang="pt-BR" sz="3200" b="1" dirty="0">
+                <a:solidFill>
+                  <a:srgbClr val="002060"/>
+                </a:solidFill>
+                <a:latin typeface="Cambria" panose="02040503050406030204" pitchFamily="18" charset="0"/>
+                <a:ea typeface="Cambria" panose="02040503050406030204" pitchFamily="18" charset="0"/>
+              </a:rPr>
+              <a:t>Panorama RS à Luz dos Dados públicos disponíveis da SSP-RS</a:t>
+            </a:r>
+          </a:p>
+        </p:txBody>
+      </p:sp>
+      <p:pic>
+        <p:nvPicPr>
+          <p:cNvPr id="2" name="Picture 2" descr="UFRGS na Serra | Visão de futuro e coragem para inovar">
+            <a:extLst>
+              <a:ext uri="{FF2B5EF4-FFF2-40B4-BE49-F238E27FC236}">
+                <a16:creationId xmlns:a16="http://schemas.microsoft.com/office/drawing/2014/main" id="{567C8E3D-C535-EC50-849C-270CEB4B8A04}"/>
+              </a:ext>
+            </a:extLst>
+          </p:cNvPr>
+          <p:cNvPicPr>
+            <a:picLocks noChangeAspect="1" noChangeArrowheads="1"/>
+          </p:cNvPicPr>
+          <p:nvPr/>
+        </p:nvPicPr>
+        <p:blipFill>
+          <a:blip r:embed="rId3">
+            <a:extLst>
+              <a:ext uri="{28A0092B-C50C-407E-A947-70E740481C1C}">
+                <a14:useLocalDpi xmlns:a14="http://schemas.microsoft.com/office/drawing/2010/main" val="0"/>
+              </a:ext>
+            </a:extLst>
+          </a:blip>
+          <a:srcRect/>
+          <a:stretch>
+            <a:fillRect/>
+          </a:stretch>
+        </p:blipFill>
+        <p:spPr bwMode="auto">
+          <a:xfrm>
+            <a:off x="119922" y="6346096"/>
+            <a:ext cx="683614" cy="445109"/>
+          </a:xfrm>
+          <a:prstGeom prst="rect">
+            <a:avLst/>
+          </a:prstGeom>
+          <a:noFill/>
+          <a:extLst>
+            <a:ext uri="{909E8E84-426E-40DD-AFC4-6F175D3DCCD1}">
+              <a14:hiddenFill xmlns:a14="http://schemas.microsoft.com/office/drawing/2010/main">
+                <a:solidFill>
+                  <a:srgbClr val="FFFFFF"/>
+                </a:solidFill>
+              </a14:hiddenFill>
+            </a:ext>
+          </a:extLst>
+        </p:spPr>
+      </p:pic>
+      <p:pic>
+        <p:nvPicPr>
+          <p:cNvPr id="3" name="Picture 4">
+            <a:extLst>
+              <a:ext uri="{FF2B5EF4-FFF2-40B4-BE49-F238E27FC236}">
+                <a16:creationId xmlns:a16="http://schemas.microsoft.com/office/drawing/2014/main" id="{C9663204-9A6C-C5D7-7C9B-AAF5653911D6}"/>
+              </a:ext>
+            </a:extLst>
+          </p:cNvPr>
+          <p:cNvPicPr>
+            <a:picLocks noChangeAspect="1" noChangeArrowheads="1"/>
+          </p:cNvPicPr>
+          <p:nvPr/>
+        </p:nvPicPr>
+        <p:blipFill>
+          <a:blip r:embed="rId4">
+            <a:extLst>
+              <a:ext uri="{28A0092B-C50C-407E-A947-70E740481C1C}">
+                <a14:useLocalDpi xmlns:a14="http://schemas.microsoft.com/office/drawing/2010/main" val="0"/>
+              </a:ext>
+            </a:extLst>
+          </a:blip>
+          <a:srcRect/>
+          <a:stretch>
+            <a:fillRect/>
+          </a:stretch>
+        </p:blipFill>
+        <p:spPr bwMode="auto">
+          <a:xfrm>
+            <a:off x="10802599" y="6212508"/>
+            <a:ext cx="1329440" cy="578697"/>
+          </a:xfrm>
+          <a:prstGeom prst="rect">
+            <a:avLst/>
+          </a:prstGeom>
+          <a:noFill/>
+          <a:extLst>
+            <a:ext uri="{909E8E84-426E-40DD-AFC4-6F175D3DCCD1}">
+              <a14:hiddenFill xmlns:a14="http://schemas.microsoft.com/office/drawing/2010/main">
+                <a:solidFill>
+                  <a:srgbClr val="FFFFFF"/>
+                </a:solidFill>
+              </a14:hiddenFill>
+            </a:ext>
+          </a:extLst>
+        </p:spPr>
+      </p:pic>
+      <p:sp>
+        <p:nvSpPr>
+          <p:cNvPr id="4" name="CaixaDeTexto 3">
+            <a:extLst>
+              <a:ext uri="{FF2B5EF4-FFF2-40B4-BE49-F238E27FC236}">
+                <a16:creationId xmlns:a16="http://schemas.microsoft.com/office/drawing/2014/main" id="{F9B44222-0FEB-DD8A-E65A-F10683C06A0F}"/>
+              </a:ext>
+            </a:extLst>
+          </p:cNvPr>
+          <p:cNvSpPr txBox="1"/>
+          <p:nvPr/>
+        </p:nvSpPr>
+        <p:spPr>
+          <a:xfrm>
+            <a:off x="940904" y="1276323"/>
+            <a:ext cx="10310191" cy="4763868"/>
+          </a:xfrm>
+          <a:prstGeom prst="rect">
+            <a:avLst/>
+          </a:prstGeom>
+          <a:noFill/>
+        </p:spPr>
+        <p:txBody>
+          <a:bodyPr wrap="square" rtlCol="0">
+            <a:spAutoFit/>
+          </a:bodyPr>
+          <a:lstStyle/>
+          <a:p>
+            <a:pPr marL="285750" indent="-285750">
+              <a:lnSpc>
+                <a:spcPct val="150000"/>
+              </a:lnSpc>
+              <a:spcAft>
+                <a:spcPts val="110"/>
+              </a:spcAft>
+              <a:buFont typeface="Wingdings" panose="05000000000000000000" pitchFamily="2" charset="2"/>
+              <a:buChar char="Ø"/>
+            </a:pPr>
+            <a:r>
+              <a:rPr lang="pt-BR" sz="2000" b="1" dirty="0"/>
+              <a:t>Descritivas</a:t>
+            </a:r>
+          </a:p>
+          <a:p>
+            <a:pPr marL="285750" indent="-285750">
+              <a:lnSpc>
+                <a:spcPct val="150000"/>
+              </a:lnSpc>
+              <a:spcAft>
+                <a:spcPts val="110"/>
+              </a:spcAft>
+              <a:buFont typeface="Wingdings" panose="05000000000000000000" pitchFamily="2" charset="2"/>
+              <a:buChar char="Ø"/>
+            </a:pPr>
+            <a:r>
+              <a:rPr lang="pt-BR" sz="2000" b="1" dirty="0"/>
+              <a:t>Taxas em Municípios pequenos</a:t>
+            </a:r>
+          </a:p>
+          <a:p>
+            <a:pPr marL="285750" indent="-285750">
+              <a:lnSpc>
+                <a:spcPct val="150000"/>
+              </a:lnSpc>
+              <a:spcAft>
+                <a:spcPts val="110"/>
+              </a:spcAft>
+              <a:buFont typeface="Wingdings" panose="05000000000000000000" pitchFamily="2" charset="2"/>
+              <a:buChar char="Ø"/>
+            </a:pPr>
+            <a:r>
+              <a:rPr lang="pt-BR" sz="2000" b="1" dirty="0"/>
+              <a:t>Autocorrelação espacial</a:t>
+            </a:r>
+          </a:p>
+          <a:p>
+            <a:pPr marL="285750" indent="-285750">
+              <a:lnSpc>
+                <a:spcPct val="150000"/>
+              </a:lnSpc>
+              <a:spcAft>
+                <a:spcPts val="110"/>
+              </a:spcAft>
+              <a:buFont typeface="Wingdings" panose="05000000000000000000" pitchFamily="2" charset="2"/>
+              <a:buChar char="Ø"/>
+            </a:pPr>
+            <a:r>
+              <a:rPr lang="pt-BR" sz="2000" b="1" dirty="0"/>
+              <a:t>Cadeias de Markov</a:t>
+            </a:r>
+          </a:p>
+          <a:p>
+            <a:pPr marL="285750" indent="-285750">
+              <a:lnSpc>
+                <a:spcPct val="150000"/>
+              </a:lnSpc>
+              <a:spcAft>
+                <a:spcPts val="110"/>
+              </a:spcAft>
+              <a:buFont typeface="Wingdings" panose="05000000000000000000" pitchFamily="2" charset="2"/>
+              <a:buChar char="Ø"/>
+            </a:pPr>
+            <a:r>
+              <a:rPr lang="pt-BR" sz="2000" b="1" dirty="0"/>
+              <a:t>Roubo de Veículos</a:t>
+            </a:r>
+          </a:p>
+          <a:p>
+            <a:pPr marL="285750" indent="-285750">
+              <a:lnSpc>
+                <a:spcPct val="150000"/>
+              </a:lnSpc>
+              <a:spcAft>
+                <a:spcPts val="110"/>
+              </a:spcAft>
+              <a:buFont typeface="Wingdings" panose="05000000000000000000" pitchFamily="2" charset="2"/>
+              <a:buChar char="Ø"/>
+            </a:pPr>
+            <a:r>
+              <a:rPr lang="pt-BR" sz="2000" b="1" dirty="0"/>
+              <a:t>Furto</a:t>
+            </a:r>
+          </a:p>
+          <a:p>
+            <a:pPr marL="285750" indent="-285750">
+              <a:lnSpc>
+                <a:spcPct val="150000"/>
+              </a:lnSpc>
+              <a:spcAft>
+                <a:spcPts val="110"/>
+              </a:spcAft>
+              <a:buFont typeface="Wingdings" panose="05000000000000000000" pitchFamily="2" charset="2"/>
+              <a:buChar char="Ø"/>
+            </a:pPr>
+            <a:r>
+              <a:rPr lang="pt-BR" sz="2000" b="1" dirty="0"/>
+              <a:t>Homicídio</a:t>
+            </a:r>
+          </a:p>
+          <a:p>
+            <a:pPr marL="285750" indent="-285750">
+              <a:lnSpc>
+                <a:spcPct val="150000"/>
+              </a:lnSpc>
+              <a:spcAft>
+                <a:spcPts val="110"/>
+              </a:spcAft>
+              <a:buFont typeface="Wingdings" panose="05000000000000000000" pitchFamily="2" charset="2"/>
+              <a:buChar char="Ø"/>
+            </a:pPr>
+            <a:r>
+              <a:rPr lang="pt-BR" sz="2000" b="1" dirty="0"/>
+              <a:t>Taxa de Homicídio ONU: 10 por 100.000</a:t>
+            </a:r>
+          </a:p>
+          <a:p>
+            <a:pPr marL="285750" indent="-285750">
+              <a:lnSpc>
+                <a:spcPct val="150000"/>
+              </a:lnSpc>
+              <a:spcAft>
+                <a:spcPts val="110"/>
+              </a:spcAft>
+              <a:buFont typeface="Wingdings" panose="05000000000000000000" pitchFamily="2" charset="2"/>
+              <a:buChar char="Ø"/>
+            </a:pPr>
+            <a:r>
+              <a:rPr lang="pt-BR" sz="2000" b="1" u="none" strike="noStrike" dirty="0">
+                <a:effectLst/>
+                <a:latin typeface="Google Sans"/>
+              </a:rPr>
+              <a:t>Média Global:</a:t>
+            </a:r>
+            <a:r>
+              <a:rPr lang="pt-BR" sz="2000" dirty="0"/>
+              <a:t> A taxa média no mundo gira em torno de </a:t>
+            </a:r>
+            <a:r>
+              <a:rPr lang="pt-BR" sz="2000" b="1" u="none" strike="noStrike" dirty="0">
+                <a:effectLst/>
+                <a:latin typeface="Google Sans"/>
+              </a:rPr>
+              <a:t>5,8 homicídios por 100 mil habitantes</a:t>
+            </a:r>
+            <a:r>
+              <a:rPr lang="pt-BR" sz="2000" dirty="0"/>
+              <a:t>.</a:t>
+            </a:r>
+            <a:endParaRPr lang="pt-BR" sz="2000" b="1" dirty="0"/>
+          </a:p>
+        </p:txBody>
+      </p:sp>
+    </p:spTree>
+    <p:extLst>
+      <p:ext uri="{BB962C8B-B14F-4D97-AF65-F5344CB8AC3E}">
+        <p14:creationId xmlns:p14="http://schemas.microsoft.com/office/powerpoint/2010/main" val="204840894"/>
+      </p:ext>
+    </p:extLst>
+  </p:cSld>
+  <p:clrMapOvr>
+    <a:masterClrMapping/>
+  </p:clrMapOvr>
+  <mc:AlternateContent xmlns:mc="http://schemas.openxmlformats.org/markup-compatibility/2006" xmlns:p159="http://schemas.microsoft.com/office/powerpoint/2015/09/main">
+    <mc:Choice Requires="p159">
+      <p:transition xmlns:p14="http://schemas.microsoft.com/office/powerpoint/2010/main" spd="slow" p14:dur="1250">
+        <p159:morph option="byObject"/>
+      </p:transition>
+    </mc:Choice>
+    <mc:Fallback xmlns="">
+      <p:transition spd="slow">
+        <p:fade/>
+      </p:transition>
+    </mc:Fallback>
+  </mc:AlternateContent>
+</p:sld>
+</file>
+
+<file path=ppt/slides/slide11.xml><?xml version="1.0" encoding="utf-8"?>
+<p:sld xmlns:a="http://schemas.openxmlformats.org/drawingml/2006/main" xmlns:r="http://schemas.openxmlformats.org/officeDocument/2006/relationships" xmlns:p="http://schemas.openxmlformats.org/presentationml/2006/main">
+  <p:cSld>
+    <p:spTree>
+      <p:nvGrpSpPr>
+        <p:cNvPr id="1" name=""/>
+        <p:cNvGrpSpPr/>
+        <p:nvPr/>
+      </p:nvGrpSpPr>
+      <p:grpSpPr>
+        <a:xfrm>
+          <a:off x="0" y="0"/>
+          <a:ext cx="0" cy="0"/>
+          <a:chOff x="0" y="0"/>
+          <a:chExt cx="0" cy="0"/>
+        </a:xfrm>
+      </p:grpSpPr>
+      <p:cxnSp>
+        <p:nvCxnSpPr>
+          <p:cNvPr id="7" name="Conector reto 6">
+            <a:extLst>
+              <a:ext uri="{FF2B5EF4-FFF2-40B4-BE49-F238E27FC236}">
+                <a16:creationId xmlns:a16="http://schemas.microsoft.com/office/drawing/2014/main" id="{280B8309-4572-4E27-8B6F-D29679313292}"/>
+              </a:ext>
+            </a:extLst>
+          </p:cNvPr>
+          <p:cNvCxnSpPr>
+            <a:cxnSpLocks/>
+          </p:cNvCxnSpPr>
+          <p:nvPr/>
+        </p:nvCxnSpPr>
+        <p:spPr>
+          <a:xfrm>
+            <a:off x="-112541" y="970671"/>
+            <a:ext cx="8328073" cy="0"/>
+          </a:xfrm>
+          <a:prstGeom prst="line">
+            <a:avLst/>
+          </a:prstGeom>
+          <a:ln w="38100"/>
+        </p:spPr>
+        <p:style>
+          <a:lnRef idx="1">
+            <a:schemeClr val="accent1"/>
+          </a:lnRef>
+          <a:fillRef idx="0">
+            <a:schemeClr val="accent1"/>
+          </a:fillRef>
+          <a:effectRef idx="0">
+            <a:schemeClr val="accent1"/>
+          </a:effectRef>
+          <a:fontRef idx="minor">
+            <a:schemeClr val="tx1"/>
+          </a:fontRef>
+        </p:style>
+      </p:cxnSp>
+      <p:sp>
+        <p:nvSpPr>
+          <p:cNvPr id="8" name="CaixaDeTexto 7">
+            <a:extLst>
+              <a:ext uri="{FF2B5EF4-FFF2-40B4-BE49-F238E27FC236}">
+                <a16:creationId xmlns:a16="http://schemas.microsoft.com/office/drawing/2014/main" id="{39AE06C5-34BE-4D68-97C3-4C07702C2DF6}"/>
+              </a:ext>
+            </a:extLst>
+          </p:cNvPr>
+          <p:cNvSpPr txBox="1"/>
+          <p:nvPr/>
+        </p:nvSpPr>
+        <p:spPr>
+          <a:xfrm>
+            <a:off x="249836" y="200638"/>
+            <a:ext cx="11692327" cy="584775"/>
+          </a:xfrm>
+          <a:prstGeom prst="rect">
+            <a:avLst/>
+          </a:prstGeom>
+          <a:noFill/>
+        </p:spPr>
+        <p:txBody>
+          <a:bodyPr wrap="square" rtlCol="0">
+            <a:spAutoFit/>
+          </a:bodyPr>
+          <a:lstStyle/>
+          <a:p>
+            <a:r>
+              <a:rPr lang="pt-BR" sz="3200" b="1" dirty="0">
+                <a:solidFill>
+                  <a:srgbClr val="002060"/>
+                </a:solidFill>
+                <a:latin typeface="Cambria" panose="02040503050406030204" pitchFamily="18" charset="0"/>
+                <a:ea typeface="Cambria" panose="02040503050406030204" pitchFamily="18" charset="0"/>
+              </a:rPr>
+              <a:t>Panorama RS à Luz dos Dados públicos disponíveis da SSP-RS</a:t>
+            </a:r>
+          </a:p>
+        </p:txBody>
+      </p:sp>
+      <p:pic>
+        <p:nvPicPr>
+          <p:cNvPr id="2" name="Picture 2" descr="UFRGS na Serra | Visão de futuro e coragem para inovar">
+            <a:extLst>
+              <a:ext uri="{FF2B5EF4-FFF2-40B4-BE49-F238E27FC236}">
+                <a16:creationId xmlns:a16="http://schemas.microsoft.com/office/drawing/2014/main" id="{567C8E3D-C535-EC50-849C-270CEB4B8A04}"/>
+              </a:ext>
+            </a:extLst>
+          </p:cNvPr>
+          <p:cNvPicPr>
+            <a:picLocks noChangeAspect="1" noChangeArrowheads="1"/>
+          </p:cNvPicPr>
+          <p:nvPr/>
+        </p:nvPicPr>
+        <p:blipFill>
+          <a:blip r:embed="rId3">
+            <a:extLst>
+              <a:ext uri="{28A0092B-C50C-407E-A947-70E740481C1C}">
+                <a14:useLocalDpi xmlns:a14="http://schemas.microsoft.com/office/drawing/2010/main" val="0"/>
+              </a:ext>
+            </a:extLst>
+          </a:blip>
+          <a:srcRect/>
+          <a:stretch>
+            <a:fillRect/>
+          </a:stretch>
+        </p:blipFill>
+        <p:spPr bwMode="auto">
+          <a:xfrm>
+            <a:off x="119922" y="6346096"/>
+            <a:ext cx="683614" cy="445109"/>
+          </a:xfrm>
+          <a:prstGeom prst="rect">
+            <a:avLst/>
+          </a:prstGeom>
+          <a:noFill/>
+          <a:extLst>
+            <a:ext uri="{909E8E84-426E-40DD-AFC4-6F175D3DCCD1}">
+              <a14:hiddenFill xmlns:a14="http://schemas.microsoft.com/office/drawing/2010/main">
+                <a:solidFill>
+                  <a:srgbClr val="FFFFFF"/>
+                </a:solidFill>
+              </a14:hiddenFill>
+            </a:ext>
+          </a:extLst>
+        </p:spPr>
+      </p:pic>
+      <p:pic>
+        <p:nvPicPr>
+          <p:cNvPr id="3" name="Picture 4">
+            <a:extLst>
+              <a:ext uri="{FF2B5EF4-FFF2-40B4-BE49-F238E27FC236}">
+                <a16:creationId xmlns:a16="http://schemas.microsoft.com/office/drawing/2014/main" id="{C9663204-9A6C-C5D7-7C9B-AAF5653911D6}"/>
+              </a:ext>
+            </a:extLst>
+          </p:cNvPr>
+          <p:cNvPicPr>
+            <a:picLocks noChangeAspect="1" noChangeArrowheads="1"/>
+          </p:cNvPicPr>
+          <p:nvPr/>
+        </p:nvPicPr>
+        <p:blipFill>
+          <a:blip r:embed="rId4">
+            <a:extLst>
+              <a:ext uri="{28A0092B-C50C-407E-A947-70E740481C1C}">
+                <a14:useLocalDpi xmlns:a14="http://schemas.microsoft.com/office/drawing/2010/main" val="0"/>
+              </a:ext>
+            </a:extLst>
+          </a:blip>
+          <a:srcRect/>
+          <a:stretch>
+            <a:fillRect/>
+          </a:stretch>
+        </p:blipFill>
+        <p:spPr bwMode="auto">
+          <a:xfrm>
+            <a:off x="10802599" y="6212508"/>
+            <a:ext cx="1329440" cy="578697"/>
+          </a:xfrm>
+          <a:prstGeom prst="rect">
+            <a:avLst/>
+          </a:prstGeom>
+          <a:noFill/>
+          <a:extLst>
+            <a:ext uri="{909E8E84-426E-40DD-AFC4-6F175D3DCCD1}">
+              <a14:hiddenFill xmlns:a14="http://schemas.microsoft.com/office/drawing/2010/main">
+                <a:solidFill>
+                  <a:srgbClr val="FFFFFF"/>
+                </a:solidFill>
+              </a14:hiddenFill>
+            </a:ext>
+          </a:extLst>
+        </p:spPr>
+      </p:pic>
+      <p:sp>
+        <p:nvSpPr>
+          <p:cNvPr id="4" name="CaixaDeTexto 3">
+            <a:extLst>
+              <a:ext uri="{FF2B5EF4-FFF2-40B4-BE49-F238E27FC236}">
+                <a16:creationId xmlns:a16="http://schemas.microsoft.com/office/drawing/2014/main" id="{F9B44222-0FEB-DD8A-E65A-F10683C06A0F}"/>
+              </a:ext>
+            </a:extLst>
+          </p:cNvPr>
+          <p:cNvSpPr txBox="1"/>
+          <p:nvPr/>
+        </p:nvSpPr>
+        <p:spPr>
+          <a:xfrm>
+            <a:off x="940904" y="1276323"/>
+            <a:ext cx="10310191" cy="4763868"/>
+          </a:xfrm>
+          <a:prstGeom prst="rect">
+            <a:avLst/>
+          </a:prstGeom>
+          <a:noFill/>
+        </p:spPr>
+        <p:txBody>
+          <a:bodyPr wrap="square" rtlCol="0">
+            <a:spAutoFit/>
+          </a:bodyPr>
+          <a:lstStyle/>
+          <a:p>
+            <a:pPr marL="285750" indent="-285750">
+              <a:lnSpc>
+                <a:spcPct val="150000"/>
+              </a:lnSpc>
+              <a:spcAft>
+                <a:spcPts val="110"/>
+              </a:spcAft>
+              <a:buFont typeface="Wingdings" panose="05000000000000000000" pitchFamily="2" charset="2"/>
+              <a:buChar char="Ø"/>
+            </a:pPr>
+            <a:r>
+              <a:rPr lang="pt-BR" sz="2000" b="1" dirty="0"/>
+              <a:t>Descritivas</a:t>
+            </a:r>
+          </a:p>
+          <a:p>
+            <a:pPr marL="285750" indent="-285750">
+              <a:lnSpc>
+                <a:spcPct val="150000"/>
+              </a:lnSpc>
+              <a:spcAft>
+                <a:spcPts val="110"/>
+              </a:spcAft>
+              <a:buFont typeface="Wingdings" panose="05000000000000000000" pitchFamily="2" charset="2"/>
+              <a:buChar char="Ø"/>
+            </a:pPr>
+            <a:r>
+              <a:rPr lang="pt-BR" sz="2000" b="1" dirty="0"/>
+              <a:t>Taxas em Municípios pequenos</a:t>
+            </a:r>
+          </a:p>
+          <a:p>
+            <a:pPr marL="285750" indent="-285750">
+              <a:lnSpc>
+                <a:spcPct val="150000"/>
+              </a:lnSpc>
+              <a:spcAft>
+                <a:spcPts val="110"/>
+              </a:spcAft>
+              <a:buFont typeface="Wingdings" panose="05000000000000000000" pitchFamily="2" charset="2"/>
+              <a:buChar char="Ø"/>
+            </a:pPr>
+            <a:r>
+              <a:rPr lang="pt-BR" sz="2000" b="1" dirty="0"/>
+              <a:t>Autocorrelação espacial</a:t>
+            </a:r>
+          </a:p>
+          <a:p>
+            <a:pPr marL="285750" indent="-285750">
+              <a:lnSpc>
+                <a:spcPct val="150000"/>
+              </a:lnSpc>
+              <a:spcAft>
+                <a:spcPts val="110"/>
+              </a:spcAft>
+              <a:buFont typeface="Wingdings" panose="05000000000000000000" pitchFamily="2" charset="2"/>
+              <a:buChar char="Ø"/>
+            </a:pPr>
+            <a:r>
+              <a:rPr lang="pt-BR" sz="2000" b="1" dirty="0"/>
+              <a:t>Cadeias de Markov</a:t>
+            </a:r>
+          </a:p>
+          <a:p>
+            <a:pPr marL="285750" indent="-285750">
+              <a:lnSpc>
+                <a:spcPct val="150000"/>
+              </a:lnSpc>
+              <a:spcAft>
+                <a:spcPts val="110"/>
+              </a:spcAft>
+              <a:buFont typeface="Wingdings" panose="05000000000000000000" pitchFamily="2" charset="2"/>
+              <a:buChar char="Ø"/>
+            </a:pPr>
+            <a:r>
+              <a:rPr lang="pt-BR" sz="2000" b="1" dirty="0"/>
+              <a:t>Roubo de Veículos</a:t>
+            </a:r>
+          </a:p>
+          <a:p>
+            <a:pPr marL="285750" indent="-285750">
+              <a:lnSpc>
+                <a:spcPct val="150000"/>
+              </a:lnSpc>
+              <a:spcAft>
+                <a:spcPts val="110"/>
+              </a:spcAft>
+              <a:buFont typeface="Wingdings" panose="05000000000000000000" pitchFamily="2" charset="2"/>
+              <a:buChar char="Ø"/>
+            </a:pPr>
+            <a:r>
+              <a:rPr lang="pt-BR" sz="2000" b="1" dirty="0"/>
+              <a:t>Furto</a:t>
+            </a:r>
+          </a:p>
+          <a:p>
+            <a:pPr marL="285750" indent="-285750">
+              <a:lnSpc>
+                <a:spcPct val="150000"/>
+              </a:lnSpc>
+              <a:spcAft>
+                <a:spcPts val="110"/>
+              </a:spcAft>
+              <a:buFont typeface="Wingdings" panose="05000000000000000000" pitchFamily="2" charset="2"/>
+              <a:buChar char="Ø"/>
+            </a:pPr>
+            <a:r>
+              <a:rPr lang="pt-BR" sz="2000" b="1" dirty="0"/>
+              <a:t>Homicídio</a:t>
+            </a:r>
+          </a:p>
+          <a:p>
+            <a:pPr marL="285750" indent="-285750">
+              <a:lnSpc>
+                <a:spcPct val="150000"/>
+              </a:lnSpc>
+              <a:spcAft>
+                <a:spcPts val="110"/>
+              </a:spcAft>
+              <a:buFont typeface="Wingdings" panose="05000000000000000000" pitchFamily="2" charset="2"/>
+              <a:buChar char="Ø"/>
+            </a:pPr>
+            <a:r>
+              <a:rPr lang="pt-BR" sz="2000" b="1" dirty="0"/>
+              <a:t>Taxa de Homicídio ONU: 10 por 100.000</a:t>
+            </a:r>
+          </a:p>
+          <a:p>
+            <a:pPr marL="285750" indent="-285750">
+              <a:lnSpc>
+                <a:spcPct val="150000"/>
+              </a:lnSpc>
+              <a:spcAft>
+                <a:spcPts val="110"/>
+              </a:spcAft>
+              <a:buFont typeface="Wingdings" panose="05000000000000000000" pitchFamily="2" charset="2"/>
+              <a:buChar char="Ø"/>
+            </a:pPr>
+            <a:r>
+              <a:rPr lang="pt-BR" sz="2000" b="1" u="none" strike="noStrike" dirty="0">
+                <a:effectLst/>
+                <a:latin typeface="Google Sans"/>
+              </a:rPr>
+              <a:t>Média Global:</a:t>
+            </a:r>
+            <a:r>
+              <a:rPr lang="pt-BR" sz="2000" dirty="0"/>
+              <a:t> A taxa média no mundo gira em torno de </a:t>
+            </a:r>
+            <a:r>
+              <a:rPr lang="pt-BR" sz="2000" b="1" u="none" strike="noStrike" dirty="0">
+                <a:effectLst/>
+                <a:latin typeface="Google Sans"/>
+              </a:rPr>
+              <a:t>5,8 homicídios por 100 mil habitantes</a:t>
+            </a:r>
+            <a:r>
+              <a:rPr lang="pt-BR" sz="2000" dirty="0"/>
+              <a:t>.</a:t>
+            </a:r>
+            <a:endParaRPr lang="pt-BR" sz="2000" b="1" dirty="0"/>
+          </a:p>
+        </p:txBody>
+      </p:sp>
+    </p:spTree>
+    <p:extLst>
+      <p:ext uri="{BB962C8B-B14F-4D97-AF65-F5344CB8AC3E}">
+        <p14:creationId xmlns:p14="http://schemas.microsoft.com/office/powerpoint/2010/main" val="1600642753"/>
+      </p:ext>
+    </p:extLst>
+  </p:cSld>
+  <p:clrMapOvr>
+    <a:masterClrMapping/>
+  </p:clrMapOvr>
+  <mc:AlternateContent xmlns:mc="http://schemas.openxmlformats.org/markup-compatibility/2006" xmlns:p159="http://schemas.microsoft.com/office/powerpoint/2015/09/main">
+    <mc:Choice Requires="p159">
+      <p:transition xmlns:p14="http://schemas.microsoft.com/office/powerpoint/2010/main" spd="slow" p14:dur="1250">
+        <p159:morph option="byObject"/>
+      </p:transition>
+    </mc:Choice>
+    <mc:Fallback xmlns="">
+      <p:transition spd="slow">
+        <p:fade/>
+      </p:transition>
+    </mc:Fallback>
+  </mc:AlternateContent>
+</p:sld>
+</file>
+
+<file path=ppt/slides/slide12.xml><?xml version="1.0" encoding="utf-8"?>
+<p:sld xmlns:a="http://schemas.openxmlformats.org/drawingml/2006/main" xmlns:r="http://schemas.openxmlformats.org/officeDocument/2006/relationships" xmlns:p="http://schemas.openxmlformats.org/presentationml/2006/main">
+  <p:cSld>
+    <p:spTree>
+      <p:nvGrpSpPr>
+        <p:cNvPr id="1" name=""/>
+        <p:cNvGrpSpPr/>
+        <p:nvPr/>
+      </p:nvGrpSpPr>
+      <p:grpSpPr>
+        <a:xfrm>
+          <a:off x="0" y="0"/>
+          <a:ext cx="0" cy="0"/>
+          <a:chOff x="0" y="0"/>
+          <a:chExt cx="0" cy="0"/>
+        </a:xfrm>
+      </p:grpSpPr>
+      <p:cxnSp>
+        <p:nvCxnSpPr>
+          <p:cNvPr id="7" name="Conector reto 6">
+            <a:extLst>
+              <a:ext uri="{FF2B5EF4-FFF2-40B4-BE49-F238E27FC236}">
+                <a16:creationId xmlns:a16="http://schemas.microsoft.com/office/drawing/2014/main" id="{280B8309-4572-4E27-8B6F-D29679313292}"/>
+              </a:ext>
+            </a:extLst>
+          </p:cNvPr>
+          <p:cNvCxnSpPr>
+            <a:cxnSpLocks/>
+          </p:cNvCxnSpPr>
+          <p:nvPr/>
+        </p:nvCxnSpPr>
+        <p:spPr>
+          <a:xfrm>
+            <a:off x="-112541" y="970671"/>
+            <a:ext cx="8328073" cy="0"/>
+          </a:xfrm>
+          <a:prstGeom prst="line">
+            <a:avLst/>
+          </a:prstGeom>
+          <a:ln w="38100"/>
+        </p:spPr>
+        <p:style>
+          <a:lnRef idx="1">
+            <a:schemeClr val="accent1"/>
+          </a:lnRef>
+          <a:fillRef idx="0">
+            <a:schemeClr val="accent1"/>
+          </a:fillRef>
+          <a:effectRef idx="0">
+            <a:schemeClr val="accent1"/>
+          </a:effectRef>
+          <a:fontRef idx="minor">
+            <a:schemeClr val="tx1"/>
+          </a:fontRef>
+        </p:style>
+      </p:cxnSp>
+      <p:sp>
+        <p:nvSpPr>
+          <p:cNvPr id="8" name="CaixaDeTexto 7">
+            <a:extLst>
+              <a:ext uri="{FF2B5EF4-FFF2-40B4-BE49-F238E27FC236}">
+                <a16:creationId xmlns:a16="http://schemas.microsoft.com/office/drawing/2014/main" id="{39AE06C5-34BE-4D68-97C3-4C07702C2DF6}"/>
+              </a:ext>
+            </a:extLst>
+          </p:cNvPr>
+          <p:cNvSpPr txBox="1"/>
+          <p:nvPr/>
+        </p:nvSpPr>
+        <p:spPr>
+          <a:xfrm>
+            <a:off x="1103819" y="140678"/>
+            <a:ext cx="7815329" cy="646331"/>
+          </a:xfrm>
+          <a:prstGeom prst="rect">
+            <a:avLst/>
+          </a:prstGeom>
+          <a:noFill/>
+        </p:spPr>
+        <p:txBody>
+          <a:bodyPr wrap="square" rtlCol="0">
+            <a:spAutoFit/>
+          </a:bodyPr>
+          <a:lstStyle/>
+          <a:p>
+            <a:r>
+              <a:rPr lang="pt-BR" sz="3600" b="1" dirty="0">
+                <a:solidFill>
+                  <a:srgbClr val="002060"/>
+                </a:solidFill>
+                <a:latin typeface="Cambria" panose="02040503050406030204" pitchFamily="18" charset="0"/>
+                <a:ea typeface="Cambria" panose="02040503050406030204" pitchFamily="18" charset="0"/>
+              </a:rPr>
+              <a:t>Armas x Criminalidade</a:t>
+            </a:r>
+          </a:p>
+        </p:txBody>
+      </p:sp>
+      <p:sp>
+        <p:nvSpPr>
+          <p:cNvPr id="14" name="CaixaDeTexto 13">
+            <a:extLst>
+              <a:ext uri="{FF2B5EF4-FFF2-40B4-BE49-F238E27FC236}">
+                <a16:creationId xmlns:a16="http://schemas.microsoft.com/office/drawing/2014/main" id="{427DBFEB-81BF-4CC3-A411-FBF43D295C56}"/>
+              </a:ext>
+            </a:extLst>
+          </p:cNvPr>
+          <p:cNvSpPr txBox="1"/>
+          <p:nvPr/>
+        </p:nvSpPr>
+        <p:spPr>
+          <a:xfrm>
+            <a:off x="940904" y="1276323"/>
+            <a:ext cx="10310191" cy="506292"/>
+          </a:xfrm>
+          <a:prstGeom prst="rect">
+            <a:avLst/>
+          </a:prstGeom>
+          <a:noFill/>
+        </p:spPr>
+        <p:txBody>
+          <a:bodyPr wrap="square" rtlCol="0">
+            <a:spAutoFit/>
+          </a:bodyPr>
+          <a:lstStyle/>
+          <a:p>
+            <a:pPr marL="285750" indent="-285750">
+              <a:lnSpc>
+                <a:spcPct val="150000"/>
+              </a:lnSpc>
+              <a:spcAft>
+                <a:spcPts val="110"/>
+              </a:spcAft>
+              <a:buFont typeface="Wingdings" panose="05000000000000000000" pitchFamily="2" charset="2"/>
+              <a:buChar char="Ø"/>
+            </a:pPr>
+            <a:r>
+              <a:rPr lang="pt-BR" sz="2000" b="1" dirty="0"/>
+              <a:t>Noções gerais sobre Estatística. </a:t>
+            </a:r>
+          </a:p>
+        </p:txBody>
+      </p:sp>
+      <p:pic>
+        <p:nvPicPr>
+          <p:cNvPr id="2" name="Picture 2" descr="UFRGS na Serra | Visão de futuro e coragem para inovar">
+            <a:extLst>
+              <a:ext uri="{FF2B5EF4-FFF2-40B4-BE49-F238E27FC236}">
+                <a16:creationId xmlns:a16="http://schemas.microsoft.com/office/drawing/2014/main" id="{567C8E3D-C535-EC50-849C-270CEB4B8A04}"/>
+              </a:ext>
+            </a:extLst>
+          </p:cNvPr>
+          <p:cNvPicPr>
+            <a:picLocks noChangeAspect="1" noChangeArrowheads="1"/>
+          </p:cNvPicPr>
+          <p:nvPr/>
+        </p:nvPicPr>
+        <p:blipFill>
+          <a:blip r:embed="rId3">
+            <a:extLst>
+              <a:ext uri="{28A0092B-C50C-407E-A947-70E740481C1C}">
+                <a14:useLocalDpi xmlns:a14="http://schemas.microsoft.com/office/drawing/2010/main" val="0"/>
+              </a:ext>
+            </a:extLst>
+          </a:blip>
+          <a:srcRect/>
+          <a:stretch>
+            <a:fillRect/>
+          </a:stretch>
+        </p:blipFill>
+        <p:spPr bwMode="auto">
+          <a:xfrm>
+            <a:off x="119922" y="6346096"/>
+            <a:ext cx="683614" cy="445109"/>
+          </a:xfrm>
+          <a:prstGeom prst="rect">
+            <a:avLst/>
+          </a:prstGeom>
+          <a:noFill/>
+          <a:extLst>
+            <a:ext uri="{909E8E84-426E-40DD-AFC4-6F175D3DCCD1}">
+              <a14:hiddenFill xmlns:a14="http://schemas.microsoft.com/office/drawing/2010/main">
+                <a:solidFill>
+                  <a:srgbClr val="FFFFFF"/>
+                </a:solidFill>
+              </a14:hiddenFill>
+            </a:ext>
+          </a:extLst>
+        </p:spPr>
+      </p:pic>
+      <p:pic>
+        <p:nvPicPr>
+          <p:cNvPr id="3" name="Picture 4">
+            <a:extLst>
+              <a:ext uri="{FF2B5EF4-FFF2-40B4-BE49-F238E27FC236}">
+                <a16:creationId xmlns:a16="http://schemas.microsoft.com/office/drawing/2014/main" id="{C9663204-9A6C-C5D7-7C9B-AAF5653911D6}"/>
+              </a:ext>
+            </a:extLst>
+          </p:cNvPr>
+          <p:cNvPicPr>
+            <a:picLocks noChangeAspect="1" noChangeArrowheads="1"/>
+          </p:cNvPicPr>
+          <p:nvPr/>
+        </p:nvPicPr>
+        <p:blipFill>
+          <a:blip r:embed="rId4">
+            <a:extLst>
+              <a:ext uri="{28A0092B-C50C-407E-A947-70E740481C1C}">
+                <a14:useLocalDpi xmlns:a14="http://schemas.microsoft.com/office/drawing/2010/main" val="0"/>
+              </a:ext>
+            </a:extLst>
+          </a:blip>
+          <a:srcRect/>
+          <a:stretch>
+            <a:fillRect/>
+          </a:stretch>
+        </p:blipFill>
+        <p:spPr bwMode="auto">
+          <a:xfrm>
+            <a:off x="10802599" y="6212508"/>
+            <a:ext cx="1329440" cy="578697"/>
+          </a:xfrm>
+          <a:prstGeom prst="rect">
+            <a:avLst/>
+          </a:prstGeom>
+          <a:noFill/>
+          <a:extLst>
+            <a:ext uri="{909E8E84-426E-40DD-AFC4-6F175D3DCCD1}">
+              <a14:hiddenFill xmlns:a14="http://schemas.microsoft.com/office/drawing/2010/main">
+                <a:solidFill>
+                  <a:srgbClr val="FFFFFF"/>
+                </a:solidFill>
+              </a14:hiddenFill>
+            </a:ext>
+          </a:extLst>
+        </p:spPr>
+      </p:pic>
+    </p:spTree>
+    <p:extLst>
+      <p:ext uri="{BB962C8B-B14F-4D97-AF65-F5344CB8AC3E}">
+        <p14:creationId xmlns:p14="http://schemas.microsoft.com/office/powerpoint/2010/main" val="3554767980"/>
+      </p:ext>
+    </p:extLst>
+  </p:cSld>
+  <p:clrMapOvr>
+    <a:masterClrMapping/>
+  </p:clrMapOvr>
+  <mc:AlternateContent xmlns:mc="http://schemas.openxmlformats.org/markup-compatibility/2006" xmlns:p159="http://schemas.microsoft.com/office/powerpoint/2015/09/main">
+    <mc:Choice Requires="p159">
+      <p:transition xmlns:p14="http://schemas.microsoft.com/office/powerpoint/2010/main" spd="slow" p14:dur="1250">
+        <p159:morph option="byObject"/>
+      </p:transition>
+    </mc:Choice>
+    <mc:Fallback xmlns="">
+      <p:transition spd="slow">
+        <p:fade/>
+      </p:transition>
+    </mc:Fallback>
+  </mc:AlternateContent>
+</p:sld>
+</file>
+
+<file path=ppt/slides/slide13.xml><?xml version="1.0" encoding="utf-8"?>
+<p:sld xmlns:a="http://schemas.openxmlformats.org/drawingml/2006/main" xmlns:r="http://schemas.openxmlformats.org/officeDocument/2006/relationships" xmlns:p="http://schemas.openxmlformats.org/presentationml/2006/main">
+  <p:cSld>
+    <p:spTree>
+      <p:nvGrpSpPr>
+        <p:cNvPr id="1" name=""/>
+        <p:cNvGrpSpPr/>
+        <p:nvPr/>
+      </p:nvGrpSpPr>
+      <p:grpSpPr>
+        <a:xfrm>
+          <a:off x="0" y="0"/>
+          <a:ext cx="0" cy="0"/>
+          <a:chOff x="0" y="0"/>
+          <a:chExt cx="0" cy="0"/>
+        </a:xfrm>
+      </p:grpSpPr>
+      <p:cxnSp>
+        <p:nvCxnSpPr>
+          <p:cNvPr id="7" name="Conector reto 6">
+            <a:extLst>
+              <a:ext uri="{FF2B5EF4-FFF2-40B4-BE49-F238E27FC236}">
+                <a16:creationId xmlns:a16="http://schemas.microsoft.com/office/drawing/2014/main" id="{280B8309-4572-4E27-8B6F-D29679313292}"/>
+              </a:ext>
+            </a:extLst>
+          </p:cNvPr>
+          <p:cNvCxnSpPr>
+            <a:cxnSpLocks/>
+          </p:cNvCxnSpPr>
+          <p:nvPr/>
+        </p:nvCxnSpPr>
+        <p:spPr>
+          <a:xfrm>
+            <a:off x="-112541" y="970671"/>
+            <a:ext cx="8328073" cy="0"/>
+          </a:xfrm>
+          <a:prstGeom prst="line">
+            <a:avLst/>
+          </a:prstGeom>
+          <a:ln w="38100"/>
+        </p:spPr>
+        <p:style>
+          <a:lnRef idx="1">
+            <a:schemeClr val="accent1"/>
+          </a:lnRef>
+          <a:fillRef idx="0">
+            <a:schemeClr val="accent1"/>
+          </a:fillRef>
+          <a:effectRef idx="0">
+            <a:schemeClr val="accent1"/>
+          </a:effectRef>
+          <a:fontRef idx="minor">
+            <a:schemeClr val="tx1"/>
+          </a:fontRef>
+        </p:style>
+      </p:cxnSp>
+      <p:sp>
+        <p:nvSpPr>
+          <p:cNvPr id="8" name="CaixaDeTexto 7">
+            <a:extLst>
+              <a:ext uri="{FF2B5EF4-FFF2-40B4-BE49-F238E27FC236}">
+                <a16:creationId xmlns:a16="http://schemas.microsoft.com/office/drawing/2014/main" id="{39AE06C5-34BE-4D68-97C3-4C07702C2DF6}"/>
+              </a:ext>
+            </a:extLst>
+          </p:cNvPr>
+          <p:cNvSpPr txBox="1"/>
+          <p:nvPr/>
+        </p:nvSpPr>
+        <p:spPr>
+          <a:xfrm>
+            <a:off x="1103819" y="140678"/>
+            <a:ext cx="7815329" cy="646331"/>
+          </a:xfrm>
+          <a:prstGeom prst="rect">
+            <a:avLst/>
+          </a:prstGeom>
+          <a:noFill/>
+        </p:spPr>
+        <p:txBody>
+          <a:bodyPr wrap="square" rtlCol="0">
+            <a:spAutoFit/>
+          </a:bodyPr>
+          <a:lstStyle/>
+          <a:p>
+            <a:r>
+              <a:rPr lang="pt-BR" sz="3600" b="1" dirty="0">
+                <a:solidFill>
+                  <a:srgbClr val="002060"/>
+                </a:solidFill>
+                <a:latin typeface="Cambria" panose="02040503050406030204" pitchFamily="18" charset="0"/>
+                <a:ea typeface="Cambria" panose="02040503050406030204" pitchFamily="18" charset="0"/>
+              </a:rPr>
+              <a:t>Luz x Criminalidade</a:t>
+            </a:r>
+          </a:p>
+        </p:txBody>
+      </p:sp>
+      <p:sp>
+        <p:nvSpPr>
+          <p:cNvPr id="14" name="CaixaDeTexto 13">
+            <a:extLst>
+              <a:ext uri="{FF2B5EF4-FFF2-40B4-BE49-F238E27FC236}">
+                <a16:creationId xmlns:a16="http://schemas.microsoft.com/office/drawing/2014/main" id="{427DBFEB-81BF-4CC3-A411-FBF43D295C56}"/>
+              </a:ext>
+            </a:extLst>
+          </p:cNvPr>
+          <p:cNvSpPr txBox="1"/>
+          <p:nvPr/>
+        </p:nvSpPr>
+        <p:spPr>
+          <a:xfrm>
+            <a:off x="940904" y="1276323"/>
+            <a:ext cx="10310191" cy="506292"/>
+          </a:xfrm>
+          <a:prstGeom prst="rect">
+            <a:avLst/>
+          </a:prstGeom>
+          <a:noFill/>
+        </p:spPr>
+        <p:txBody>
+          <a:bodyPr wrap="square" rtlCol="0">
+            <a:spAutoFit/>
+          </a:bodyPr>
+          <a:lstStyle/>
+          <a:p>
+            <a:pPr marL="285750" indent="-285750">
+              <a:lnSpc>
+                <a:spcPct val="150000"/>
+              </a:lnSpc>
+              <a:spcAft>
+                <a:spcPts val="110"/>
+              </a:spcAft>
+              <a:buFont typeface="Wingdings" panose="05000000000000000000" pitchFamily="2" charset="2"/>
+              <a:buChar char="Ø"/>
+            </a:pPr>
+            <a:r>
+              <a:rPr lang="pt-BR" sz="2000" b="1" dirty="0"/>
+              <a:t>Noções gerais sobre Estatística. </a:t>
+            </a:r>
+          </a:p>
+        </p:txBody>
+      </p:sp>
+      <p:pic>
+        <p:nvPicPr>
+          <p:cNvPr id="2" name="Picture 2" descr="UFRGS na Serra | Visão de futuro e coragem para inovar">
+            <a:extLst>
+              <a:ext uri="{FF2B5EF4-FFF2-40B4-BE49-F238E27FC236}">
+                <a16:creationId xmlns:a16="http://schemas.microsoft.com/office/drawing/2014/main" id="{567C8E3D-C535-EC50-849C-270CEB4B8A04}"/>
+              </a:ext>
+            </a:extLst>
+          </p:cNvPr>
+          <p:cNvPicPr>
+            <a:picLocks noChangeAspect="1" noChangeArrowheads="1"/>
+          </p:cNvPicPr>
+          <p:nvPr/>
+        </p:nvPicPr>
+        <p:blipFill>
+          <a:blip r:embed="rId3">
+            <a:extLst>
+              <a:ext uri="{28A0092B-C50C-407E-A947-70E740481C1C}">
+                <a14:useLocalDpi xmlns:a14="http://schemas.microsoft.com/office/drawing/2010/main" val="0"/>
+              </a:ext>
+            </a:extLst>
+          </a:blip>
+          <a:srcRect/>
+          <a:stretch>
+            <a:fillRect/>
+          </a:stretch>
+        </p:blipFill>
+        <p:spPr bwMode="auto">
+          <a:xfrm>
+            <a:off x="119922" y="6346096"/>
+            <a:ext cx="683614" cy="445109"/>
+          </a:xfrm>
+          <a:prstGeom prst="rect">
+            <a:avLst/>
+          </a:prstGeom>
+          <a:noFill/>
+          <a:extLst>
+            <a:ext uri="{909E8E84-426E-40DD-AFC4-6F175D3DCCD1}">
+              <a14:hiddenFill xmlns:a14="http://schemas.microsoft.com/office/drawing/2010/main">
+                <a:solidFill>
+                  <a:srgbClr val="FFFFFF"/>
+                </a:solidFill>
+              </a14:hiddenFill>
+            </a:ext>
+          </a:extLst>
+        </p:spPr>
+      </p:pic>
+      <p:pic>
+        <p:nvPicPr>
+          <p:cNvPr id="3" name="Picture 4">
+            <a:extLst>
+              <a:ext uri="{FF2B5EF4-FFF2-40B4-BE49-F238E27FC236}">
+                <a16:creationId xmlns:a16="http://schemas.microsoft.com/office/drawing/2014/main" id="{C9663204-9A6C-C5D7-7C9B-AAF5653911D6}"/>
+              </a:ext>
+            </a:extLst>
+          </p:cNvPr>
+          <p:cNvPicPr>
+            <a:picLocks noChangeAspect="1" noChangeArrowheads="1"/>
+          </p:cNvPicPr>
+          <p:nvPr/>
+        </p:nvPicPr>
+        <p:blipFill>
+          <a:blip r:embed="rId4">
+            <a:extLst>
+              <a:ext uri="{28A0092B-C50C-407E-A947-70E740481C1C}">
+                <a14:useLocalDpi xmlns:a14="http://schemas.microsoft.com/office/drawing/2010/main" val="0"/>
+              </a:ext>
+            </a:extLst>
+          </a:blip>
+          <a:srcRect/>
+          <a:stretch>
+            <a:fillRect/>
+          </a:stretch>
+        </p:blipFill>
+        <p:spPr bwMode="auto">
+          <a:xfrm>
+            <a:off x="10802599" y="6212508"/>
+            <a:ext cx="1329440" cy="578697"/>
+          </a:xfrm>
+          <a:prstGeom prst="rect">
+            <a:avLst/>
+          </a:prstGeom>
+          <a:noFill/>
+          <a:extLst>
+            <a:ext uri="{909E8E84-426E-40DD-AFC4-6F175D3DCCD1}">
+              <a14:hiddenFill xmlns:a14="http://schemas.microsoft.com/office/drawing/2010/main">
+                <a:solidFill>
+                  <a:srgbClr val="FFFFFF"/>
+                </a:solidFill>
+              </a14:hiddenFill>
+            </a:ext>
+          </a:extLst>
+        </p:spPr>
+      </p:pic>
+    </p:spTree>
+    <p:extLst>
+      <p:ext uri="{BB962C8B-B14F-4D97-AF65-F5344CB8AC3E}">
+        <p14:creationId xmlns:p14="http://schemas.microsoft.com/office/powerpoint/2010/main" val="1536836101"/>
+      </p:ext>
+    </p:extLst>
+  </p:cSld>
+  <p:clrMapOvr>
+    <a:masterClrMapping/>
+  </p:clrMapOvr>
+  <mc:AlternateContent xmlns:mc="http://schemas.openxmlformats.org/markup-compatibility/2006" xmlns:p159="http://schemas.microsoft.com/office/powerpoint/2015/09/main">
+    <mc:Choice Requires="p159">
+      <p:transition xmlns:p14="http://schemas.microsoft.com/office/powerpoint/2010/main" spd="slow" p14:dur="1250">
+        <p159:morph option="byObject"/>
+      </p:transition>
+    </mc:Choice>
+    <mc:Fallback xmlns="">
+      <p:transition spd="slow">
+        <p:fade/>
+      </p:transition>
+    </mc:Fallback>
+  </mc:AlternateContent>
+</p:sld>
+</file>
+
+<file path=ppt/slides/slide14.xml><?xml version="1.0" encoding="utf-8"?>
+<p:sld xmlns:a="http://schemas.openxmlformats.org/drawingml/2006/main" xmlns:r="http://schemas.openxmlformats.org/officeDocument/2006/relationships" xmlns:p="http://schemas.openxmlformats.org/presentationml/2006/main">
+  <p:cSld>
+    <p:spTree>
+      <p:nvGrpSpPr>
+        <p:cNvPr id="1" name=""/>
+        <p:cNvGrpSpPr/>
+        <p:nvPr/>
+      </p:nvGrpSpPr>
+      <p:grpSpPr>
+        <a:xfrm>
+          <a:off x="0" y="0"/>
+          <a:ext cx="0" cy="0"/>
+          <a:chOff x="0" y="0"/>
+          <a:chExt cx="0" cy="0"/>
+        </a:xfrm>
+      </p:grpSpPr>
+      <p:cxnSp>
+        <p:nvCxnSpPr>
+          <p:cNvPr id="7" name="Conector reto 6">
+            <a:extLst>
+              <a:ext uri="{FF2B5EF4-FFF2-40B4-BE49-F238E27FC236}">
+                <a16:creationId xmlns:a16="http://schemas.microsoft.com/office/drawing/2014/main" id="{280B8309-4572-4E27-8B6F-D29679313292}"/>
+              </a:ext>
+            </a:extLst>
+          </p:cNvPr>
+          <p:cNvCxnSpPr>
+            <a:cxnSpLocks/>
+          </p:cNvCxnSpPr>
+          <p:nvPr/>
+        </p:nvCxnSpPr>
+        <p:spPr>
+          <a:xfrm>
+            <a:off x="-112541" y="970671"/>
+            <a:ext cx="8328073" cy="0"/>
+          </a:xfrm>
+          <a:prstGeom prst="line">
+            <a:avLst/>
+          </a:prstGeom>
+          <a:ln w="38100"/>
+        </p:spPr>
+        <p:style>
+          <a:lnRef idx="1">
+            <a:schemeClr val="accent1"/>
+          </a:lnRef>
+          <a:fillRef idx="0">
+            <a:schemeClr val="accent1"/>
+          </a:fillRef>
+          <a:effectRef idx="0">
+            <a:schemeClr val="accent1"/>
+          </a:effectRef>
+          <a:fontRef idx="minor">
+            <a:schemeClr val="tx1"/>
+          </a:fontRef>
+        </p:style>
+      </p:cxnSp>
+      <p:sp>
+        <p:nvSpPr>
+          <p:cNvPr id="8" name="CaixaDeTexto 7">
+            <a:extLst>
+              <a:ext uri="{FF2B5EF4-FFF2-40B4-BE49-F238E27FC236}">
+                <a16:creationId xmlns:a16="http://schemas.microsoft.com/office/drawing/2014/main" id="{39AE06C5-34BE-4D68-97C3-4C07702C2DF6}"/>
+              </a:ext>
+            </a:extLst>
+          </p:cNvPr>
+          <p:cNvSpPr txBox="1"/>
+          <p:nvPr/>
+        </p:nvSpPr>
+        <p:spPr>
+          <a:xfrm>
+            <a:off x="779259" y="294626"/>
+            <a:ext cx="10633479" cy="523220"/>
+          </a:xfrm>
+          <a:prstGeom prst="rect">
+            <a:avLst/>
+          </a:prstGeom>
+          <a:noFill/>
+        </p:spPr>
+        <p:txBody>
+          <a:bodyPr wrap="square" rtlCol="0">
+            <a:spAutoFit/>
+          </a:bodyPr>
+          <a:lstStyle/>
+          <a:p>
+            <a:r>
+              <a:rPr lang="pt-BR" sz="2800" b="1" dirty="0">
+                <a:solidFill>
+                  <a:srgbClr val="002060"/>
+                </a:solidFill>
+                <a:latin typeface="Cambria" panose="02040503050406030204" pitchFamily="18" charset="0"/>
+                <a:ea typeface="Cambria" panose="02040503050406030204" pitchFamily="18" charset="0"/>
+              </a:rPr>
+              <a:t>Reincidência Criminal: o Efeito Estigma de </a:t>
+            </a:r>
+            <a:r>
+              <a:rPr lang="pt-BR" sz="2800" b="1" dirty="0" err="1">
+                <a:solidFill>
+                  <a:srgbClr val="002060"/>
+                </a:solidFill>
+                <a:latin typeface="Cambria" panose="02040503050406030204" pitchFamily="18" charset="0"/>
+                <a:ea typeface="Cambria" panose="02040503050406030204" pitchFamily="18" charset="0"/>
+              </a:rPr>
+              <a:t>Ex-Presidiários</a:t>
+            </a:r>
+            <a:endParaRPr lang="pt-BR" sz="2800" b="1" dirty="0">
+              <a:solidFill>
+                <a:srgbClr val="002060"/>
+              </a:solidFill>
+              <a:latin typeface="Cambria" panose="02040503050406030204" pitchFamily="18" charset="0"/>
+              <a:ea typeface="Cambria" panose="02040503050406030204" pitchFamily="18" charset="0"/>
+            </a:endParaRPr>
+          </a:p>
+        </p:txBody>
+      </p:sp>
+      <p:sp>
+        <p:nvSpPr>
+          <p:cNvPr id="14" name="CaixaDeTexto 13">
+            <a:extLst>
+              <a:ext uri="{FF2B5EF4-FFF2-40B4-BE49-F238E27FC236}">
+                <a16:creationId xmlns:a16="http://schemas.microsoft.com/office/drawing/2014/main" id="{427DBFEB-81BF-4CC3-A411-FBF43D295C56}"/>
+              </a:ext>
+            </a:extLst>
+          </p:cNvPr>
+          <p:cNvSpPr txBox="1"/>
+          <p:nvPr/>
+        </p:nvSpPr>
+        <p:spPr>
+          <a:xfrm>
+            <a:off x="940904" y="1276323"/>
+            <a:ext cx="10310191" cy="506292"/>
+          </a:xfrm>
+          <a:prstGeom prst="rect">
+            <a:avLst/>
+          </a:prstGeom>
+          <a:noFill/>
+        </p:spPr>
+        <p:txBody>
+          <a:bodyPr wrap="square" rtlCol="0">
+            <a:spAutoFit/>
+          </a:bodyPr>
+          <a:lstStyle/>
+          <a:p>
+            <a:pPr marL="285750" indent="-285750">
+              <a:lnSpc>
+                <a:spcPct val="150000"/>
+              </a:lnSpc>
+              <a:spcAft>
+                <a:spcPts val="110"/>
+              </a:spcAft>
+              <a:buFont typeface="Wingdings" panose="05000000000000000000" pitchFamily="2" charset="2"/>
+              <a:buChar char="Ø"/>
+            </a:pPr>
+            <a:r>
+              <a:rPr lang="pt-BR" sz="2000" b="1" dirty="0"/>
+              <a:t>Noções gerais sobre Estatística. </a:t>
+            </a:r>
+          </a:p>
+        </p:txBody>
+      </p:sp>
+      <p:pic>
+        <p:nvPicPr>
+          <p:cNvPr id="2" name="Picture 2" descr="UFRGS na Serra | Visão de futuro e coragem para inovar">
+            <a:extLst>
+              <a:ext uri="{FF2B5EF4-FFF2-40B4-BE49-F238E27FC236}">
+                <a16:creationId xmlns:a16="http://schemas.microsoft.com/office/drawing/2014/main" id="{567C8E3D-C535-EC50-849C-270CEB4B8A04}"/>
+              </a:ext>
+            </a:extLst>
+          </p:cNvPr>
+          <p:cNvPicPr>
+            <a:picLocks noChangeAspect="1" noChangeArrowheads="1"/>
+          </p:cNvPicPr>
+          <p:nvPr/>
+        </p:nvPicPr>
+        <p:blipFill>
+          <a:blip r:embed="rId3">
+            <a:extLst>
+              <a:ext uri="{28A0092B-C50C-407E-A947-70E740481C1C}">
+                <a14:useLocalDpi xmlns:a14="http://schemas.microsoft.com/office/drawing/2010/main" val="0"/>
+              </a:ext>
+            </a:extLst>
+          </a:blip>
+          <a:srcRect/>
+          <a:stretch>
+            <a:fillRect/>
+          </a:stretch>
+        </p:blipFill>
+        <p:spPr bwMode="auto">
+          <a:xfrm>
+            <a:off x="119922" y="6346096"/>
+            <a:ext cx="683614" cy="445109"/>
+          </a:xfrm>
+          <a:prstGeom prst="rect">
+            <a:avLst/>
+          </a:prstGeom>
+          <a:noFill/>
+          <a:extLst>
+            <a:ext uri="{909E8E84-426E-40DD-AFC4-6F175D3DCCD1}">
+              <a14:hiddenFill xmlns:a14="http://schemas.microsoft.com/office/drawing/2010/main">
+                <a:solidFill>
+                  <a:srgbClr val="FFFFFF"/>
+                </a:solidFill>
+              </a14:hiddenFill>
+            </a:ext>
+          </a:extLst>
+        </p:spPr>
+      </p:pic>
+      <p:pic>
+        <p:nvPicPr>
+          <p:cNvPr id="3" name="Picture 4">
+            <a:extLst>
+              <a:ext uri="{FF2B5EF4-FFF2-40B4-BE49-F238E27FC236}">
+                <a16:creationId xmlns:a16="http://schemas.microsoft.com/office/drawing/2014/main" id="{C9663204-9A6C-C5D7-7C9B-AAF5653911D6}"/>
+              </a:ext>
+            </a:extLst>
+          </p:cNvPr>
+          <p:cNvPicPr>
+            <a:picLocks noChangeAspect="1" noChangeArrowheads="1"/>
+          </p:cNvPicPr>
+          <p:nvPr/>
+        </p:nvPicPr>
+        <p:blipFill>
+          <a:blip r:embed="rId4">
+            <a:extLst>
+              <a:ext uri="{28A0092B-C50C-407E-A947-70E740481C1C}">
+                <a14:useLocalDpi xmlns:a14="http://schemas.microsoft.com/office/drawing/2010/main" val="0"/>
+              </a:ext>
+            </a:extLst>
+          </a:blip>
+          <a:srcRect/>
+          <a:stretch>
+            <a:fillRect/>
+          </a:stretch>
+        </p:blipFill>
+        <p:spPr bwMode="auto">
+          <a:xfrm>
+            <a:off x="10802599" y="6212508"/>
+            <a:ext cx="1329440" cy="578697"/>
+          </a:xfrm>
+          <a:prstGeom prst="rect">
+            <a:avLst/>
+          </a:prstGeom>
+          <a:noFill/>
+          <a:extLst>
+            <a:ext uri="{909E8E84-426E-40DD-AFC4-6F175D3DCCD1}">
+              <a14:hiddenFill xmlns:a14="http://schemas.microsoft.com/office/drawing/2010/main">
+                <a:solidFill>
+                  <a:srgbClr val="FFFFFF"/>
+                </a:solidFill>
+              </a14:hiddenFill>
+            </a:ext>
+          </a:extLst>
+        </p:spPr>
+      </p:pic>
+    </p:spTree>
+    <p:extLst>
+      <p:ext uri="{BB962C8B-B14F-4D97-AF65-F5344CB8AC3E}">
+        <p14:creationId xmlns:p14="http://schemas.microsoft.com/office/powerpoint/2010/main" val="1070033144"/>
+      </p:ext>
+    </p:extLst>
+  </p:cSld>
+  <p:clrMapOvr>
+    <a:masterClrMapping/>
+  </p:clrMapOvr>
+  <mc:AlternateContent xmlns:mc="http://schemas.openxmlformats.org/markup-compatibility/2006" xmlns:p159="http://schemas.microsoft.com/office/powerpoint/2015/09/main">
+    <mc:Choice Requires="p159">
+      <p:transition xmlns:p14="http://schemas.microsoft.com/office/powerpoint/2010/main" spd="slow" p14:dur="1250">
+        <p159:morph option="byObject"/>
+      </p:transition>
+    </mc:Choice>
+    <mc:Fallback xmlns="">
+      <p:transition spd="slow">
+        <p:fade/>
+      </p:transition>
+    </mc:Fallback>
+  </mc:AlternateContent>
+</p:sld>
+</file>
+
+<file path=ppt/slides/slide15.xml><?xml version="1.0" encoding="utf-8"?>
+<p:sld xmlns:a="http://schemas.openxmlformats.org/drawingml/2006/main" xmlns:r="http://schemas.openxmlformats.org/officeDocument/2006/relationships" xmlns:p="http://schemas.openxmlformats.org/presentationml/2006/main">
+  <p:cSld>
+    <p:spTree>
+      <p:nvGrpSpPr>
+        <p:cNvPr id="1" name=""/>
+        <p:cNvGrpSpPr/>
+        <p:nvPr/>
+      </p:nvGrpSpPr>
+      <p:grpSpPr>
+        <a:xfrm>
+          <a:off x="0" y="0"/>
+          <a:ext cx="0" cy="0"/>
+          <a:chOff x="0" y="0"/>
+          <a:chExt cx="0" cy="0"/>
+        </a:xfrm>
+      </p:grpSpPr>
+      <p:cxnSp>
+        <p:nvCxnSpPr>
+          <p:cNvPr id="7" name="Conector reto 6">
+            <a:extLst>
+              <a:ext uri="{FF2B5EF4-FFF2-40B4-BE49-F238E27FC236}">
+                <a16:creationId xmlns:a16="http://schemas.microsoft.com/office/drawing/2014/main" id="{280B8309-4572-4E27-8B6F-D29679313292}"/>
+              </a:ext>
+            </a:extLst>
+          </p:cNvPr>
+          <p:cNvCxnSpPr>
+            <a:cxnSpLocks/>
+          </p:cNvCxnSpPr>
+          <p:nvPr/>
+        </p:nvCxnSpPr>
+        <p:spPr>
+          <a:xfrm>
+            <a:off x="-112541" y="970671"/>
+            <a:ext cx="8328073" cy="0"/>
+          </a:xfrm>
+          <a:prstGeom prst="line">
+            <a:avLst/>
+          </a:prstGeom>
+          <a:ln w="38100"/>
+        </p:spPr>
+        <p:style>
+          <a:lnRef idx="1">
+            <a:schemeClr val="accent1"/>
+          </a:lnRef>
+          <a:fillRef idx="0">
+            <a:schemeClr val="accent1"/>
+          </a:fillRef>
+          <a:effectRef idx="0">
+            <a:schemeClr val="accent1"/>
+          </a:effectRef>
+          <a:fontRef idx="minor">
+            <a:schemeClr val="tx1"/>
+          </a:fontRef>
+        </p:style>
+      </p:cxnSp>
+      <p:sp>
+        <p:nvSpPr>
+          <p:cNvPr id="8" name="CaixaDeTexto 7">
+            <a:extLst>
+              <a:ext uri="{FF2B5EF4-FFF2-40B4-BE49-F238E27FC236}">
+                <a16:creationId xmlns:a16="http://schemas.microsoft.com/office/drawing/2014/main" id="{39AE06C5-34BE-4D68-97C3-4C07702C2DF6}"/>
+              </a:ext>
+            </a:extLst>
+          </p:cNvPr>
+          <p:cNvSpPr txBox="1"/>
+          <p:nvPr/>
+        </p:nvSpPr>
+        <p:spPr>
+          <a:xfrm>
             <a:off x="1103819" y="140678"/>
             <a:ext cx="7815329" cy="646331"/>
           </a:xfrm>
@@ -7693,7 +9960,7 @@
 </p:sld>
 </file>
 
-<file path=ppt/slides/slide11.xml><?xml version="1.0" encoding="utf-8"?>
+<file path=ppt/slides/slide16.xml><?xml version="1.0" encoding="utf-8"?>
 <p:sld xmlns:a="http://schemas.openxmlformats.org/drawingml/2006/main" xmlns:r="http://schemas.openxmlformats.org/officeDocument/2006/relationships" xmlns:p="http://schemas.openxmlformats.org/presentationml/2006/main">
   <p:cSld>
     <p:spTree>
@@ -8708,7 +10975,7 @@
     </p:spTree>
     <p:extLst>
       <p:ext uri="{BB962C8B-B14F-4D97-AF65-F5344CB8AC3E}">
-        <p14:creationId xmlns:p14="http://schemas.microsoft.com/office/powerpoint/2010/main" val="1465096313"/>
+        <p14:creationId xmlns:p14="http://schemas.microsoft.com/office/powerpoint/2010/main" val="587472357"/>
       </p:ext>
     </p:extLst>
   </p:cSld>
@@ -10101,8 +12368,8 @@
         </p:nvSpPr>
         <p:spPr>
           <a:xfrm>
-            <a:off x="940904" y="1276323"/>
-            <a:ext cx="10310191" cy="4763868"/>
+            <a:off x="940903" y="1573800"/>
+            <a:ext cx="10310191" cy="4503797"/>
           </a:xfrm>
           <a:prstGeom prst="rect">
             <a:avLst/>
@@ -10116,9 +12383,6 @@
           <a:lstStyle/>
           <a:p>
             <a:pPr marL="285750" indent="-285750">
-              <a:lnSpc>
-                <a:spcPct val="150000"/>
-              </a:lnSpc>
               <a:spcAft>
                 <a:spcPts val="110"/>
               </a:spcAft>
@@ -10127,14 +12391,21 @@
             </a:pPr>
             <a:r>
               <a:rPr lang="pt-BR" sz="2000" b="1" dirty="0"/>
-              <a:t>Descritivas</a:t>
+              <a:t>Porque muitas analises focam na taxa de homicídio?</a:t>
             </a:r>
           </a:p>
           <a:p>
             <a:pPr marL="285750" indent="-285750">
-              <a:lnSpc>
-                <a:spcPct val="150000"/>
-              </a:lnSpc>
+              <a:spcAft>
+                <a:spcPts val="110"/>
+              </a:spcAft>
+              <a:buFont typeface="Wingdings" panose="05000000000000000000" pitchFamily="2" charset="2"/>
+              <a:buChar char="Ø"/>
+            </a:pPr>
+            <a:endParaRPr lang="pt-BR" sz="2000" b="1" dirty="0"/>
+          </a:p>
+          <a:p>
+            <a:pPr marL="285750" indent="-285750">
               <a:spcAft>
                 <a:spcPts val="110"/>
               </a:spcAft>
@@ -10143,14 +12414,32 @@
             </a:pPr>
             <a:r>
               <a:rPr lang="pt-BR" sz="2000" b="1" dirty="0"/>
-              <a:t>Taxas em Municípios pequenos</a:t>
+              <a:t>Porque possui </a:t>
             </a:r>
+            <a:r>
+              <a:rPr lang="pt-BR" sz="2000" b="1" u="none" strike="noStrike" dirty="0">
+                <a:effectLst/>
+                <a:latin typeface="Google Sans"/>
+              </a:rPr>
+              <a:t>menor margem de subnotificação</a:t>
+            </a:r>
+            <a:r>
+              <a:rPr lang="pt-BR" sz="2000" b="1" dirty="0"/>
+              <a:t> e maior confiabilidade estatística do que outros crimes</a:t>
+            </a:r>
           </a:p>
           <a:p>
             <a:pPr marL="285750" indent="-285750">
-              <a:lnSpc>
-                <a:spcPct val="150000"/>
-              </a:lnSpc>
+              <a:spcAft>
+                <a:spcPts val="110"/>
+              </a:spcAft>
+              <a:buFont typeface="Wingdings" panose="05000000000000000000" pitchFamily="2" charset="2"/>
+              <a:buChar char="Ø"/>
+            </a:pPr>
+            <a:endParaRPr lang="pt-BR" sz="2000" b="1" dirty="0"/>
+          </a:p>
+          <a:p>
+            <a:pPr marL="285750" indent="-285750">
               <a:spcAft>
                 <a:spcPts val="110"/>
               </a:spcAft>
@@ -10159,14 +12448,33 @@
             </a:pPr>
             <a:r>
               <a:rPr lang="pt-BR" sz="2000" b="1" dirty="0"/>
-              <a:t>Autocorrelação espacial</a:t>
+              <a:t>Especialistas em segurança pública explicam que nem todo furto, roubo ou ameaça é registrado em delegacias, mas um assassinato quase sempre deixa um corpo e gera um registro oficial em sistemas de saúde e de polícia (Fonte: </a:t>
             </a:r>
+            <a:r>
+              <a:rPr lang="pt-BR" sz="2000" b="1" u="none" strike="noStrike" dirty="0">
+                <a:effectLst/>
+                <a:latin typeface="Google Sans"/>
+                <a:hlinkClick r:id="rId5"/>
+              </a:rPr>
+              <a:t>Fórum Brasileiro de Segurança Pública</a:t>
+            </a:r>
+            <a:r>
+              <a:rPr lang="pt-BR" sz="2000" b="1" dirty="0"/>
+              <a:t>).</a:t>
+            </a:r>
           </a:p>
           <a:p>
             <a:pPr marL="285750" indent="-285750">
-              <a:lnSpc>
-                <a:spcPct val="150000"/>
-              </a:lnSpc>
+              <a:spcAft>
+                <a:spcPts val="110"/>
+              </a:spcAft>
+              <a:buFont typeface="Wingdings" panose="05000000000000000000" pitchFamily="2" charset="2"/>
+              <a:buChar char="Ø"/>
+            </a:pPr>
+            <a:endParaRPr lang="pt-BR" sz="2000" b="1" dirty="0"/>
+          </a:p>
+          <a:p>
+            <a:pPr marL="285750" indent="-285750">
               <a:spcAft>
                 <a:spcPts val="110"/>
               </a:spcAft>
@@ -10175,78 +12483,21 @@
             </a:pPr>
             <a:r>
               <a:rPr lang="pt-BR" sz="2000" b="1" dirty="0"/>
-              <a:t>Cadeias de Markov</a:t>
+              <a:t>Taxa de Homicídio que a ONU considerada epidemia: 10 por 100.000</a:t>
             </a:r>
           </a:p>
           <a:p>
             <a:pPr marL="285750" indent="-285750">
-              <a:lnSpc>
-                <a:spcPct val="150000"/>
-              </a:lnSpc>
               <a:spcAft>
                 <a:spcPts val="110"/>
               </a:spcAft>
               <a:buFont typeface="Wingdings" panose="05000000000000000000" pitchFamily="2" charset="2"/>
               <a:buChar char="Ø"/>
             </a:pPr>
-            <a:r>
-              <a:rPr lang="pt-BR" sz="2000" b="1" dirty="0"/>
-              <a:t>Roubo de Veículos</a:t>
-            </a:r>
+            <a:endParaRPr lang="pt-BR" sz="2000" b="1" dirty="0"/>
           </a:p>
           <a:p>
             <a:pPr marL="285750" indent="-285750">
-              <a:lnSpc>
-                <a:spcPct val="150000"/>
-              </a:lnSpc>
-              <a:spcAft>
-                <a:spcPts val="110"/>
-              </a:spcAft>
-              <a:buFont typeface="Wingdings" panose="05000000000000000000" pitchFamily="2" charset="2"/>
-              <a:buChar char="Ø"/>
-            </a:pPr>
-            <a:r>
-              <a:rPr lang="pt-BR" sz="2000" b="1" dirty="0"/>
-              <a:t>Furto</a:t>
-            </a:r>
-          </a:p>
-          <a:p>
-            <a:pPr marL="285750" indent="-285750">
-              <a:lnSpc>
-                <a:spcPct val="150000"/>
-              </a:lnSpc>
-              <a:spcAft>
-                <a:spcPts val="110"/>
-              </a:spcAft>
-              <a:buFont typeface="Wingdings" panose="05000000000000000000" pitchFamily="2" charset="2"/>
-              <a:buChar char="Ø"/>
-            </a:pPr>
-            <a:r>
-              <a:rPr lang="pt-BR" sz="2000" b="1" dirty="0"/>
-              <a:t>Homicídio</a:t>
-            </a:r>
-          </a:p>
-          <a:p>
-            <a:pPr marL="285750" indent="-285750">
-              <a:lnSpc>
-                <a:spcPct val="150000"/>
-              </a:lnSpc>
-              <a:spcAft>
-                <a:spcPts val="110"/>
-              </a:spcAft>
-              <a:buFont typeface="Wingdings" panose="05000000000000000000" pitchFamily="2" charset="2"/>
-              <a:buChar char="Ø"/>
-            </a:pPr>
-            <a:r>
-              <a:rPr lang="pt-BR" sz="2000" b="1" dirty="0"/>
-              <a:t>Taxa de Homicídio ONU: 10 por 100.000</a:t>
-            </a:r>
-          </a:p>
-          <a:p>
-            <a:pPr marL="285750" indent="-285750">
-              <a:lnSpc>
-                <a:spcPct val="150000"/>
-              </a:lnSpc>
               <a:spcAft>
                 <a:spcPts val="110"/>
               </a:spcAft>
@@ -10261,7 +12512,7 @@
               <a:t>Média Global:</a:t>
             </a:r>
             <a:r>
-              <a:rPr lang="pt-BR" sz="2000" dirty="0"/>
+              <a:rPr lang="pt-BR" sz="2000" b="1" dirty="0"/>
               <a:t> A taxa média no mundo gira em torno de </a:t>
             </a:r>
             <a:r>
@@ -10272,17 +12523,16 @@
               <a:t>5,8 homicídios por 100 mil habitantes</a:t>
             </a:r>
             <a:r>
-              <a:rPr lang="pt-BR" sz="2000" dirty="0"/>
+              <a:rPr lang="pt-BR" sz="2000" b="1" dirty="0"/>
               <a:t>.</a:t>
             </a:r>
-            <a:endParaRPr lang="pt-BR" sz="2000" b="1" dirty="0"/>
           </a:p>
         </p:txBody>
       </p:sp>
     </p:spTree>
     <p:extLst>
       <p:ext uri="{BB962C8B-B14F-4D97-AF65-F5344CB8AC3E}">
-        <p14:creationId xmlns:p14="http://schemas.microsoft.com/office/powerpoint/2010/main" val="204840894"/>
+        <p14:creationId xmlns:p14="http://schemas.microsoft.com/office/powerpoint/2010/main" val="2697758197"/>
       </p:ext>
     </p:extLst>
   </p:cSld>
@@ -10495,12 +12745,42 @@
           </a:extLst>
         </p:spPr>
       </p:pic>
-      <p:sp>
-        <p:nvSpPr>
-          <p:cNvPr id="4" name="CaixaDeTexto 3">
-            <a:extLst>
-              <a:ext uri="{FF2B5EF4-FFF2-40B4-BE49-F238E27FC236}">
-                <a16:creationId xmlns:a16="http://schemas.microsoft.com/office/drawing/2014/main" id="{F9B44222-0FEB-DD8A-E65A-F10683C06A0F}"/>
+      <p:pic>
+        <p:nvPicPr>
+          <p:cNvPr id="6" name="Imagem 5">
+            <a:extLst>
+              <a:ext uri="{FF2B5EF4-FFF2-40B4-BE49-F238E27FC236}">
+                <a16:creationId xmlns:a16="http://schemas.microsoft.com/office/drawing/2014/main" id="{C7CB915E-012D-A5FC-3321-870B91EF401C}"/>
+              </a:ext>
+            </a:extLst>
+          </p:cNvPr>
+          <p:cNvPicPr>
+            <a:picLocks noChangeAspect="1"/>
+          </p:cNvPicPr>
+          <p:nvPr/>
+        </p:nvPicPr>
+        <p:blipFill>
+          <a:blip r:embed="rId5"/>
+          <a:stretch>
+            <a:fillRect/>
+          </a:stretch>
+        </p:blipFill>
+        <p:spPr>
+          <a:xfrm>
+            <a:off x="1398216" y="1693895"/>
+            <a:ext cx="9404383" cy="4382314"/>
+          </a:xfrm>
+          <a:prstGeom prst="rect">
+            <a:avLst/>
+          </a:prstGeom>
+        </p:spPr>
+      </p:pic>
+      <p:sp>
+        <p:nvSpPr>
+          <p:cNvPr id="10" name="CaixaDeTexto 9">
+            <a:extLst>
+              <a:ext uri="{FF2B5EF4-FFF2-40B4-BE49-F238E27FC236}">
+                <a16:creationId xmlns:a16="http://schemas.microsoft.com/office/drawing/2014/main" id="{439966E0-F76D-F319-6141-19CB38DC8D8B}"/>
               </a:ext>
             </a:extLst>
           </p:cNvPr>
@@ -10509,8 +12789,8 @@
         </p:nvSpPr>
         <p:spPr>
           <a:xfrm>
-            <a:off x="940904" y="1276323"/>
-            <a:ext cx="10310191" cy="4763868"/>
+            <a:off x="5039192" y="2243955"/>
+            <a:ext cx="3492708" cy="646331"/>
           </a:xfrm>
           <a:prstGeom prst="rect">
             <a:avLst/>
@@ -10523,174 +12803,64 @@
           </a:bodyPr>
           <a:lstStyle/>
           <a:p>
-            <a:pPr marL="285750" indent="-285750">
-              <a:lnSpc>
-                <a:spcPct val="150000"/>
-              </a:lnSpc>
-              <a:spcAft>
-                <a:spcPts val="110"/>
-              </a:spcAft>
-              <a:buFont typeface="Wingdings" panose="05000000000000000000" pitchFamily="2" charset="2"/>
-              <a:buChar char="Ø"/>
-            </a:pPr>
+            <a:pPr algn="ctr"/>
             <a:r>
-              <a:rPr lang="pt-BR" sz="2000" b="1" dirty="0"/>
-              <a:t>Descritivas</a:t>
+              <a:rPr lang="pt-BR" b="1" dirty="0"/>
+              <a:t>2017 também foi ano de inflexão para outros crimes</a:t>
             </a:r>
           </a:p>
-          <a:p>
-            <a:pPr marL="285750" indent="-285750">
-              <a:lnSpc>
-                <a:spcPct val="150000"/>
-              </a:lnSpc>
-              <a:spcAft>
-                <a:spcPts val="110"/>
-              </a:spcAft>
-              <a:buFont typeface="Wingdings" panose="05000000000000000000" pitchFamily="2" charset="2"/>
-              <a:buChar char="Ø"/>
-            </a:pPr>
-            <a:r>
-              <a:rPr lang="pt-BR" sz="2000" b="1" dirty="0"/>
-              <a:t>Taxas em Municípios pequenos</a:t>
-            </a:r>
-          </a:p>
-          <a:p>
-            <a:pPr marL="285750" indent="-285750">
-              <a:lnSpc>
-                <a:spcPct val="150000"/>
-              </a:lnSpc>
-              <a:spcAft>
-                <a:spcPts val="110"/>
-              </a:spcAft>
-              <a:buFont typeface="Wingdings" panose="05000000000000000000" pitchFamily="2" charset="2"/>
-              <a:buChar char="Ø"/>
-            </a:pPr>
-            <a:r>
-              <a:rPr lang="pt-BR" sz="2000" b="1" dirty="0"/>
-              <a:t>Autocorrelação espacial</a:t>
-            </a:r>
-          </a:p>
-          <a:p>
-            <a:pPr marL="285750" indent="-285750">
-              <a:lnSpc>
-                <a:spcPct val="150000"/>
-              </a:lnSpc>
-              <a:spcAft>
-                <a:spcPts val="110"/>
-              </a:spcAft>
-              <a:buFont typeface="Wingdings" panose="05000000000000000000" pitchFamily="2" charset="2"/>
-              <a:buChar char="Ø"/>
-            </a:pPr>
-            <a:r>
-              <a:rPr lang="pt-BR" sz="2000" b="1" dirty="0"/>
-              <a:t>Cadeias de Markov</a:t>
-            </a:r>
-          </a:p>
-          <a:p>
-            <a:pPr marL="285750" indent="-285750">
-              <a:lnSpc>
-                <a:spcPct val="150000"/>
-              </a:lnSpc>
-              <a:spcAft>
-                <a:spcPts val="110"/>
-              </a:spcAft>
-              <a:buFont typeface="Wingdings" panose="05000000000000000000" pitchFamily="2" charset="2"/>
-              <a:buChar char="Ø"/>
-            </a:pPr>
-            <a:r>
-              <a:rPr lang="pt-BR" sz="2000" b="1" dirty="0"/>
-              <a:t>Roubo de Veículos</a:t>
-            </a:r>
-          </a:p>
-          <a:p>
-            <a:pPr marL="285750" indent="-285750">
-              <a:lnSpc>
-                <a:spcPct val="150000"/>
-              </a:lnSpc>
-              <a:spcAft>
-                <a:spcPts val="110"/>
-              </a:spcAft>
-              <a:buFont typeface="Wingdings" panose="05000000000000000000" pitchFamily="2" charset="2"/>
-              <a:buChar char="Ø"/>
-            </a:pPr>
-            <a:r>
-              <a:rPr lang="pt-BR" sz="2000" b="1" dirty="0"/>
-              <a:t>Furto</a:t>
-            </a:r>
-          </a:p>
-          <a:p>
-            <a:pPr marL="285750" indent="-285750">
-              <a:lnSpc>
-                <a:spcPct val="150000"/>
-              </a:lnSpc>
-              <a:spcAft>
-                <a:spcPts val="110"/>
-              </a:spcAft>
-              <a:buFont typeface="Wingdings" panose="05000000000000000000" pitchFamily="2" charset="2"/>
-              <a:buChar char="Ø"/>
-            </a:pPr>
-            <a:r>
-              <a:rPr lang="pt-BR" sz="2000" b="1" dirty="0"/>
-              <a:t>Homicídio</a:t>
-            </a:r>
-          </a:p>
-          <a:p>
-            <a:pPr marL="285750" indent="-285750">
-              <a:lnSpc>
-                <a:spcPct val="150000"/>
-              </a:lnSpc>
-              <a:spcAft>
-                <a:spcPts val="110"/>
-              </a:spcAft>
-              <a:buFont typeface="Wingdings" panose="05000000000000000000" pitchFamily="2" charset="2"/>
-              <a:buChar char="Ø"/>
-            </a:pPr>
-            <a:r>
-              <a:rPr lang="pt-BR" sz="2000" b="1" dirty="0"/>
-              <a:t>Taxa de Homicídio ONU: 10 por 100.000</a:t>
-            </a:r>
-          </a:p>
-          <a:p>
-            <a:pPr marL="285750" indent="-285750">
-              <a:lnSpc>
-                <a:spcPct val="150000"/>
-              </a:lnSpc>
-              <a:spcAft>
-                <a:spcPts val="110"/>
-              </a:spcAft>
-              <a:buFont typeface="Wingdings" panose="05000000000000000000" pitchFamily="2" charset="2"/>
-              <a:buChar char="Ø"/>
-            </a:pPr>
-            <a:r>
-              <a:rPr lang="pt-BR" sz="2000" b="1" u="none" strike="noStrike" dirty="0">
-                <a:effectLst/>
-                <a:latin typeface="Google Sans"/>
-              </a:rPr>
-              <a:t>Média Global:</a:t>
-            </a:r>
-            <a:r>
-              <a:rPr lang="pt-BR" sz="2000" dirty="0"/>
-              <a:t> A taxa média no mundo gira em torno de </a:t>
-            </a:r>
-            <a:r>
-              <a:rPr lang="pt-BR" sz="2000" b="1" u="none" strike="noStrike" dirty="0">
-                <a:effectLst/>
-                <a:latin typeface="Google Sans"/>
-              </a:rPr>
-              <a:t>5,8 homicídios por 100 mil habitantes</a:t>
-            </a:r>
-            <a:r>
-              <a:rPr lang="pt-BR" sz="2000" dirty="0"/>
-              <a:t>.</a:t>
-            </a:r>
-            <a:endParaRPr lang="pt-BR" sz="2000" b="1" dirty="0"/>
+        </p:txBody>
+      </p:sp>
+      <p:sp>
+        <p:nvSpPr>
+          <p:cNvPr id="14" name="Seta: para a Direita 13">
+            <a:extLst>
+              <a:ext uri="{FF2B5EF4-FFF2-40B4-BE49-F238E27FC236}">
+                <a16:creationId xmlns:a16="http://schemas.microsoft.com/office/drawing/2014/main" id="{09C2AF41-9EBC-A93B-F400-326DED611B2C}"/>
+              </a:ext>
+            </a:extLst>
+          </p:cNvPr>
+          <p:cNvSpPr/>
+          <p:nvPr/>
+        </p:nvSpPr>
+        <p:spPr>
+          <a:xfrm rot="5400000">
+            <a:off x="6387845" y="3011930"/>
+            <a:ext cx="435637" cy="359764"/>
+          </a:xfrm>
+          <a:prstGeom prst="rightArrow">
+            <a:avLst/>
+          </a:prstGeom>
+        </p:spPr>
+        <p:style>
+          <a:lnRef idx="2">
+            <a:schemeClr val="accent1">
+              <a:shade val="15000"/>
+            </a:schemeClr>
+          </a:lnRef>
+          <a:fillRef idx="1">
+            <a:schemeClr val="accent1"/>
+          </a:fillRef>
+          <a:effectRef idx="0">
+            <a:schemeClr val="accent1"/>
+          </a:effectRef>
+          <a:fontRef idx="minor">
+            <a:schemeClr val="lt1"/>
+          </a:fontRef>
+        </p:style>
+        <p:txBody>
+          <a:bodyPr rtlCol="0" anchor="ctr"/>
+          <a:lstStyle/>
+          <a:p>
+            <a:pPr algn="ctr"/>
+            <a:endParaRPr lang="pt-BR"/>
           </a:p>
         </p:txBody>
       </p:sp>
     </p:spTree>
     <p:extLst>
       <p:ext uri="{BB962C8B-B14F-4D97-AF65-F5344CB8AC3E}">
-        <p14:creationId xmlns:p14="http://schemas.microsoft.com/office/powerpoint/2010/main" val="1600642753"/>
+        <p14:creationId xmlns:p14="http://schemas.microsoft.com/office/powerpoint/2010/main" val="1268954086"/>
       </p:ext>
     </p:extLst>
   </p:cSld>
@@ -10709,6 +12879,220 @@
       </p:transition>
     </mc:Fallback>
   </mc:AlternateContent>
+  <p:timing>
+    <p:tnLst>
+      <p:par>
+        <p:cTn id="1" dur="indefinite" restart="never" nodeType="tmRoot">
+          <p:childTnLst>
+            <p:seq concurrent="1" nextAc="seek">
+              <p:cTn id="2" dur="indefinite" nodeType="mainSeq">
+                <p:childTnLst>
+                  <p:par>
+                    <p:cTn id="3" fill="hold">
+                      <p:stCondLst>
+                        <p:cond delay="indefinite"/>
+                      </p:stCondLst>
+                      <p:childTnLst>
+                        <p:par>
+                          <p:cTn id="4" fill="hold">
+                            <p:stCondLst>
+                              <p:cond delay="0"/>
+                            </p:stCondLst>
+                            <p:childTnLst>
+                              <p:par>
+                                <p:cTn id="5" presetID="42" presetClass="entr" presetSubtype="0" fill="hold" grpId="0" nodeType="clickEffect">
+                                  <p:stCondLst>
+                                    <p:cond delay="0"/>
+                                  </p:stCondLst>
+                                  <p:childTnLst>
+                                    <p:set>
+                                      <p:cBhvr>
+                                        <p:cTn id="6" dur="1" fill="hold">
+                                          <p:stCondLst>
+                                            <p:cond delay="0"/>
+                                          </p:stCondLst>
+                                        </p:cTn>
+                                        <p:tgtEl>
+                                          <p:spTgt spid="14"/>
+                                        </p:tgtEl>
+                                        <p:attrNameLst>
+                                          <p:attrName>style.visibility</p:attrName>
+                                        </p:attrNameLst>
+                                      </p:cBhvr>
+                                      <p:to>
+                                        <p:strVal val="visible"/>
+                                      </p:to>
+                                    </p:set>
+                                    <p:animEffect transition="in" filter="fade">
+                                      <p:cBhvr>
+                                        <p:cTn id="7" dur="1000"/>
+                                        <p:tgtEl>
+                                          <p:spTgt spid="14"/>
+                                        </p:tgtEl>
+                                      </p:cBhvr>
+                                    </p:animEffect>
+                                    <p:anim calcmode="lin" valueType="num">
+                                      <p:cBhvr>
+                                        <p:cTn id="8" dur="1000" fill="hold"/>
+                                        <p:tgtEl>
+                                          <p:spTgt spid="14"/>
+                                        </p:tgtEl>
+                                        <p:attrNameLst>
+                                          <p:attrName>ppt_x</p:attrName>
+                                        </p:attrNameLst>
+                                      </p:cBhvr>
+                                      <p:tavLst>
+                                        <p:tav tm="0">
+                                          <p:val>
+                                            <p:strVal val="#ppt_x"/>
+                                          </p:val>
+                                        </p:tav>
+                                        <p:tav tm="100000">
+                                          <p:val>
+                                            <p:strVal val="#ppt_x"/>
+                                          </p:val>
+                                        </p:tav>
+                                      </p:tavLst>
+                                    </p:anim>
+                                    <p:anim calcmode="lin" valueType="num">
+                                      <p:cBhvr>
+                                        <p:cTn id="9" dur="1000" fill="hold"/>
+                                        <p:tgtEl>
+                                          <p:spTgt spid="14"/>
+                                        </p:tgtEl>
+                                        <p:attrNameLst>
+                                          <p:attrName>ppt_y</p:attrName>
+                                        </p:attrNameLst>
+                                      </p:cBhvr>
+                                      <p:tavLst>
+                                        <p:tav tm="0">
+                                          <p:val>
+                                            <p:strVal val="#ppt_y+.1"/>
+                                          </p:val>
+                                        </p:tav>
+                                        <p:tav tm="100000">
+                                          <p:val>
+                                            <p:strVal val="#ppt_y"/>
+                                          </p:val>
+                                        </p:tav>
+                                      </p:tavLst>
+                                    </p:anim>
+                                  </p:childTnLst>
+                                </p:cTn>
+                              </p:par>
+                              <p:par>
+                                <p:cTn id="10" presetID="42" presetClass="entr" presetSubtype="0" fill="hold" grpId="0" nodeType="withEffect">
+                                  <p:stCondLst>
+                                    <p:cond delay="0"/>
+                                  </p:stCondLst>
+                                  <p:childTnLst>
+                                    <p:set>
+                                      <p:cBhvr>
+                                        <p:cTn id="11" dur="1" fill="hold">
+                                          <p:stCondLst>
+                                            <p:cond delay="0"/>
+                                          </p:stCondLst>
+                                        </p:cTn>
+                                        <p:tgtEl>
+                                          <p:spTgt spid="10"/>
+                                        </p:tgtEl>
+                                        <p:attrNameLst>
+                                          <p:attrName>style.visibility</p:attrName>
+                                        </p:attrNameLst>
+                                      </p:cBhvr>
+                                      <p:to>
+                                        <p:strVal val="visible"/>
+                                      </p:to>
+                                    </p:set>
+                                    <p:animEffect transition="in" filter="fade">
+                                      <p:cBhvr>
+                                        <p:cTn id="12" dur="1000"/>
+                                        <p:tgtEl>
+                                          <p:spTgt spid="10"/>
+                                        </p:tgtEl>
+                                      </p:cBhvr>
+                                    </p:animEffect>
+                                    <p:anim calcmode="lin" valueType="num">
+                                      <p:cBhvr>
+                                        <p:cTn id="13" dur="1000" fill="hold"/>
+                                        <p:tgtEl>
+                                          <p:spTgt spid="10"/>
+                                        </p:tgtEl>
+                                        <p:attrNameLst>
+                                          <p:attrName>ppt_x</p:attrName>
+                                        </p:attrNameLst>
+                                      </p:cBhvr>
+                                      <p:tavLst>
+                                        <p:tav tm="0">
+                                          <p:val>
+                                            <p:strVal val="#ppt_x"/>
+                                          </p:val>
+                                        </p:tav>
+                                        <p:tav tm="100000">
+                                          <p:val>
+                                            <p:strVal val="#ppt_x"/>
+                                          </p:val>
+                                        </p:tav>
+                                      </p:tavLst>
+                                    </p:anim>
+                                    <p:anim calcmode="lin" valueType="num">
+                                      <p:cBhvr>
+                                        <p:cTn id="14" dur="1000" fill="hold"/>
+                                        <p:tgtEl>
+                                          <p:spTgt spid="10"/>
+                                        </p:tgtEl>
+                                        <p:attrNameLst>
+                                          <p:attrName>ppt_y</p:attrName>
+                                        </p:attrNameLst>
+                                      </p:cBhvr>
+                                      <p:tavLst>
+                                        <p:tav tm="0">
+                                          <p:val>
+                                            <p:strVal val="#ppt_y+.1"/>
+                                          </p:val>
+                                        </p:tav>
+                                        <p:tav tm="100000">
+                                          <p:val>
+                                            <p:strVal val="#ppt_y"/>
+                                          </p:val>
+                                        </p:tav>
+                                      </p:tavLst>
+                                    </p:anim>
+                                  </p:childTnLst>
+                                </p:cTn>
+                              </p:par>
+                            </p:childTnLst>
+                          </p:cTn>
+                        </p:par>
+                      </p:childTnLst>
+                    </p:cTn>
+                  </p:par>
+                </p:childTnLst>
+              </p:cTn>
+              <p:prevCondLst>
+                <p:cond evt="onPrev" delay="0">
+                  <p:tgtEl>
+                    <p:sldTgt/>
+                  </p:tgtEl>
+                </p:cond>
+              </p:prevCondLst>
+              <p:nextCondLst>
+                <p:cond evt="onNext" delay="0">
+                  <p:tgtEl>
+                    <p:sldTgt/>
+                  </p:tgtEl>
+                </p:cond>
+              </p:nextCondLst>
+            </p:seq>
+          </p:childTnLst>
+        </p:cTn>
+      </p:par>
+    </p:tnLst>
+    <p:bldLst>
+      <p:bldP spid="10" grpId="0"/>
+      <p:bldP spid="14" grpId="0" animBg="1"/>
+    </p:bldLst>
+  </p:timing>
 </p:sld>
 </file>
 
@@ -10782,8 +13166,8 @@
         </p:nvSpPr>
         <p:spPr>
           <a:xfrm>
-            <a:off x="1103819" y="140678"/>
-            <a:ext cx="7815329" cy="646331"/>
+            <a:off x="249836" y="200638"/>
+            <a:ext cx="11692327" cy="584775"/>
           </a:xfrm>
           <a:prstGeom prst="rect">
             <a:avLst/>
@@ -10797,59 +13181,14 @@
           <a:lstStyle/>
           <a:p>
             <a:r>
-              <a:rPr lang="pt-BR" sz="3600" b="1" dirty="0">
+              <a:rPr lang="pt-BR" sz="3200" b="1" dirty="0">
                 <a:solidFill>
                   <a:srgbClr val="002060"/>
                 </a:solidFill>
                 <a:latin typeface="Cambria" panose="02040503050406030204" pitchFamily="18" charset="0"/>
                 <a:ea typeface="Cambria" panose="02040503050406030204" pitchFamily="18" charset="0"/>
               </a:rPr>
-              <a:t>Armas x Criminalidade</a:t>
-            </a:r>
-          </a:p>
-        </p:txBody>
-      </p:sp>
-      <p:sp>
-        <p:nvSpPr>
-          <p:cNvPr id="14" name="CaixaDeTexto 13">
-            <a:extLst>
-              <a:ext uri="{FF2B5EF4-FFF2-40B4-BE49-F238E27FC236}">
-                <a16:creationId xmlns:a16="http://schemas.microsoft.com/office/drawing/2014/main" id="{427DBFEB-81BF-4CC3-A411-FBF43D295C56}"/>
-              </a:ext>
-            </a:extLst>
-          </p:cNvPr>
-          <p:cNvSpPr txBox="1"/>
-          <p:nvPr/>
-        </p:nvSpPr>
-        <p:spPr>
-          <a:xfrm>
-            <a:off x="940904" y="1276323"/>
-            <a:ext cx="10310191" cy="506292"/>
-          </a:xfrm>
-          <a:prstGeom prst="rect">
-            <a:avLst/>
-          </a:prstGeom>
-          <a:noFill/>
-        </p:spPr>
-        <p:txBody>
-          <a:bodyPr wrap="square" rtlCol="0">
-            <a:spAutoFit/>
-          </a:bodyPr>
-          <a:lstStyle/>
-          <a:p>
-            <a:pPr marL="285750" indent="-285750">
-              <a:lnSpc>
-                <a:spcPct val="150000"/>
-              </a:lnSpc>
-              <a:spcAft>
-                <a:spcPts val="110"/>
-              </a:spcAft>
-              <a:buFont typeface="Wingdings" panose="05000000000000000000" pitchFamily="2" charset="2"/>
-              <a:buChar char="Ø"/>
-            </a:pPr>
-            <a:r>
-              <a:rPr lang="pt-BR" sz="2000" b="1" dirty="0"/>
-              <a:t>Noções gerais sobre Estatística. </a:t>
+              <a:t>Panorama RS à Luz dos Dados públicos disponíveis da SSP-RS</a:t>
             </a:r>
           </a:p>
         </p:txBody>
@@ -10951,7 +13290,7 @@
     </p:spTree>
     <p:extLst>
       <p:ext uri="{BB962C8B-B14F-4D97-AF65-F5344CB8AC3E}">
-        <p14:creationId xmlns:p14="http://schemas.microsoft.com/office/powerpoint/2010/main" val="3554767980"/>
+        <p14:creationId xmlns:p14="http://schemas.microsoft.com/office/powerpoint/2010/main" val="3832149468"/>
       </p:ext>
     </p:extLst>
   </p:cSld>
@@ -11043,8 +13382,8 @@
         </p:nvSpPr>
         <p:spPr>
           <a:xfrm>
-            <a:off x="1103819" y="140678"/>
-            <a:ext cx="7815329" cy="646331"/>
+            <a:off x="249836" y="200638"/>
+            <a:ext cx="11692327" cy="584775"/>
           </a:xfrm>
           <a:prstGeom prst="rect">
             <a:avLst/>
@@ -11058,59 +13397,14 @@
           <a:lstStyle/>
           <a:p>
             <a:r>
-              <a:rPr lang="pt-BR" sz="3600" b="1" dirty="0">
+              <a:rPr lang="pt-BR" sz="3200" b="1" dirty="0">
                 <a:solidFill>
                   <a:srgbClr val="002060"/>
                 </a:solidFill>
                 <a:latin typeface="Cambria" panose="02040503050406030204" pitchFamily="18" charset="0"/>
                 <a:ea typeface="Cambria" panose="02040503050406030204" pitchFamily="18" charset="0"/>
               </a:rPr>
-              <a:t>Luz x Criminalidade</a:t>
-            </a:r>
-          </a:p>
-        </p:txBody>
-      </p:sp>
-      <p:sp>
-        <p:nvSpPr>
-          <p:cNvPr id="14" name="CaixaDeTexto 13">
-            <a:extLst>
-              <a:ext uri="{FF2B5EF4-FFF2-40B4-BE49-F238E27FC236}">
-                <a16:creationId xmlns:a16="http://schemas.microsoft.com/office/drawing/2014/main" id="{427DBFEB-81BF-4CC3-A411-FBF43D295C56}"/>
-              </a:ext>
-            </a:extLst>
-          </p:cNvPr>
-          <p:cNvSpPr txBox="1"/>
-          <p:nvPr/>
-        </p:nvSpPr>
-        <p:spPr>
-          <a:xfrm>
-            <a:off x="940904" y="1276323"/>
-            <a:ext cx="10310191" cy="506292"/>
-          </a:xfrm>
-          <a:prstGeom prst="rect">
-            <a:avLst/>
-          </a:prstGeom>
-          <a:noFill/>
-        </p:spPr>
-        <p:txBody>
-          <a:bodyPr wrap="square" rtlCol="0">
-            <a:spAutoFit/>
-          </a:bodyPr>
-          <a:lstStyle/>
-          <a:p>
-            <a:pPr marL="285750" indent="-285750">
-              <a:lnSpc>
-                <a:spcPct val="150000"/>
-              </a:lnSpc>
-              <a:spcAft>
-                <a:spcPts val="110"/>
-              </a:spcAft>
-              <a:buFont typeface="Wingdings" panose="05000000000000000000" pitchFamily="2" charset="2"/>
-              <a:buChar char="Ø"/>
-            </a:pPr>
-            <a:r>
-              <a:rPr lang="pt-BR" sz="2000" b="1" dirty="0"/>
-              <a:t>Noções gerais sobre Estatística. </a:t>
+              <a:t>Panorama RS à Luz dos Dados públicos disponíveis da SSP-RS</a:t>
             </a:r>
           </a:p>
         </p:txBody>
@@ -11209,10 +13503,214 @@
           </a:extLst>
         </p:spPr>
       </p:pic>
+      <p:sp>
+        <p:nvSpPr>
+          <p:cNvPr id="4" name="CaixaDeTexto 3">
+            <a:extLst>
+              <a:ext uri="{FF2B5EF4-FFF2-40B4-BE49-F238E27FC236}">
+                <a16:creationId xmlns:a16="http://schemas.microsoft.com/office/drawing/2014/main" id="{F9B44222-0FEB-DD8A-E65A-F10683C06A0F}"/>
+              </a:ext>
+            </a:extLst>
+          </p:cNvPr>
+          <p:cNvSpPr txBox="1"/>
+          <p:nvPr/>
+        </p:nvSpPr>
+        <p:spPr>
+          <a:xfrm>
+            <a:off x="940903" y="1573800"/>
+            <a:ext cx="10310191" cy="707886"/>
+          </a:xfrm>
+          <a:prstGeom prst="rect">
+            <a:avLst/>
+          </a:prstGeom>
+          <a:noFill/>
+        </p:spPr>
+        <p:txBody>
+          <a:bodyPr wrap="square" rtlCol="0">
+            <a:spAutoFit/>
+          </a:bodyPr>
+          <a:lstStyle/>
+          <a:p>
+            <a:pPr marL="285750" indent="-285750">
+              <a:spcAft>
+                <a:spcPts val="110"/>
+              </a:spcAft>
+              <a:buFont typeface="Wingdings" panose="05000000000000000000" pitchFamily="2" charset="2"/>
+              <a:buChar char="Ø"/>
+            </a:pPr>
+            <a:r>
+              <a:rPr lang="pt-BR" sz="2000" b="1" dirty="0"/>
+              <a:t>Problema Estatístico: Taxas em Localidades com baixa população produzem estimativas com alta variabilidade.</a:t>
+            </a:r>
+          </a:p>
+        </p:txBody>
+      </p:sp>
+      <p:pic>
+        <p:nvPicPr>
+          <p:cNvPr id="6" name="Imagem 5">
+            <a:extLst>
+              <a:ext uri="{FF2B5EF4-FFF2-40B4-BE49-F238E27FC236}">
+                <a16:creationId xmlns:a16="http://schemas.microsoft.com/office/drawing/2014/main" id="{E0B70768-61C8-F85A-E614-A9F14CEAD950}"/>
+              </a:ext>
+            </a:extLst>
+          </p:cNvPr>
+          <p:cNvPicPr>
+            <a:picLocks noChangeAspect="1"/>
+          </p:cNvPicPr>
+          <p:nvPr/>
+        </p:nvPicPr>
+        <p:blipFill>
+          <a:blip r:embed="rId5"/>
+          <a:stretch>
+            <a:fillRect/>
+          </a:stretch>
+        </p:blipFill>
+        <p:spPr>
+          <a:xfrm>
+            <a:off x="0" y="2795311"/>
+            <a:ext cx="5909943" cy="2653720"/>
+          </a:xfrm>
+          <a:prstGeom prst="rect">
+            <a:avLst/>
+          </a:prstGeom>
+        </p:spPr>
+      </p:pic>
+      <p:sp>
+        <p:nvSpPr>
+          <p:cNvPr id="12" name="Retângulo 11">
+            <a:extLst>
+              <a:ext uri="{FF2B5EF4-FFF2-40B4-BE49-F238E27FC236}">
+                <a16:creationId xmlns:a16="http://schemas.microsoft.com/office/drawing/2014/main" id="{0B40F988-AD4C-F7F7-CE31-F2CDDF82E91A}"/>
+              </a:ext>
+            </a:extLst>
+          </p:cNvPr>
+          <p:cNvSpPr/>
+          <p:nvPr/>
+        </p:nvSpPr>
+        <p:spPr>
+          <a:xfrm>
+            <a:off x="1963711" y="3021788"/>
+            <a:ext cx="329784" cy="246068"/>
+          </a:xfrm>
+          <a:prstGeom prst="rect">
+            <a:avLst/>
+          </a:prstGeom>
+          <a:noFill/>
+          <a:ln w="57150">
+            <a:solidFill>
+              <a:schemeClr val="tx1"/>
+            </a:solidFill>
+          </a:ln>
+        </p:spPr>
+        <p:style>
+          <a:lnRef idx="2">
+            <a:schemeClr val="accent1">
+              <a:shade val="15000"/>
+            </a:schemeClr>
+          </a:lnRef>
+          <a:fillRef idx="1">
+            <a:schemeClr val="accent1"/>
+          </a:fillRef>
+          <a:effectRef idx="0">
+            <a:schemeClr val="accent1"/>
+          </a:effectRef>
+          <a:fontRef idx="minor">
+            <a:schemeClr val="lt1"/>
+          </a:fontRef>
+        </p:style>
+        <p:txBody>
+          <a:bodyPr rtlCol="0" anchor="ctr"/>
+          <a:lstStyle/>
+          <a:p>
+            <a:pPr algn="ctr"/>
+            <a:endParaRPr lang="pt-BR"/>
+          </a:p>
+        </p:txBody>
+      </p:sp>
+      <p:sp>
+        <p:nvSpPr>
+          <p:cNvPr id="13" name="Seta: Curva para Baixo 12">
+            <a:extLst>
+              <a:ext uri="{FF2B5EF4-FFF2-40B4-BE49-F238E27FC236}">
+                <a16:creationId xmlns:a16="http://schemas.microsoft.com/office/drawing/2014/main" id="{D34651EC-928C-45A9-FB4A-89294682FE03}"/>
+              </a:ext>
+            </a:extLst>
+          </p:cNvPr>
+          <p:cNvSpPr/>
+          <p:nvPr/>
+        </p:nvSpPr>
+        <p:spPr>
+          <a:xfrm>
+            <a:off x="2405332" y="2221305"/>
+            <a:ext cx="6363914" cy="788387"/>
+          </a:xfrm>
+          <a:prstGeom prst="curvedDownArrow">
+            <a:avLst/>
+          </a:prstGeom>
+        </p:spPr>
+        <p:style>
+          <a:lnRef idx="2">
+            <a:schemeClr val="accent1">
+              <a:shade val="15000"/>
+            </a:schemeClr>
+          </a:lnRef>
+          <a:fillRef idx="1">
+            <a:schemeClr val="accent1"/>
+          </a:fillRef>
+          <a:effectRef idx="0">
+            <a:schemeClr val="accent1"/>
+          </a:effectRef>
+          <a:fontRef idx="minor">
+            <a:schemeClr val="lt1"/>
+          </a:fontRef>
+        </p:style>
+        <p:txBody>
+          <a:bodyPr rtlCol="0" anchor="ctr"/>
+          <a:lstStyle/>
+          <a:p>
+            <a:pPr algn="ctr"/>
+            <a:endParaRPr lang="pt-BR">
+              <a:solidFill>
+                <a:schemeClr val="tx1"/>
+              </a:solidFill>
+            </a:endParaRPr>
+          </a:p>
+        </p:txBody>
+      </p:sp>
+      <p:pic>
+        <p:nvPicPr>
+          <p:cNvPr id="15" name="Imagem 14">
+            <a:extLst>
+              <a:ext uri="{FF2B5EF4-FFF2-40B4-BE49-F238E27FC236}">
+                <a16:creationId xmlns:a16="http://schemas.microsoft.com/office/drawing/2014/main" id="{AD23F083-ACAE-F3BE-99C5-AC59D9D5284D}"/>
+              </a:ext>
+            </a:extLst>
+          </p:cNvPr>
+          <p:cNvPicPr>
+            <a:picLocks noChangeAspect="1"/>
+          </p:cNvPicPr>
+          <p:nvPr/>
+        </p:nvPicPr>
+        <p:blipFill>
+          <a:blip r:embed="rId6"/>
+          <a:stretch>
+            <a:fillRect/>
+          </a:stretch>
+        </p:blipFill>
+        <p:spPr>
+          <a:xfrm>
+            <a:off x="7313232" y="3078001"/>
+            <a:ext cx="2915057" cy="2743583"/>
+          </a:xfrm>
+          <a:prstGeom prst="rect">
+            <a:avLst/>
+          </a:prstGeom>
+        </p:spPr>
+      </p:pic>
     </p:spTree>
     <p:extLst>
       <p:ext uri="{BB962C8B-B14F-4D97-AF65-F5344CB8AC3E}">
-        <p14:creationId xmlns:p14="http://schemas.microsoft.com/office/powerpoint/2010/main" val="1536836101"/>
+        <p14:creationId xmlns:p14="http://schemas.microsoft.com/office/powerpoint/2010/main" val="2071889659"/>
       </p:ext>
     </p:extLst>
   </p:cSld>
@@ -11304,8 +13802,8 @@
         </p:nvSpPr>
         <p:spPr>
           <a:xfrm>
-            <a:off x="779259" y="294626"/>
-            <a:ext cx="10633479" cy="523220"/>
+            <a:off x="249836" y="200638"/>
+            <a:ext cx="11692327" cy="584775"/>
           </a:xfrm>
           <a:prstGeom prst="rect">
             <a:avLst/>
@@ -11319,76 +13817,14 @@
           <a:lstStyle/>
           <a:p>
             <a:r>
-              <a:rPr lang="pt-BR" sz="2800" b="1" dirty="0">
+              <a:rPr lang="pt-BR" sz="3200" b="1" dirty="0">
                 <a:solidFill>
                   <a:srgbClr val="002060"/>
                 </a:solidFill>
                 <a:latin typeface="Cambria" panose="02040503050406030204" pitchFamily="18" charset="0"/>
                 <a:ea typeface="Cambria" panose="02040503050406030204" pitchFamily="18" charset="0"/>
               </a:rPr>
-              <a:t>Reincidência Criminal: o Efeito Estigma de </a:t>
-            </a:r>
-            <a:r>
-              <a:rPr lang="pt-BR" sz="2800" b="1" dirty="0" err="1">
-                <a:solidFill>
-                  <a:srgbClr val="002060"/>
-                </a:solidFill>
-                <a:latin typeface="Cambria" panose="02040503050406030204" pitchFamily="18" charset="0"/>
-                <a:ea typeface="Cambria" panose="02040503050406030204" pitchFamily="18" charset="0"/>
-              </a:rPr>
-              <a:t>Ex-Presidiários</a:t>
-            </a:r>
-            <a:endParaRPr lang="pt-BR" sz="2800" b="1" dirty="0">
-              <a:solidFill>
-                <a:srgbClr val="002060"/>
-              </a:solidFill>
-              <a:latin typeface="Cambria" panose="02040503050406030204" pitchFamily="18" charset="0"/>
-              <a:ea typeface="Cambria" panose="02040503050406030204" pitchFamily="18" charset="0"/>
-            </a:endParaRPr>
-          </a:p>
-        </p:txBody>
-      </p:sp>
-      <p:sp>
-        <p:nvSpPr>
-          <p:cNvPr id="14" name="CaixaDeTexto 13">
-            <a:extLst>
-              <a:ext uri="{FF2B5EF4-FFF2-40B4-BE49-F238E27FC236}">
-                <a16:creationId xmlns:a16="http://schemas.microsoft.com/office/drawing/2014/main" id="{427DBFEB-81BF-4CC3-A411-FBF43D295C56}"/>
-              </a:ext>
-            </a:extLst>
-          </p:cNvPr>
-          <p:cNvSpPr txBox="1"/>
-          <p:nvPr/>
-        </p:nvSpPr>
-        <p:spPr>
-          <a:xfrm>
-            <a:off x="940904" y="1276323"/>
-            <a:ext cx="10310191" cy="506292"/>
-          </a:xfrm>
-          <a:prstGeom prst="rect">
-            <a:avLst/>
-          </a:prstGeom>
-          <a:noFill/>
-        </p:spPr>
-        <p:txBody>
-          <a:bodyPr wrap="square" rtlCol="0">
-            <a:spAutoFit/>
-          </a:bodyPr>
-          <a:lstStyle/>
-          <a:p>
-            <a:pPr marL="285750" indent="-285750">
-              <a:lnSpc>
-                <a:spcPct val="150000"/>
-              </a:lnSpc>
-              <a:spcAft>
-                <a:spcPts val="110"/>
-              </a:spcAft>
-              <a:buFont typeface="Wingdings" panose="05000000000000000000" pitchFamily="2" charset="2"/>
-              <a:buChar char="Ø"/>
-            </a:pPr>
-            <a:r>
-              <a:rPr lang="pt-BR" sz="2000" b="1" dirty="0"/>
-              <a:t>Noções gerais sobre Estatística. </a:t>
+              <a:t>Panorama RS à Luz dos Dados públicos disponíveis da SSP-RS</a:t>
             </a:r>
           </a:p>
         </p:txBody>
@@ -11487,10 +13923,204 @@
           </a:extLst>
         </p:spPr>
       </p:pic>
+      <p:pic>
+        <p:nvPicPr>
+          <p:cNvPr id="5" name="Imagem 4">
+            <a:extLst>
+              <a:ext uri="{FF2B5EF4-FFF2-40B4-BE49-F238E27FC236}">
+                <a16:creationId xmlns:a16="http://schemas.microsoft.com/office/drawing/2014/main" id="{4318DFD3-3634-EC8F-4CA2-B0EB8093C36F}"/>
+              </a:ext>
+            </a:extLst>
+          </p:cNvPr>
+          <p:cNvPicPr>
+            <a:picLocks noChangeAspect="1"/>
+          </p:cNvPicPr>
+          <p:nvPr/>
+        </p:nvPicPr>
+        <p:blipFill>
+          <a:blip r:embed="rId5"/>
+          <a:stretch>
+            <a:fillRect/>
+          </a:stretch>
+        </p:blipFill>
+        <p:spPr>
+          <a:xfrm>
+            <a:off x="834897" y="1724537"/>
+            <a:ext cx="9043291" cy="4162785"/>
+          </a:xfrm>
+          <a:prstGeom prst="rect">
+            <a:avLst/>
+          </a:prstGeom>
+        </p:spPr>
+      </p:pic>
+      <p:sp>
+        <p:nvSpPr>
+          <p:cNvPr id="9" name="Seta: para a Direita 8">
+            <a:extLst>
+              <a:ext uri="{FF2B5EF4-FFF2-40B4-BE49-F238E27FC236}">
+                <a16:creationId xmlns:a16="http://schemas.microsoft.com/office/drawing/2014/main" id="{4ADC85D4-4D6F-B41F-8D19-0C37EEA6532F}"/>
+              </a:ext>
+            </a:extLst>
+          </p:cNvPr>
+          <p:cNvSpPr/>
+          <p:nvPr/>
+        </p:nvSpPr>
+        <p:spPr>
+          <a:xfrm rot="9753462">
+            <a:off x="5878180" y="1914580"/>
+            <a:ext cx="435637" cy="359764"/>
+          </a:xfrm>
+          <a:prstGeom prst="rightArrow">
+            <a:avLst/>
+          </a:prstGeom>
+        </p:spPr>
+        <p:style>
+          <a:lnRef idx="2">
+            <a:schemeClr val="accent1">
+              <a:shade val="15000"/>
+            </a:schemeClr>
+          </a:lnRef>
+          <a:fillRef idx="1">
+            <a:schemeClr val="accent1"/>
+          </a:fillRef>
+          <a:effectRef idx="0">
+            <a:schemeClr val="accent1"/>
+          </a:effectRef>
+          <a:fontRef idx="minor">
+            <a:schemeClr val="lt1"/>
+          </a:fontRef>
+        </p:style>
+        <p:txBody>
+          <a:bodyPr rtlCol="0" anchor="ctr"/>
+          <a:lstStyle/>
+          <a:p>
+            <a:pPr algn="ctr"/>
+            <a:endParaRPr lang="pt-BR"/>
+          </a:p>
+        </p:txBody>
+      </p:sp>
+      <p:sp>
+        <p:nvSpPr>
+          <p:cNvPr id="11" name="CaixaDeTexto 10">
+            <a:extLst>
+              <a:ext uri="{FF2B5EF4-FFF2-40B4-BE49-F238E27FC236}">
+                <a16:creationId xmlns:a16="http://schemas.microsoft.com/office/drawing/2014/main" id="{2618659E-1058-1132-89D4-6B86F32FC853}"/>
+              </a:ext>
+            </a:extLst>
+          </p:cNvPr>
+          <p:cNvSpPr txBox="1"/>
+          <p:nvPr/>
+        </p:nvSpPr>
+        <p:spPr>
+          <a:xfrm>
+            <a:off x="6220773" y="1725130"/>
+            <a:ext cx="2265502" cy="369332"/>
+          </a:xfrm>
+          <a:prstGeom prst="rect">
+            <a:avLst/>
+          </a:prstGeom>
+          <a:noFill/>
+        </p:spPr>
+        <p:txBody>
+          <a:bodyPr wrap="square" rtlCol="0">
+            <a:spAutoFit/>
+          </a:bodyPr>
+          <a:lstStyle/>
+          <a:p>
+            <a:pPr algn="ctr"/>
+            <a:r>
+              <a:rPr lang="pt-BR" b="1" dirty="0"/>
+              <a:t>Porto Alegre: 48,84</a:t>
+            </a:r>
+          </a:p>
+        </p:txBody>
+      </p:sp>
+      <p:sp>
+        <p:nvSpPr>
+          <p:cNvPr id="12" name="Seta: para a Direita 11">
+            <a:extLst>
+              <a:ext uri="{FF2B5EF4-FFF2-40B4-BE49-F238E27FC236}">
+                <a16:creationId xmlns:a16="http://schemas.microsoft.com/office/drawing/2014/main" id="{0A11E838-7A28-D1BE-5FDC-461C62B8169E}"/>
+              </a:ext>
+            </a:extLst>
+          </p:cNvPr>
+          <p:cNvSpPr/>
+          <p:nvPr/>
+        </p:nvSpPr>
+        <p:spPr>
+          <a:xfrm rot="9753462">
+            <a:off x="8530178" y="4959034"/>
+            <a:ext cx="435637" cy="359764"/>
+          </a:xfrm>
+          <a:prstGeom prst="rightArrow">
+            <a:avLst/>
+          </a:prstGeom>
+        </p:spPr>
+        <p:style>
+          <a:lnRef idx="2">
+            <a:schemeClr val="accent1">
+              <a:shade val="15000"/>
+            </a:schemeClr>
+          </a:lnRef>
+          <a:fillRef idx="1">
+            <a:schemeClr val="accent1"/>
+          </a:fillRef>
+          <a:effectRef idx="0">
+            <a:schemeClr val="accent1"/>
+          </a:effectRef>
+          <a:fontRef idx="minor">
+            <a:schemeClr val="lt1"/>
+          </a:fontRef>
+        </p:style>
+        <p:txBody>
+          <a:bodyPr rtlCol="0" anchor="ctr"/>
+          <a:lstStyle/>
+          <a:p>
+            <a:pPr algn="ctr"/>
+            <a:endParaRPr lang="pt-BR"/>
+          </a:p>
+        </p:txBody>
+      </p:sp>
+      <p:sp>
+        <p:nvSpPr>
+          <p:cNvPr id="13" name="CaixaDeTexto 12">
+            <a:extLst>
+              <a:ext uri="{FF2B5EF4-FFF2-40B4-BE49-F238E27FC236}">
+                <a16:creationId xmlns:a16="http://schemas.microsoft.com/office/drawing/2014/main" id="{D1F1D044-C509-E859-2F17-4F37728104EB}"/>
+              </a:ext>
+            </a:extLst>
+          </p:cNvPr>
+          <p:cNvSpPr txBox="1"/>
+          <p:nvPr/>
+        </p:nvSpPr>
+        <p:spPr>
+          <a:xfrm>
+            <a:off x="8872771" y="4769584"/>
+            <a:ext cx="2265502" cy="369332"/>
+          </a:xfrm>
+          <a:prstGeom prst="rect">
+            <a:avLst/>
+          </a:prstGeom>
+          <a:noFill/>
+        </p:spPr>
+        <p:txBody>
+          <a:bodyPr wrap="square" rtlCol="0">
+            <a:spAutoFit/>
+          </a:bodyPr>
+          <a:lstStyle/>
+          <a:p>
+            <a:pPr algn="ctr"/>
+            <a:r>
+              <a:rPr lang="pt-BR" b="1" dirty="0"/>
+              <a:t>Pelotas: 2,68</a:t>
+            </a:r>
+          </a:p>
+        </p:txBody>
+      </p:sp>
     </p:spTree>
     <p:extLst>
       <p:ext uri="{BB962C8B-B14F-4D97-AF65-F5344CB8AC3E}">
-        <p14:creationId xmlns:p14="http://schemas.microsoft.com/office/powerpoint/2010/main" val="1070033144"/>
+        <p14:creationId xmlns:p14="http://schemas.microsoft.com/office/powerpoint/2010/main" val="1290076"/>
       </p:ext>
     </p:extLst>
   </p:cSld>
@@ -11509,6 +14139,384 @@
       </p:transition>
     </mc:Fallback>
   </mc:AlternateContent>
+  <p:timing>
+    <p:tnLst>
+      <p:par>
+        <p:cTn id="1" dur="indefinite" restart="never" nodeType="tmRoot">
+          <p:childTnLst>
+            <p:seq concurrent="1" nextAc="seek">
+              <p:cTn id="2" dur="indefinite" nodeType="mainSeq">
+                <p:childTnLst>
+                  <p:par>
+                    <p:cTn id="3" fill="hold">
+                      <p:stCondLst>
+                        <p:cond delay="indefinite"/>
+                      </p:stCondLst>
+                      <p:childTnLst>
+                        <p:par>
+                          <p:cTn id="4" fill="hold">
+                            <p:stCondLst>
+                              <p:cond delay="0"/>
+                            </p:stCondLst>
+                            <p:childTnLst>
+                              <p:par>
+                                <p:cTn id="5" presetID="42" presetClass="entr" presetSubtype="0" fill="hold" grpId="0" nodeType="clickEffect">
+                                  <p:stCondLst>
+                                    <p:cond delay="0"/>
+                                  </p:stCondLst>
+                                  <p:childTnLst>
+                                    <p:set>
+                                      <p:cBhvr>
+                                        <p:cTn id="6" dur="1" fill="hold">
+                                          <p:stCondLst>
+                                            <p:cond delay="0"/>
+                                          </p:stCondLst>
+                                        </p:cTn>
+                                        <p:tgtEl>
+                                          <p:spTgt spid="9"/>
+                                        </p:tgtEl>
+                                        <p:attrNameLst>
+                                          <p:attrName>style.visibility</p:attrName>
+                                        </p:attrNameLst>
+                                      </p:cBhvr>
+                                      <p:to>
+                                        <p:strVal val="visible"/>
+                                      </p:to>
+                                    </p:set>
+                                    <p:animEffect transition="in" filter="fade">
+                                      <p:cBhvr>
+                                        <p:cTn id="7" dur="1000"/>
+                                        <p:tgtEl>
+                                          <p:spTgt spid="9"/>
+                                        </p:tgtEl>
+                                      </p:cBhvr>
+                                    </p:animEffect>
+                                    <p:anim calcmode="lin" valueType="num">
+                                      <p:cBhvr>
+                                        <p:cTn id="8" dur="1000" fill="hold"/>
+                                        <p:tgtEl>
+                                          <p:spTgt spid="9"/>
+                                        </p:tgtEl>
+                                        <p:attrNameLst>
+                                          <p:attrName>ppt_x</p:attrName>
+                                        </p:attrNameLst>
+                                      </p:cBhvr>
+                                      <p:tavLst>
+                                        <p:tav tm="0">
+                                          <p:val>
+                                            <p:strVal val="#ppt_x"/>
+                                          </p:val>
+                                        </p:tav>
+                                        <p:tav tm="100000">
+                                          <p:val>
+                                            <p:strVal val="#ppt_x"/>
+                                          </p:val>
+                                        </p:tav>
+                                      </p:tavLst>
+                                    </p:anim>
+                                    <p:anim calcmode="lin" valueType="num">
+                                      <p:cBhvr>
+                                        <p:cTn id="9" dur="1000" fill="hold"/>
+                                        <p:tgtEl>
+                                          <p:spTgt spid="9"/>
+                                        </p:tgtEl>
+                                        <p:attrNameLst>
+                                          <p:attrName>ppt_y</p:attrName>
+                                        </p:attrNameLst>
+                                      </p:cBhvr>
+                                      <p:tavLst>
+                                        <p:tav tm="0">
+                                          <p:val>
+                                            <p:strVal val="#ppt_y+.1"/>
+                                          </p:val>
+                                        </p:tav>
+                                        <p:tav tm="100000">
+                                          <p:val>
+                                            <p:strVal val="#ppt_y"/>
+                                          </p:val>
+                                        </p:tav>
+                                      </p:tavLst>
+                                    </p:anim>
+                                  </p:childTnLst>
+                                </p:cTn>
+                              </p:par>
+                              <p:par>
+                                <p:cTn id="10" presetID="42" presetClass="entr" presetSubtype="0" fill="hold" grpId="0" nodeType="withEffect">
+                                  <p:stCondLst>
+                                    <p:cond delay="0"/>
+                                  </p:stCondLst>
+                                  <p:childTnLst>
+                                    <p:set>
+                                      <p:cBhvr>
+                                        <p:cTn id="11" dur="1" fill="hold">
+                                          <p:stCondLst>
+                                            <p:cond delay="0"/>
+                                          </p:stCondLst>
+                                        </p:cTn>
+                                        <p:tgtEl>
+                                          <p:spTgt spid="11"/>
+                                        </p:tgtEl>
+                                        <p:attrNameLst>
+                                          <p:attrName>style.visibility</p:attrName>
+                                        </p:attrNameLst>
+                                      </p:cBhvr>
+                                      <p:to>
+                                        <p:strVal val="visible"/>
+                                      </p:to>
+                                    </p:set>
+                                    <p:animEffect transition="in" filter="fade">
+                                      <p:cBhvr>
+                                        <p:cTn id="12" dur="1000"/>
+                                        <p:tgtEl>
+                                          <p:spTgt spid="11"/>
+                                        </p:tgtEl>
+                                      </p:cBhvr>
+                                    </p:animEffect>
+                                    <p:anim calcmode="lin" valueType="num">
+                                      <p:cBhvr>
+                                        <p:cTn id="13" dur="1000" fill="hold"/>
+                                        <p:tgtEl>
+                                          <p:spTgt spid="11"/>
+                                        </p:tgtEl>
+                                        <p:attrNameLst>
+                                          <p:attrName>ppt_x</p:attrName>
+                                        </p:attrNameLst>
+                                      </p:cBhvr>
+                                      <p:tavLst>
+                                        <p:tav tm="0">
+                                          <p:val>
+                                            <p:strVal val="#ppt_x"/>
+                                          </p:val>
+                                        </p:tav>
+                                        <p:tav tm="100000">
+                                          <p:val>
+                                            <p:strVal val="#ppt_x"/>
+                                          </p:val>
+                                        </p:tav>
+                                      </p:tavLst>
+                                    </p:anim>
+                                    <p:anim calcmode="lin" valueType="num">
+                                      <p:cBhvr>
+                                        <p:cTn id="14" dur="1000" fill="hold"/>
+                                        <p:tgtEl>
+                                          <p:spTgt spid="11"/>
+                                        </p:tgtEl>
+                                        <p:attrNameLst>
+                                          <p:attrName>ppt_y</p:attrName>
+                                        </p:attrNameLst>
+                                      </p:cBhvr>
+                                      <p:tavLst>
+                                        <p:tav tm="0">
+                                          <p:val>
+                                            <p:strVal val="#ppt_y+.1"/>
+                                          </p:val>
+                                        </p:tav>
+                                        <p:tav tm="100000">
+                                          <p:val>
+                                            <p:strVal val="#ppt_y"/>
+                                          </p:val>
+                                        </p:tav>
+                                      </p:tavLst>
+                                    </p:anim>
+                                  </p:childTnLst>
+                                </p:cTn>
+                              </p:par>
+                              <p:par>
+                                <p:cTn id="15" presetID="42" presetClass="entr" presetSubtype="0" fill="hold" grpId="0" nodeType="withEffect">
+                                  <p:stCondLst>
+                                    <p:cond delay="0"/>
+                                  </p:stCondLst>
+                                  <p:childTnLst>
+                                    <p:set>
+                                      <p:cBhvr>
+                                        <p:cTn id="16" dur="1" fill="hold">
+                                          <p:stCondLst>
+                                            <p:cond delay="0"/>
+                                          </p:stCondLst>
+                                        </p:cTn>
+                                        <p:tgtEl>
+                                          <p:spTgt spid="12"/>
+                                        </p:tgtEl>
+                                        <p:attrNameLst>
+                                          <p:attrName>style.visibility</p:attrName>
+                                        </p:attrNameLst>
+                                      </p:cBhvr>
+                                      <p:to>
+                                        <p:strVal val="visible"/>
+                                      </p:to>
+                                    </p:set>
+                                    <p:animEffect transition="in" filter="fade">
+                                      <p:cBhvr>
+                                        <p:cTn id="17" dur="1000"/>
+                                        <p:tgtEl>
+                                          <p:spTgt spid="12"/>
+                                        </p:tgtEl>
+                                      </p:cBhvr>
+                                    </p:animEffect>
+                                    <p:anim calcmode="lin" valueType="num">
+                                      <p:cBhvr>
+                                        <p:cTn id="18" dur="1000" fill="hold"/>
+                                        <p:tgtEl>
+                                          <p:spTgt spid="12"/>
+                                        </p:tgtEl>
+                                        <p:attrNameLst>
+                                          <p:attrName>ppt_x</p:attrName>
+                                        </p:attrNameLst>
+                                      </p:cBhvr>
+                                      <p:tavLst>
+                                        <p:tav tm="0">
+                                          <p:val>
+                                            <p:strVal val="#ppt_x"/>
+                                          </p:val>
+                                        </p:tav>
+                                        <p:tav tm="100000">
+                                          <p:val>
+                                            <p:strVal val="#ppt_x"/>
+                                          </p:val>
+                                        </p:tav>
+                                      </p:tavLst>
+                                    </p:anim>
+                                    <p:anim calcmode="lin" valueType="num">
+                                      <p:cBhvr>
+                                        <p:cTn id="19" dur="1000" fill="hold"/>
+                                        <p:tgtEl>
+                                          <p:spTgt spid="12"/>
+                                        </p:tgtEl>
+                                        <p:attrNameLst>
+                                          <p:attrName>ppt_y</p:attrName>
+                                        </p:attrNameLst>
+                                      </p:cBhvr>
+                                      <p:tavLst>
+                                        <p:tav tm="0">
+                                          <p:val>
+                                            <p:strVal val="#ppt_y+.1"/>
+                                          </p:val>
+                                        </p:tav>
+                                        <p:tav tm="100000">
+                                          <p:val>
+                                            <p:strVal val="#ppt_y"/>
+                                          </p:val>
+                                        </p:tav>
+                                      </p:tavLst>
+                                    </p:anim>
+                                  </p:childTnLst>
+                                </p:cTn>
+                              </p:par>
+                              <p:par>
+                                <p:cTn id="20" presetID="42" presetClass="entr" presetSubtype="0" fill="hold" grpId="0" nodeType="withEffect">
+                                  <p:stCondLst>
+                                    <p:cond delay="0"/>
+                                  </p:stCondLst>
+                                  <p:childTnLst>
+                                    <p:set>
+                                      <p:cBhvr>
+                                        <p:cTn id="21" dur="1" fill="hold">
+                                          <p:stCondLst>
+                                            <p:cond delay="0"/>
+                                          </p:stCondLst>
+                                        </p:cTn>
+                                        <p:tgtEl>
+                                          <p:spTgt spid="13"/>
+                                        </p:tgtEl>
+                                        <p:attrNameLst>
+                                          <p:attrName>style.visibility</p:attrName>
+                                        </p:attrNameLst>
+                                      </p:cBhvr>
+                                      <p:to>
+                                        <p:strVal val="visible"/>
+                                      </p:to>
+                                    </p:set>
+                                    <p:animEffect transition="in" filter="fade">
+                                      <p:cBhvr>
+                                        <p:cTn id="22" dur="1000"/>
+                                        <p:tgtEl>
+                                          <p:spTgt spid="13"/>
+                                        </p:tgtEl>
+                                      </p:cBhvr>
+                                    </p:animEffect>
+                                    <p:anim calcmode="lin" valueType="num">
+                                      <p:cBhvr>
+                                        <p:cTn id="23" dur="1000" fill="hold"/>
+                                        <p:tgtEl>
+                                          <p:spTgt spid="13"/>
+                                        </p:tgtEl>
+                                        <p:attrNameLst>
+                                          <p:attrName>ppt_x</p:attrName>
+                                        </p:attrNameLst>
+                                      </p:cBhvr>
+                                      <p:tavLst>
+                                        <p:tav tm="0">
+                                          <p:val>
+                                            <p:strVal val="#ppt_x"/>
+                                          </p:val>
+                                        </p:tav>
+                                        <p:tav tm="100000">
+                                          <p:val>
+                                            <p:strVal val="#ppt_x"/>
+                                          </p:val>
+                                        </p:tav>
+                                      </p:tavLst>
+                                    </p:anim>
+                                    <p:anim calcmode="lin" valueType="num">
+                                      <p:cBhvr>
+                                        <p:cTn id="24" dur="1000" fill="hold"/>
+                                        <p:tgtEl>
+                                          <p:spTgt spid="13"/>
+                                        </p:tgtEl>
+                                        <p:attrNameLst>
+                                          <p:attrName>ppt_y</p:attrName>
+                                        </p:attrNameLst>
+                                      </p:cBhvr>
+                                      <p:tavLst>
+                                        <p:tav tm="0">
+                                          <p:val>
+                                            <p:strVal val="#ppt_y+.1"/>
+                                          </p:val>
+                                        </p:tav>
+                                        <p:tav tm="100000">
+                                          <p:val>
+                                            <p:strVal val="#ppt_y"/>
+                                          </p:val>
+                                        </p:tav>
+                                      </p:tavLst>
+                                    </p:anim>
+                                  </p:childTnLst>
+                                </p:cTn>
+                              </p:par>
+                            </p:childTnLst>
+                          </p:cTn>
+                        </p:par>
+                      </p:childTnLst>
+                    </p:cTn>
+                  </p:par>
+                </p:childTnLst>
+              </p:cTn>
+              <p:prevCondLst>
+                <p:cond evt="onPrev" delay="0">
+                  <p:tgtEl>
+                    <p:sldTgt/>
+                  </p:tgtEl>
+                </p:cond>
+              </p:prevCondLst>
+              <p:nextCondLst>
+                <p:cond evt="onNext" delay="0">
+                  <p:tgtEl>
+                    <p:sldTgt/>
+                  </p:tgtEl>
+                </p:cond>
+              </p:nextCondLst>
+            </p:seq>
+          </p:childTnLst>
+        </p:cTn>
+      </p:par>
+    </p:tnLst>
+    <p:bldLst>
+      <p:bldP spid="9" grpId="0" animBg="1"/>
+      <p:bldP spid="11" grpId="0"/>
+      <p:bldP spid="12" grpId="0" animBg="1"/>
+      <p:bldP spid="13" grpId="0"/>
+    </p:bldLst>
+  </p:timing>
 </p:sld>
 </file>
 

</xml_diff>

<commit_message>
ajustes finais e add luz pra todos paper
</commit_message>
<xml_diff>
--- a/DIA 2 - APRESENTACAO - VERSAO AMPLIADA FINAL.pptx
+++ b/DIA 2 - APRESENTACAO - VERSAO AMPLIADA FINAL.pptx
@@ -3876,7 +3876,7 @@
           <a:p>
             <a:fld id="{9B3F8303-3E6A-4B9A-B114-90BC24763552}" type="datetimeFigureOut">
               <a:rPr lang="pt-BR" smtClean="0"/>
-              <a:t>06/10/2026</a:t>
+              <a:t>15/10/2026</a:t>
             </a:fld>
             <a:endParaRPr lang="pt-BR"/>
           </a:p>
@@ -5634,7 +5634,7 @@
           <a:p>
             <a:fld id="{6D1CE400-4242-4B09-9036-D13CC6199FDE}" type="datetimeFigureOut">
               <a:rPr lang="pt-BR" smtClean="0"/>
-              <a:t>06/10/2026</a:t>
+              <a:t>15/10/2026</a:t>
             </a:fld>
             <a:endParaRPr lang="pt-BR"/>
           </a:p>
@@ -5832,7 +5832,7 @@
           <a:p>
             <a:fld id="{6D1CE400-4242-4B09-9036-D13CC6199FDE}" type="datetimeFigureOut">
               <a:rPr lang="pt-BR" smtClean="0"/>
-              <a:t>06/10/2026</a:t>
+              <a:t>15/10/2026</a:t>
             </a:fld>
             <a:endParaRPr lang="pt-BR"/>
           </a:p>
@@ -6040,7 +6040,7 @@
           <a:p>
             <a:fld id="{6D1CE400-4242-4B09-9036-D13CC6199FDE}" type="datetimeFigureOut">
               <a:rPr lang="pt-BR" smtClean="0"/>
-              <a:t>06/10/2026</a:t>
+              <a:t>15/10/2026</a:t>
             </a:fld>
             <a:endParaRPr lang="pt-BR"/>
           </a:p>
@@ -6238,7 +6238,7 @@
           <a:p>
             <a:fld id="{6D1CE400-4242-4B09-9036-D13CC6199FDE}" type="datetimeFigureOut">
               <a:rPr lang="pt-BR" smtClean="0"/>
-              <a:t>06/10/2026</a:t>
+              <a:t>15/10/2026</a:t>
             </a:fld>
             <a:endParaRPr lang="pt-BR"/>
           </a:p>
@@ -6513,7 +6513,7 @@
           <a:p>
             <a:fld id="{6D1CE400-4242-4B09-9036-D13CC6199FDE}" type="datetimeFigureOut">
               <a:rPr lang="pt-BR" smtClean="0"/>
-              <a:t>06/10/2026</a:t>
+              <a:t>15/10/2026</a:t>
             </a:fld>
             <a:endParaRPr lang="pt-BR"/>
           </a:p>
@@ -6778,7 +6778,7 @@
           <a:p>
             <a:fld id="{6D1CE400-4242-4B09-9036-D13CC6199FDE}" type="datetimeFigureOut">
               <a:rPr lang="pt-BR" smtClean="0"/>
-              <a:t>06/10/2026</a:t>
+              <a:t>15/10/2026</a:t>
             </a:fld>
             <a:endParaRPr lang="pt-BR"/>
           </a:p>
@@ -7190,7 +7190,7 @@
           <a:p>
             <a:fld id="{6D1CE400-4242-4B09-9036-D13CC6199FDE}" type="datetimeFigureOut">
               <a:rPr lang="pt-BR" smtClean="0"/>
-              <a:t>06/10/2026</a:t>
+              <a:t>15/10/2026</a:t>
             </a:fld>
             <a:endParaRPr lang="pt-BR"/>
           </a:p>
@@ -7331,7 +7331,7 @@
           <a:p>
             <a:fld id="{6D1CE400-4242-4B09-9036-D13CC6199FDE}" type="datetimeFigureOut">
               <a:rPr lang="pt-BR" smtClean="0"/>
-              <a:t>06/10/2026</a:t>
+              <a:t>15/10/2026</a:t>
             </a:fld>
             <a:endParaRPr lang="pt-BR"/>
           </a:p>
@@ -7444,7 +7444,7 @@
           <a:p>
             <a:fld id="{6D1CE400-4242-4B09-9036-D13CC6199FDE}" type="datetimeFigureOut">
               <a:rPr lang="pt-BR" smtClean="0"/>
-              <a:t>06/10/2026</a:t>
+              <a:t>15/10/2026</a:t>
             </a:fld>
             <a:endParaRPr lang="pt-BR"/>
           </a:p>
@@ -7755,7 +7755,7 @@
           <a:p>
             <a:fld id="{6D1CE400-4242-4B09-9036-D13CC6199FDE}" type="datetimeFigureOut">
               <a:rPr lang="pt-BR" smtClean="0"/>
-              <a:t>06/10/2026</a:t>
+              <a:t>15/10/2026</a:t>
             </a:fld>
             <a:endParaRPr lang="pt-BR"/>
           </a:p>
@@ -8043,7 +8043,7 @@
           <a:p>
             <a:fld id="{6D1CE400-4242-4B09-9036-D13CC6199FDE}" type="datetimeFigureOut">
               <a:rPr lang="pt-BR" smtClean="0"/>
-              <a:t>06/10/2026</a:t>
+              <a:t>15/10/2026</a:t>
             </a:fld>
             <a:endParaRPr lang="pt-BR"/>
           </a:p>
@@ -8287,7 +8287,7 @@
           <a:p>
             <a:fld id="{6D1CE400-4242-4B09-9036-D13CC6199FDE}" type="datetimeFigureOut">
               <a:rPr lang="pt-BR" smtClean="0"/>
-              <a:t>06/10/2026</a:t>
+              <a:t>15/10/2026</a:t>
             </a:fld>
             <a:endParaRPr lang="pt-BR"/>
           </a:p>
@@ -9504,6 +9504,447 @@
       </p:transition>
     </mc:Fallback>
   </mc:AlternateContent>
+  <p:timing>
+    <p:tnLst>
+      <p:par>
+        <p:cTn id="1" dur="indefinite" restart="never" nodeType="tmRoot">
+          <p:childTnLst>
+            <p:seq concurrent="1" nextAc="seek">
+              <p:cTn id="2" dur="indefinite" nodeType="mainSeq">
+                <p:childTnLst>
+                  <p:par>
+                    <p:cTn id="3" fill="hold">
+                      <p:stCondLst>
+                        <p:cond delay="indefinite"/>
+                      </p:stCondLst>
+                      <p:childTnLst>
+                        <p:par>
+                          <p:cTn id="4" fill="hold">
+                            <p:stCondLst>
+                              <p:cond delay="0"/>
+                            </p:stCondLst>
+                            <p:childTnLst>
+                              <p:par>
+                                <p:cTn id="5" presetID="42" presetClass="entr" presetSubtype="0" fill="hold" nodeType="clickEffect">
+                                  <p:stCondLst>
+                                    <p:cond delay="0"/>
+                                  </p:stCondLst>
+                                  <p:childTnLst>
+                                    <p:set>
+                                      <p:cBhvr>
+                                        <p:cTn id="6" dur="1" fill="hold">
+                                          <p:stCondLst>
+                                            <p:cond delay="0"/>
+                                          </p:stCondLst>
+                                        </p:cTn>
+                                        <p:tgtEl>
+                                          <p:spTgt spid="5">
+                                            <p:txEl>
+                                              <p:pRg st="0" end="0"/>
+                                            </p:txEl>
+                                          </p:spTgt>
+                                        </p:tgtEl>
+                                        <p:attrNameLst>
+                                          <p:attrName>style.visibility</p:attrName>
+                                        </p:attrNameLst>
+                                      </p:cBhvr>
+                                      <p:to>
+                                        <p:strVal val="visible"/>
+                                      </p:to>
+                                    </p:set>
+                                    <p:animEffect transition="in" filter="fade">
+                                      <p:cBhvr>
+                                        <p:cTn id="7" dur="1000"/>
+                                        <p:tgtEl>
+                                          <p:spTgt spid="5">
+                                            <p:txEl>
+                                              <p:pRg st="0" end="0"/>
+                                            </p:txEl>
+                                          </p:spTgt>
+                                        </p:tgtEl>
+                                      </p:cBhvr>
+                                    </p:animEffect>
+                                    <p:anim calcmode="lin" valueType="num">
+                                      <p:cBhvr>
+                                        <p:cTn id="8" dur="1000" fill="hold"/>
+                                        <p:tgtEl>
+                                          <p:spTgt spid="5">
+                                            <p:txEl>
+                                              <p:pRg st="0" end="0"/>
+                                            </p:txEl>
+                                          </p:spTgt>
+                                        </p:tgtEl>
+                                        <p:attrNameLst>
+                                          <p:attrName>ppt_x</p:attrName>
+                                        </p:attrNameLst>
+                                      </p:cBhvr>
+                                      <p:tavLst>
+                                        <p:tav tm="0">
+                                          <p:val>
+                                            <p:strVal val="#ppt_x"/>
+                                          </p:val>
+                                        </p:tav>
+                                        <p:tav tm="100000">
+                                          <p:val>
+                                            <p:strVal val="#ppt_x"/>
+                                          </p:val>
+                                        </p:tav>
+                                      </p:tavLst>
+                                    </p:anim>
+                                    <p:anim calcmode="lin" valueType="num">
+                                      <p:cBhvr>
+                                        <p:cTn id="9" dur="1000" fill="hold"/>
+                                        <p:tgtEl>
+                                          <p:spTgt spid="5">
+                                            <p:txEl>
+                                              <p:pRg st="0" end="0"/>
+                                            </p:txEl>
+                                          </p:spTgt>
+                                        </p:tgtEl>
+                                        <p:attrNameLst>
+                                          <p:attrName>ppt_y</p:attrName>
+                                        </p:attrNameLst>
+                                      </p:cBhvr>
+                                      <p:tavLst>
+                                        <p:tav tm="0">
+                                          <p:val>
+                                            <p:strVal val="#ppt_y+.1"/>
+                                          </p:val>
+                                        </p:tav>
+                                        <p:tav tm="100000">
+                                          <p:val>
+                                            <p:strVal val="#ppt_y"/>
+                                          </p:val>
+                                        </p:tav>
+                                      </p:tavLst>
+                                    </p:anim>
+                                  </p:childTnLst>
+                                </p:cTn>
+                              </p:par>
+                            </p:childTnLst>
+                          </p:cTn>
+                        </p:par>
+                      </p:childTnLst>
+                    </p:cTn>
+                  </p:par>
+                  <p:par>
+                    <p:cTn id="10" fill="hold">
+                      <p:stCondLst>
+                        <p:cond delay="indefinite"/>
+                      </p:stCondLst>
+                      <p:childTnLst>
+                        <p:par>
+                          <p:cTn id="11" fill="hold">
+                            <p:stCondLst>
+                              <p:cond delay="0"/>
+                            </p:stCondLst>
+                            <p:childTnLst>
+                              <p:par>
+                                <p:cTn id="12" presetID="42" presetClass="entr" presetSubtype="0" fill="hold" nodeType="clickEffect">
+                                  <p:stCondLst>
+                                    <p:cond delay="0"/>
+                                  </p:stCondLst>
+                                  <p:childTnLst>
+                                    <p:set>
+                                      <p:cBhvr>
+                                        <p:cTn id="13" dur="1" fill="hold">
+                                          <p:stCondLst>
+                                            <p:cond delay="0"/>
+                                          </p:stCondLst>
+                                        </p:cTn>
+                                        <p:tgtEl>
+                                          <p:spTgt spid="5">
+                                            <p:txEl>
+                                              <p:pRg st="2" end="2"/>
+                                            </p:txEl>
+                                          </p:spTgt>
+                                        </p:tgtEl>
+                                        <p:attrNameLst>
+                                          <p:attrName>style.visibility</p:attrName>
+                                        </p:attrNameLst>
+                                      </p:cBhvr>
+                                      <p:to>
+                                        <p:strVal val="visible"/>
+                                      </p:to>
+                                    </p:set>
+                                    <p:animEffect transition="in" filter="fade">
+                                      <p:cBhvr>
+                                        <p:cTn id="14" dur="1000"/>
+                                        <p:tgtEl>
+                                          <p:spTgt spid="5">
+                                            <p:txEl>
+                                              <p:pRg st="2" end="2"/>
+                                            </p:txEl>
+                                          </p:spTgt>
+                                        </p:tgtEl>
+                                      </p:cBhvr>
+                                    </p:animEffect>
+                                    <p:anim calcmode="lin" valueType="num">
+                                      <p:cBhvr>
+                                        <p:cTn id="15" dur="1000" fill="hold"/>
+                                        <p:tgtEl>
+                                          <p:spTgt spid="5">
+                                            <p:txEl>
+                                              <p:pRg st="2" end="2"/>
+                                            </p:txEl>
+                                          </p:spTgt>
+                                        </p:tgtEl>
+                                        <p:attrNameLst>
+                                          <p:attrName>ppt_x</p:attrName>
+                                        </p:attrNameLst>
+                                      </p:cBhvr>
+                                      <p:tavLst>
+                                        <p:tav tm="0">
+                                          <p:val>
+                                            <p:strVal val="#ppt_x"/>
+                                          </p:val>
+                                        </p:tav>
+                                        <p:tav tm="100000">
+                                          <p:val>
+                                            <p:strVal val="#ppt_x"/>
+                                          </p:val>
+                                        </p:tav>
+                                      </p:tavLst>
+                                    </p:anim>
+                                    <p:anim calcmode="lin" valueType="num">
+                                      <p:cBhvr>
+                                        <p:cTn id="16" dur="1000" fill="hold"/>
+                                        <p:tgtEl>
+                                          <p:spTgt spid="5">
+                                            <p:txEl>
+                                              <p:pRg st="2" end="2"/>
+                                            </p:txEl>
+                                          </p:spTgt>
+                                        </p:tgtEl>
+                                        <p:attrNameLst>
+                                          <p:attrName>ppt_y</p:attrName>
+                                        </p:attrNameLst>
+                                      </p:cBhvr>
+                                      <p:tavLst>
+                                        <p:tav tm="0">
+                                          <p:val>
+                                            <p:strVal val="#ppt_y+.1"/>
+                                          </p:val>
+                                        </p:tav>
+                                        <p:tav tm="100000">
+                                          <p:val>
+                                            <p:strVal val="#ppt_y"/>
+                                          </p:val>
+                                        </p:tav>
+                                      </p:tavLst>
+                                    </p:anim>
+                                  </p:childTnLst>
+                                </p:cTn>
+                              </p:par>
+                              <p:par>
+                                <p:cTn id="17" presetID="42" presetClass="entr" presetSubtype="0" fill="hold" nodeType="withEffect">
+                                  <p:stCondLst>
+                                    <p:cond delay="0"/>
+                                  </p:stCondLst>
+                                  <p:childTnLst>
+                                    <p:set>
+                                      <p:cBhvr>
+                                        <p:cTn id="18" dur="1" fill="hold">
+                                          <p:stCondLst>
+                                            <p:cond delay="0"/>
+                                          </p:stCondLst>
+                                        </p:cTn>
+                                        <p:tgtEl>
+                                          <p:spTgt spid="5">
+                                            <p:txEl>
+                                              <p:pRg st="4" end="4"/>
+                                            </p:txEl>
+                                          </p:spTgt>
+                                        </p:tgtEl>
+                                        <p:attrNameLst>
+                                          <p:attrName>style.visibility</p:attrName>
+                                        </p:attrNameLst>
+                                      </p:cBhvr>
+                                      <p:to>
+                                        <p:strVal val="visible"/>
+                                      </p:to>
+                                    </p:set>
+                                    <p:animEffect transition="in" filter="fade">
+                                      <p:cBhvr>
+                                        <p:cTn id="19" dur="1000"/>
+                                        <p:tgtEl>
+                                          <p:spTgt spid="5">
+                                            <p:txEl>
+                                              <p:pRg st="4" end="4"/>
+                                            </p:txEl>
+                                          </p:spTgt>
+                                        </p:tgtEl>
+                                      </p:cBhvr>
+                                    </p:animEffect>
+                                    <p:anim calcmode="lin" valueType="num">
+                                      <p:cBhvr>
+                                        <p:cTn id="20" dur="1000" fill="hold"/>
+                                        <p:tgtEl>
+                                          <p:spTgt spid="5">
+                                            <p:txEl>
+                                              <p:pRg st="4" end="4"/>
+                                            </p:txEl>
+                                          </p:spTgt>
+                                        </p:tgtEl>
+                                        <p:attrNameLst>
+                                          <p:attrName>ppt_x</p:attrName>
+                                        </p:attrNameLst>
+                                      </p:cBhvr>
+                                      <p:tavLst>
+                                        <p:tav tm="0">
+                                          <p:val>
+                                            <p:strVal val="#ppt_x"/>
+                                          </p:val>
+                                        </p:tav>
+                                        <p:tav tm="100000">
+                                          <p:val>
+                                            <p:strVal val="#ppt_x"/>
+                                          </p:val>
+                                        </p:tav>
+                                      </p:tavLst>
+                                    </p:anim>
+                                    <p:anim calcmode="lin" valueType="num">
+                                      <p:cBhvr>
+                                        <p:cTn id="21" dur="1000" fill="hold"/>
+                                        <p:tgtEl>
+                                          <p:spTgt spid="5">
+                                            <p:txEl>
+                                              <p:pRg st="4" end="4"/>
+                                            </p:txEl>
+                                          </p:spTgt>
+                                        </p:tgtEl>
+                                        <p:attrNameLst>
+                                          <p:attrName>ppt_y</p:attrName>
+                                        </p:attrNameLst>
+                                      </p:cBhvr>
+                                      <p:tavLst>
+                                        <p:tav tm="0">
+                                          <p:val>
+                                            <p:strVal val="#ppt_y+.1"/>
+                                          </p:val>
+                                        </p:tav>
+                                        <p:tav tm="100000">
+                                          <p:val>
+                                            <p:strVal val="#ppt_y"/>
+                                          </p:val>
+                                        </p:tav>
+                                      </p:tavLst>
+                                    </p:anim>
+                                  </p:childTnLst>
+                                </p:cTn>
+                              </p:par>
+                              <p:par>
+                                <p:cTn id="22" presetID="42" presetClass="entr" presetSubtype="0" fill="hold" grpId="0" nodeType="withEffect">
+                                  <p:stCondLst>
+                                    <p:cond delay="0"/>
+                                  </p:stCondLst>
+                                  <p:childTnLst>
+                                    <p:set>
+                                      <p:cBhvr>
+                                        <p:cTn id="23" dur="1" fill="hold">
+                                          <p:stCondLst>
+                                            <p:cond delay="0"/>
+                                          </p:stCondLst>
+                                        </p:cTn>
+                                        <p:tgtEl>
+                                          <p:spTgt spid="9"/>
+                                        </p:tgtEl>
+                                        <p:attrNameLst>
+                                          <p:attrName>style.visibility</p:attrName>
+                                        </p:attrNameLst>
+                                      </p:cBhvr>
+                                      <p:to>
+                                        <p:strVal val="visible"/>
+                                      </p:to>
+                                    </p:set>
+                                    <p:animEffect transition="in" filter="fade">
+                                      <p:cBhvr>
+                                        <p:cTn id="24" dur="1000"/>
+                                        <p:tgtEl>
+                                          <p:spTgt spid="9"/>
+                                        </p:tgtEl>
+                                      </p:cBhvr>
+                                    </p:animEffect>
+                                    <p:anim calcmode="lin" valueType="num">
+                                      <p:cBhvr>
+                                        <p:cTn id="25" dur="1000" fill="hold"/>
+                                        <p:tgtEl>
+                                          <p:spTgt spid="9"/>
+                                        </p:tgtEl>
+                                        <p:attrNameLst>
+                                          <p:attrName>ppt_x</p:attrName>
+                                        </p:attrNameLst>
+                                      </p:cBhvr>
+                                      <p:tavLst>
+                                        <p:tav tm="0">
+                                          <p:val>
+                                            <p:strVal val="#ppt_x"/>
+                                          </p:val>
+                                        </p:tav>
+                                        <p:tav tm="100000">
+                                          <p:val>
+                                            <p:strVal val="#ppt_x"/>
+                                          </p:val>
+                                        </p:tav>
+                                      </p:tavLst>
+                                    </p:anim>
+                                    <p:anim calcmode="lin" valueType="num">
+                                      <p:cBhvr>
+                                        <p:cTn id="26" dur="1000" fill="hold"/>
+                                        <p:tgtEl>
+                                          <p:spTgt spid="9"/>
+                                        </p:tgtEl>
+                                        <p:attrNameLst>
+                                          <p:attrName>ppt_y</p:attrName>
+                                        </p:attrNameLst>
+                                      </p:cBhvr>
+                                      <p:tavLst>
+                                        <p:tav tm="0">
+                                          <p:val>
+                                            <p:strVal val="#ppt_y+.1"/>
+                                          </p:val>
+                                        </p:tav>
+                                        <p:tav tm="100000">
+                                          <p:val>
+                                            <p:strVal val="#ppt_y"/>
+                                          </p:val>
+                                        </p:tav>
+                                      </p:tavLst>
+                                    </p:anim>
+                                  </p:childTnLst>
+                                </p:cTn>
+                              </p:par>
+                            </p:childTnLst>
+                          </p:cTn>
+                        </p:par>
+                      </p:childTnLst>
+                    </p:cTn>
+                  </p:par>
+                </p:childTnLst>
+              </p:cTn>
+              <p:prevCondLst>
+                <p:cond evt="onPrev" delay="0">
+                  <p:tgtEl>
+                    <p:sldTgt/>
+                  </p:tgtEl>
+                </p:cond>
+              </p:prevCondLst>
+              <p:nextCondLst>
+                <p:cond evt="onNext" delay="0">
+                  <p:tgtEl>
+                    <p:sldTgt/>
+                  </p:tgtEl>
+                </p:cond>
+              </p:nextCondLst>
+            </p:seq>
+          </p:childTnLst>
+        </p:cTn>
+      </p:par>
+    </p:tnLst>
+    <p:bldLst>
+      <p:bldP spid="9" grpId="0"/>
+    </p:bldLst>
+  </p:timing>
 </p:sld>
 </file>
 
@@ -10482,7 +10923,7 @@
 </file>
 
 <file path=ppt/slides/slide14.xml><?xml version="1.0" encoding="utf-8"?>
-<p:sld xmlns:a="http://schemas.openxmlformats.org/drawingml/2006/main" xmlns:r="http://schemas.openxmlformats.org/officeDocument/2006/relationships" xmlns:p="http://schemas.openxmlformats.org/presentationml/2006/main">
+<p:sld xmlns:a="http://schemas.openxmlformats.org/drawingml/2006/main" xmlns:r="http://schemas.openxmlformats.org/officeDocument/2006/relationships" xmlns:p="http://schemas.openxmlformats.org/presentationml/2006/main" show="0">
   <p:cSld>
     <p:spTree>
       <p:nvGrpSpPr>
@@ -11600,13 +12041,13 @@
   <p:clrMapOvr>
     <a:masterClrMapping/>
   </p:clrMapOvr>
-  <mc:AlternateContent xmlns:mc="http://schemas.openxmlformats.org/markup-compatibility/2006" xmlns:p159="http://schemas.microsoft.com/office/powerpoint/2015/09/main">
-    <mc:Choice Requires="p159">
+  <mc:AlternateContent xmlns:mc="http://schemas.openxmlformats.org/markup-compatibility/2006">
+    <mc:Choice xmlns:p159="http://schemas.microsoft.com/office/powerpoint/2015/09/main" Requires="p159">
       <p:transition xmlns:p14="http://schemas.microsoft.com/office/powerpoint/2010/main" spd="slow" p14:dur="1250">
         <p159:morph option="byObject"/>
       </p:transition>
     </mc:Choice>
-    <mc:Fallback xmlns="">
+    <mc:Fallback>
       <p:transition spd="slow">
         <p:fade/>
       </p:transition>
@@ -14068,6 +14509,42 @@
             <a:r>
               <a:rPr lang="pt-BR" dirty="0"/>
               <a:t>Homicídio Doloso</a:t>
+            </a:r>
+          </a:p>
+        </p:txBody>
+      </p:sp>
+      <p:sp>
+        <p:nvSpPr>
+          <p:cNvPr id="4" name="CaixaDeTexto 3">
+            <a:extLst>
+              <a:ext uri="{FF2B5EF4-FFF2-40B4-BE49-F238E27FC236}">
+                <a16:creationId xmlns:a16="http://schemas.microsoft.com/office/drawing/2014/main" id="{A99C661F-9D50-CD91-A721-A8B43B2331B0}"/>
+              </a:ext>
+            </a:extLst>
+          </p:cNvPr>
+          <p:cNvSpPr txBox="1"/>
+          <p:nvPr/>
+        </p:nvSpPr>
+        <p:spPr>
+          <a:xfrm>
+            <a:off x="119922" y="1096835"/>
+            <a:ext cx="3480684" cy="769441"/>
+          </a:xfrm>
+          <a:prstGeom prst="rect">
+            <a:avLst/>
+          </a:prstGeom>
+          <a:noFill/>
+        </p:spPr>
+        <p:txBody>
+          <a:bodyPr wrap="square" rtlCol="0">
+            <a:spAutoFit/>
+          </a:bodyPr>
+          <a:lstStyle/>
+          <a:p>
+            <a:pPr algn="ctr"/>
+            <a:r>
+              <a:rPr lang="pt-BR" sz="2200" b="1" dirty="0"/>
+              <a:t>A queda recente da taxa de homicídios dolosos no RS</a:t>
             </a:r>
           </a:p>
         </p:txBody>

</xml_diff>